<commit_message>
chore(pitch): atualizar slide Fase 0 com auditoria de conhecimento (ADR-012)
Slide 10 redesenhado para refletir as 3 sub-etapas obrigatórias antes
do bootstrap de skills: inventário (0-A), validação com SMEs (0-B) e
definição de dono + processo de manutenção (0-C). Dois bloqueadores
explicitados na base: ADR-009 (distribuição) e ADR-012 (qualidade).

Co-Authored-By: Claude Sonnet 4.6 <noreply@anthropic.com>
</commit_message>
<xml_diff>
--- a/esteira-agentica-pitch.pptx
+++ b/esteira-agentica-pitch.pptx
@@ -604,7 +604,7 @@
           <a:p>
             <a:r>
               <a:rPr lang="en-US" dirty="0"/>
-              <a:t>Fase 0 é bloqueante: sem ela, agentes geram código que viola padrões e o review humano cancela o ganho. Bootstrap progressivo: repos com mais mudanças primeiro. Objetivo: nível mínimo em 60 dias. Decisão aberta: como distribuir skills para dezenas de repos.</a:t>
+              <a:t>ADR-012 (novo): a documentação de plataforma existente está desatualizada e incompleta. A Fase 0 começa com 3 sub-etapas: inventário (0-A), validação com SMEs (0-B), e definição de dono + processo de manutenção por domínio (0-C). Skills sem fonte de verdade validada não entram em produção. Dois bloqueadores: ADR-009 (distribuição) e ADR-012 (qualidade do conteúdo).</a:t>
             </a:r>
             <a:endParaRPr lang="en-US" dirty="0"/>
           </a:p>
@@ -2445,7 +2445,7 @@
                 <a:ea typeface="Calibri" pitchFamily="34" charset="-122"/>
                 <a:cs typeface="Calibri" pitchFamily="34" charset="-120"/>
               </a:rPr>
-              <a:t>Sem contexto de plataforma, o agente gera código que viola padrões — e o review humano cancela o ganho de velocidade</a:t>
+              <a:t>Antes de escrever qualquer skill, é preciso garantir que o conteúdo é correto</a:t>
             </a:r>
             <a:endParaRPr lang="en-US" sz="1300" dirty="0"/>
           </a:p>
@@ -2498,16 +2498,16 @@
         </p:nvSpPr>
         <p:spPr>
           <a:xfrm>
-            <a:off x="640080" y="1371600"/>
-            <a:ext cx="3657600" cy="2377440"/>
+            <a:off x="640080" y="1143000"/>
+            <a:ext cx="7863840" cy="685800"/>
           </a:xfrm>
           <a:prstGeom prst="roundRect">
             <a:avLst>
-              <a:gd name="adj" fmla="val 3077"/>
+              <a:gd name="adj" fmla="val 10667"/>
             </a:avLst>
           </a:prstGeom>
           <a:solidFill>
-            <a:srgbClr val="EFF6FF"/>
+            <a:srgbClr val="FEF2F2"/>
           </a:solidFill>
           <a:ln/>
           <a:effectLst>
@@ -2527,8 +2527,8 @@
         </p:nvSpPr>
         <p:spPr>
           <a:xfrm>
-            <a:off x="822960" y="1463040"/>
-            <a:ext cx="3291840" cy="320040"/>
+            <a:off x="822960" y="1170432"/>
+            <a:ext cx="822960" cy="256032"/>
           </a:xfrm>
           <a:prstGeom prst="rect">
             <a:avLst/>
@@ -2544,17 +2544,17 @@
               <a:buNone/>
             </a:pPr>
             <a:r>
-              <a:rPr lang="en-US" sz="1400" b="1" dirty="0">
-                <a:solidFill>
-                  <a:srgbClr val="2563EB"/>
-                </a:solidFill>
-                <a:latin typeface="Calibri" pitchFamily="34" charset="0"/>
-                <a:ea typeface="Calibri" pitchFamily="34" charset="-122"/>
-                <a:cs typeface="Calibri" pitchFamily="34" charset="-120"/>
-              </a:rPr>
-              <a:t>Fase 0 — Conhecimento de Plataforma</a:t>
-            </a:r>
-            <a:endParaRPr lang="en-US" sz="1400" dirty="0"/>
+              <a:rPr lang="en-US" sz="1000" b="1" dirty="0">
+                <a:solidFill>
+                  <a:srgbClr val="DC2626"/>
+                </a:solidFill>
+                <a:latin typeface="Calibri" pitchFamily="34" charset="0"/>
+                <a:ea typeface="Calibri" pitchFamily="34" charset="-122"/>
+                <a:cs typeface="Calibri" pitchFamily="34" charset="-120"/>
+              </a:rPr>
+              <a:t>ADR-012</a:t>
+            </a:r>
+            <a:endParaRPr lang="en-US" sz="1000" dirty="0"/>
           </a:p>
         </p:txBody>
       </p:sp>
@@ -2566,8 +2566,8 @@
         </p:nvSpPr>
         <p:spPr>
           <a:xfrm>
-            <a:off x="822960" y="1920240"/>
-            <a:ext cx="3291840" cy="1645920"/>
+            <a:off x="822960" y="1389888"/>
+            <a:ext cx="7315200" cy="256032"/>
           </a:xfrm>
           <a:prstGeom prst="rect">
             <a:avLst/>
@@ -2579,88 +2579,81 @@
           <a:bodyPr wrap="square" lIns="0" tIns="0" rIns="0" bIns="0" rtlCol="0" anchor="ctr"/>
           <a:lstStyle/>
           <a:p>
-            <a:pPr marL="342900" indent="-342900">
-              <a:spcAft>
-                <a:spcPts val="800"/>
-              </a:spcAft>
-              <a:buSzPct val="100000"/>
-              <a:buChar char="•"/>
-            </a:pPr>
-            <a:r>
-              <a:rPr lang="en-US" sz="1200" dirty="0">
-                <a:solidFill>
-                  <a:srgbClr val="0F172A"/>
-                </a:solidFill>
-                <a:latin typeface="Calibri" pitchFamily="34" charset="0"/>
-                <a:ea typeface="Calibri" pitchFamily="34" charset="-122"/>
-                <a:cs typeface="Calibri" pitchFamily="34" charset="-120"/>
-              </a:rPr>
-              <a:t>platform-standards: convenções, arquitetura de bundle, anti-patterns documentados</a:t>
-            </a:r>
-            <a:endParaRPr lang="en-US" sz="1200" dirty="0"/>
-          </a:p>
-          <a:p>
-            <a:pPr marL="342900" indent="-342900">
-              <a:spcAft>
-                <a:spcPts val="800"/>
-              </a:spcAft>
-              <a:buSzPct val="100000"/>
-              <a:buChar char="•"/>
-            </a:pPr>
-            <a:r>
-              <a:rPr lang="en-US" sz="1200" dirty="0">
-                <a:solidFill>
-                  <a:srgbClr val="0F172A"/>
-                </a:solidFill>
-                <a:latin typeface="Calibri" pitchFamily="34" charset="0"/>
-                <a:ea typeface="Calibri" pitchFamily="34" charset="-122"/>
-                <a:cs typeface="Calibri" pitchFamily="34" charset="-120"/>
-              </a:rPr>
-              <a:t>security: OWASP mobile, secure storage, cert pinning, padrões de autenticação</a:t>
-            </a:r>
-            <a:endParaRPr lang="en-US" sz="1200" dirty="0"/>
-          </a:p>
-          <a:p>
-            <a:pPr marL="342900" indent="-342900">
-              <a:spcAft>
-                <a:spcPts val="800"/>
-              </a:spcAft>
-              <a:buSzPct val="100000"/>
-              <a:buChar char="•"/>
-            </a:pPr>
-            <a:r>
-              <a:rPr lang="en-US" sz="1200" dirty="0">
-                <a:solidFill>
-                  <a:srgbClr val="0F172A"/>
-                </a:solidFill>
-                <a:latin typeface="Calibri" pitchFamily="34" charset="0"/>
-                <a:ea typeface="Calibri" pitchFamily="34" charset="-122"/>
-                <a:cs typeface="Calibri" pitchFamily="34" charset="-120"/>
-              </a:rPr>
-              <a:t>copilot-instructions.md em cada repo — o "README para o agente"</a:t>
-            </a:r>
-            <a:endParaRPr lang="en-US" sz="1200" dirty="0"/>
-          </a:p>
-        </p:txBody>
-      </p:sp>
-      <p:sp>
-        <p:nvSpPr>
-          <p:cNvPr id="8" name="Shape 6"/>
+            <a:pPr indent="0" marL="0">
+              <a:buNone/>
+            </a:pPr>
+            <a:r>
+              <a:rPr lang="en-US" sz="1000" b="1" dirty="0">
+                <a:solidFill>
+                  <a:srgbClr val="DC2626"/>
+                </a:solidFill>
+                <a:latin typeface="Calibri" pitchFamily="34" charset="0"/>
+                <a:ea typeface="Calibri" pitchFamily="34" charset="-122"/>
+                <a:cs typeface="Calibri" pitchFamily="34" charset="-120"/>
+              </a:rPr>
+              <a:t>Pré-etapa obrigatória: auditoria da documentação existente</a:t>
+            </a:r>
+            <a:endParaRPr lang="en-US" sz="1000" dirty="0"/>
+          </a:p>
+        </p:txBody>
+      </p:sp>
+      <p:sp>
+        <p:nvSpPr>
+          <p:cNvPr id="8" name="Text 6"/>
+          <p:cNvSpPr txBox="1"/>
+          <p:nvPr/>
+        </p:nvSpPr>
+        <p:spPr>
+          <a:xfrm>
+            <a:off x="822960" y="1170432"/>
+            <a:ext cx="7132320" cy="640080"/>
+          </a:xfrm>
+          <a:prstGeom prst="rect">
+            <a:avLst/>
+          </a:prstGeom>
+          <a:noFill/>
+          <a:ln/>
+        </p:spPr>
+        <p:txBody>
+          <a:bodyPr wrap="square" lIns="0" tIns="0" rIns="0" bIns="0" rtlCol="0" anchor="ctr"/>
+          <a:lstStyle/>
+          <a:p>
+            <a:pPr indent="0" marL="0">
+              <a:buNone/>
+            </a:pPr>
+            <a:r>
+              <a:rPr lang="en-US" sz="1100" dirty="0">
+                <a:solidFill>
+                  <a:srgbClr val="DC2626"/>
+                </a:solidFill>
+                <a:latin typeface="Calibri" pitchFamily="34" charset="0"/>
+                <a:ea typeface="Calibri" pitchFamily="34" charset="-122"/>
+                <a:cs typeface="Calibri" pitchFamily="34" charset="-120"/>
+              </a:rPr>
+              <a:t>Skills são tão confiáveis quanto o conteúdo que encodam — conteúdo incorreto distribuído de forma determinística é erro codificado com confiança.</a:t>
+            </a:r>
+            <a:endParaRPr lang="en-US" sz="1100" dirty="0"/>
+          </a:p>
+        </p:txBody>
+      </p:sp>
+      <p:sp>
+        <p:nvSpPr>
+          <p:cNvPr id="9" name="Shape 7"/>
           <p:cNvSpPr/>
           <p:nvPr/>
         </p:nvSpPr>
         <p:spPr>
           <a:xfrm>
-            <a:off x="4480560" y="1371600"/>
-            <a:ext cx="4023360" cy="2377440"/>
+            <a:off x="640080" y="2011680"/>
+            <a:ext cx="2514600" cy="1691640"/>
           </a:xfrm>
           <a:prstGeom prst="roundRect">
             <a:avLst>
-              <a:gd name="adj" fmla="val 3077"/>
+              <a:gd name="adj" fmla="val 4324"/>
             </a:avLst>
           </a:prstGeom>
           <a:solidFill>
-            <a:srgbClr val="F0FDF4"/>
+            <a:srgbClr val="FFF7ED"/>
           </a:solidFill>
           <a:ln/>
           <a:effectLst>
@@ -2674,53 +2667,14 @@
       </p:sp>
       <p:sp>
         <p:nvSpPr>
-          <p:cNvPr id="9" name="Text 7"/>
-          <p:cNvSpPr txBox="1"/>
-          <p:nvPr/>
-        </p:nvSpPr>
-        <p:spPr>
-          <a:xfrm>
-            <a:off x="4663440" y="1463040"/>
-            <a:ext cx="3657600" cy="320040"/>
-          </a:xfrm>
-          <a:prstGeom prst="rect">
-            <a:avLst/>
-          </a:prstGeom>
-          <a:noFill/>
-          <a:ln/>
-        </p:spPr>
-        <p:txBody>
-          <a:bodyPr wrap="square" lIns="0" tIns="0" rIns="0" bIns="0" rtlCol="0" anchor="ctr"/>
-          <a:lstStyle/>
-          <a:p>
-            <a:pPr indent="0" marL="0">
-              <a:buNone/>
-            </a:pPr>
-            <a:r>
-              <a:rPr lang="en-US" sz="1400" b="1" dirty="0">
-                <a:solidFill>
-                  <a:srgbClr val="059669"/>
-                </a:solidFill>
-                <a:latin typeface="Calibri" pitchFamily="34" charset="0"/>
-                <a:ea typeface="Calibri" pitchFamily="34" charset="-122"/>
-                <a:cs typeface="Calibri" pitchFamily="34" charset="-120"/>
-              </a:rPr>
-              <a:t>Fase 0b — Conhecimento BBDS (auto-gerado)</a:t>
-            </a:r>
-            <a:endParaRPr lang="en-US" sz="1400" dirty="0"/>
-          </a:p>
-        </p:txBody>
-      </p:sp>
-      <p:sp>
-        <p:nvSpPr>
           <p:cNvPr id="10" name="Text 8"/>
           <p:cNvSpPr txBox="1"/>
           <p:nvPr/>
         </p:nvSpPr>
         <p:spPr>
           <a:xfrm>
-            <a:off x="4663440" y="1920240"/>
-            <a:ext cx="3657600" cy="1645920"/>
+            <a:off x="777240" y="2084832"/>
+            <a:ext cx="2240280" cy="274320"/>
           </a:xfrm>
           <a:prstGeom prst="rect">
             <a:avLst/>
@@ -2732,15 +2686,50 @@
           <a:bodyPr wrap="square" lIns="0" tIns="0" rIns="0" bIns="0" rtlCol="0" anchor="ctr"/>
           <a:lstStyle/>
           <a:p>
-            <a:pPr marL="342900" indent="-342900">
-              <a:spcAft>
-                <a:spcPts val="800"/>
-              </a:spcAft>
-              <a:buSzPct val="100000"/>
-              <a:buChar char="•"/>
-            </a:pPr>
-            <a:r>
-              <a:rPr lang="en-US" sz="1200" dirty="0">
+            <a:pPr indent="0" marL="0">
+              <a:buNone/>
+            </a:pPr>
+            <a:r>
+              <a:rPr lang="en-US" sz="1300" b="1" dirty="0">
+                <a:solidFill>
+                  <a:srgbClr val="D97706"/>
+                </a:solidFill>
+                <a:latin typeface="Calibri" pitchFamily="34" charset="0"/>
+                <a:ea typeface="Calibri" pitchFamily="34" charset="-122"/>
+                <a:cs typeface="Calibri" pitchFamily="34" charset="-120"/>
+              </a:rPr>
+              <a:t>Fase 0-A</a:t>
+            </a:r>
+            <a:endParaRPr lang="en-US" sz="1300" dirty="0"/>
+          </a:p>
+        </p:txBody>
+      </p:sp>
+      <p:sp>
+        <p:nvSpPr>
+          <p:cNvPr id="11" name="Text 9"/>
+          <p:cNvSpPr txBox="1"/>
+          <p:nvPr/>
+        </p:nvSpPr>
+        <p:spPr>
+          <a:xfrm>
+            <a:off x="777240" y="2340864"/>
+            <a:ext cx="2240280" cy="228600"/>
+          </a:xfrm>
+          <a:prstGeom prst="rect">
+            <a:avLst/>
+          </a:prstGeom>
+          <a:noFill/>
+          <a:ln/>
+        </p:spPr>
+        <p:txBody>
+          <a:bodyPr wrap="square" lIns="0" tIns="0" rIns="0" bIns="0" rtlCol="0" anchor="ctr"/>
+          <a:lstStyle/>
+          <a:p>
+            <a:pPr indent="0" marL="0">
+              <a:buNone/>
+            </a:pPr>
+            <a:r>
+              <a:rPr lang="en-US" sz="1100" b="1" dirty="0">
                 <a:solidFill>
                   <a:srgbClr val="0F172A"/>
                 </a:solidFill>
@@ -2748,72 +2737,111 @@
                 <a:ea typeface="Calibri" pitchFamily="34" charset="-122"/>
                 <a:cs typeface="Calibri" pitchFamily="34" charset="-120"/>
               </a:rPr>
-              <a:t>bbds-api: props, tipos, deprecated + migration paths — gerada via ts-morph a cada bump</a:t>
-            </a:r>
-            <a:endParaRPr lang="en-US" sz="1200" dirty="0"/>
-          </a:p>
-          <a:p>
-            <a:pPr marL="342900" indent="-342900">
-              <a:spcAft>
-                <a:spcPts val="800"/>
-              </a:spcAft>
-              <a:buSzPct val="100000"/>
-              <a:buChar char="•"/>
-            </a:pPr>
-            <a:r>
-              <a:rPr lang="en-US" sz="1200" dirty="0">
-                <a:solidFill>
-                  <a:srgbClr val="0F172A"/>
-                </a:solidFill>
-                <a:latin typeface="Calibri" pitchFamily="34" charset="0"/>
-                <a:ea typeface="Calibri" pitchFamily="34" charset="-122"/>
-                <a:cs typeface="Calibri" pitchFamily="34" charset="-120"/>
-              </a:rPr>
-              <a:t>bbds-ux-guidelines: quando usar / não usar cada componente (curado pelo UX)</a:t>
-            </a:r>
-            <a:endParaRPr lang="en-US" sz="1200" dirty="0"/>
-          </a:p>
-          <a:p>
-            <a:pPr marL="342900" indent="-342900">
-              <a:spcAft>
-                <a:spcPts val="800"/>
-              </a:spcAft>
-              <a:buSzPct val="100000"/>
-              <a:buChar char="•"/>
-            </a:pPr>
-            <a:r>
-              <a:rPr lang="en-US" sz="1200" dirty="0">
-                <a:solidFill>
-                  <a:srgbClr val="0F172A"/>
-                </a:solidFill>
-                <a:latin typeface="Calibri" pitchFamily="34" charset="0"/>
-                <a:ea typeface="Calibri" pitchFamily="34" charset="-122"/>
-                <a:cs typeface="Calibri" pitchFamily="34" charset="-120"/>
-              </a:rPr>
-              <a:t>bbds-patterns: padrões de composição de telas (curado pela plataforma)</a:t>
-            </a:r>
-            <a:endParaRPr lang="en-US" sz="1200" dirty="0"/>
-          </a:p>
-        </p:txBody>
-      </p:sp>
-      <p:sp>
-        <p:nvSpPr>
-          <p:cNvPr id="11" name="Shape 9"/>
+              <a:t>Inventário</a:t>
+            </a:r>
+            <a:endParaRPr lang="en-US" sz="1100" dirty="0"/>
+          </a:p>
+        </p:txBody>
+      </p:sp>
+      <p:sp>
+        <p:nvSpPr>
+          <p:cNvPr id="12" name="Text 10"/>
+          <p:cNvSpPr txBox="1"/>
+          <p:nvPr/>
+        </p:nvSpPr>
+        <p:spPr>
+          <a:xfrm>
+            <a:off x="777240" y="2606040"/>
+            <a:ext cx="2240280" cy="1005840"/>
+          </a:xfrm>
+          <a:prstGeom prst="rect">
+            <a:avLst/>
+          </a:prstGeom>
+          <a:noFill/>
+          <a:ln/>
+        </p:spPr>
+        <p:txBody>
+          <a:bodyPr wrap="square" lIns="0" tIns="0" rIns="0" bIns="0" rtlCol="0" anchor="ctr"/>
+          <a:lstStyle/>
+          <a:p>
+            <a:pPr indent="0" marL="0">
+              <a:lnSpc>
+                <a:spcPct val="125000"/>
+              </a:lnSpc>
+              <a:buNone/>
+            </a:pPr>
+            <a:r>
+              <a:rPr lang="en-US" sz="1100" dirty="0">
+                <a:solidFill>
+                  <a:srgbClr val="475569"/>
+                </a:solidFill>
+                <a:latin typeface="Calibri" pitchFamily="34" charset="0"/>
+                <a:ea typeface="Calibri" pitchFamily="34" charset="-122"/>
+                <a:cs typeface="Calibri" pitchFamily="34" charset="-120"/>
+              </a:rPr>
+              <a:t>Onde o conhecimento existe hoje: repos, wikis, Figma, cabeças de seniores. Classificar por domínio e identificar contradições.</a:t>
+            </a:r>
+            <a:endParaRPr lang="en-US" sz="1100" dirty="0"/>
+          </a:p>
+        </p:txBody>
+      </p:sp>
+      <p:sp>
+        <p:nvSpPr>
+          <p:cNvPr id="13" name="Text 11"/>
+          <p:cNvSpPr txBox="1"/>
+          <p:nvPr/>
+        </p:nvSpPr>
+        <p:spPr>
+          <a:xfrm>
+            <a:off x="3182112" y="2679192"/>
+            <a:ext cx="201168" cy="320040"/>
+          </a:xfrm>
+          <a:prstGeom prst="rect">
+            <a:avLst/>
+          </a:prstGeom>
+          <a:noFill/>
+          <a:ln/>
+        </p:spPr>
+        <p:txBody>
+          <a:bodyPr wrap="square" lIns="0" tIns="0" rIns="0" bIns="0" rtlCol="0" anchor="ctr"/>
+          <a:lstStyle/>
+          <a:p>
+            <a:pPr algn="ctr" indent="0" marL="0">
+              <a:buNone/>
+            </a:pPr>
+            <a:r>
+              <a:rPr lang="en-US" sz="1300" dirty="0">
+                <a:solidFill>
+                  <a:srgbClr val="94A3B8"/>
+                </a:solidFill>
+                <a:latin typeface="Calibri" pitchFamily="34" charset="0"/>
+                <a:ea typeface="Calibri" pitchFamily="34" charset="-122"/>
+                <a:cs typeface="Calibri" pitchFamily="34" charset="-120"/>
+              </a:rPr>
+              <a:t>▶</a:t>
+            </a:r>
+            <a:endParaRPr lang="en-US" sz="1300" dirty="0"/>
+          </a:p>
+        </p:txBody>
+      </p:sp>
+      <p:sp>
+        <p:nvSpPr>
+          <p:cNvPr id="14" name="Shape 12"/>
           <p:cNvSpPr/>
           <p:nvPr/>
         </p:nvSpPr>
         <p:spPr>
           <a:xfrm>
-            <a:off x="640080" y="3977640"/>
-            <a:ext cx="7863840" cy="594360"/>
+            <a:off x="3429000" y="2011680"/>
+            <a:ext cx="2514600" cy="1691640"/>
           </a:xfrm>
           <a:prstGeom prst="roundRect">
             <a:avLst>
-              <a:gd name="adj" fmla="val 12308"/>
+              <a:gd name="adj" fmla="val 4324"/>
             </a:avLst>
           </a:prstGeom>
           <a:solidFill>
-            <a:srgbClr val="FFF7ED"/>
+            <a:srgbClr val="EFF6FF"/>
           </a:solidFill>
           <a:ln/>
           <a:effectLst>
@@ -2827,14 +2855,14 @@
       </p:sp>
       <p:sp>
         <p:nvSpPr>
-          <p:cNvPr id="12" name="Text 10"/>
+          <p:cNvPr id="15" name="Text 13"/>
           <p:cNvSpPr txBox="1"/>
           <p:nvPr/>
         </p:nvSpPr>
         <p:spPr>
           <a:xfrm>
-            <a:off x="822960" y="3977640"/>
-            <a:ext cx="7498080" cy="594360"/>
+            <a:off x="3566160" y="2084832"/>
+            <a:ext cx="2240280" cy="274320"/>
           </a:xfrm>
           <a:prstGeom prst="rect">
             <a:avLst/>
@@ -2850,7 +2878,344 @@
               <a:buNone/>
             </a:pPr>
             <a:r>
-              <a:rPr lang="en-US" sz="1200" dirty="0">
+              <a:rPr lang="en-US" sz="1300" b="1" dirty="0">
+                <a:solidFill>
+                  <a:srgbClr val="2563EB"/>
+                </a:solidFill>
+                <a:latin typeface="Calibri" pitchFamily="34" charset="0"/>
+                <a:ea typeface="Calibri" pitchFamily="34" charset="-122"/>
+                <a:cs typeface="Calibri" pitchFamily="34" charset="-120"/>
+              </a:rPr>
+              <a:t>Fase 0-B</a:t>
+            </a:r>
+            <a:endParaRPr lang="en-US" sz="1300" dirty="0"/>
+          </a:p>
+        </p:txBody>
+      </p:sp>
+      <p:sp>
+        <p:nvSpPr>
+          <p:cNvPr id="16" name="Text 14"/>
+          <p:cNvSpPr txBox="1"/>
+          <p:nvPr/>
+        </p:nvSpPr>
+        <p:spPr>
+          <a:xfrm>
+            <a:off x="3566160" y="2340864"/>
+            <a:ext cx="2240280" cy="228600"/>
+          </a:xfrm>
+          <a:prstGeom prst="rect">
+            <a:avLst/>
+          </a:prstGeom>
+          <a:noFill/>
+          <a:ln/>
+        </p:spPr>
+        <p:txBody>
+          <a:bodyPr wrap="square" lIns="0" tIns="0" rIns="0" bIns="0" rtlCol="0" anchor="ctr"/>
+          <a:lstStyle/>
+          <a:p>
+            <a:pPr indent="0" marL="0">
+              <a:buNone/>
+            </a:pPr>
+            <a:r>
+              <a:rPr lang="en-US" sz="1100" b="1" dirty="0">
+                <a:solidFill>
+                  <a:srgbClr val="0F172A"/>
+                </a:solidFill>
+                <a:latin typeface="Calibri" pitchFamily="34" charset="0"/>
+                <a:ea typeface="Calibri" pitchFamily="34" charset="-122"/>
+                <a:cs typeface="Calibri" pitchFamily="34" charset="-120"/>
+              </a:rPr>
+              <a:t>Validação SMEs</a:t>
+            </a:r>
+            <a:endParaRPr lang="en-US" sz="1100" dirty="0"/>
+          </a:p>
+        </p:txBody>
+      </p:sp>
+      <p:sp>
+        <p:nvSpPr>
+          <p:cNvPr id="17" name="Text 15"/>
+          <p:cNvSpPr txBox="1"/>
+          <p:nvPr/>
+        </p:nvSpPr>
+        <p:spPr>
+          <a:xfrm>
+            <a:off x="3566160" y="2606040"/>
+            <a:ext cx="2240280" cy="1005840"/>
+          </a:xfrm>
+          <a:prstGeom prst="rect">
+            <a:avLst/>
+          </a:prstGeom>
+          <a:noFill/>
+          <a:ln/>
+        </p:spPr>
+        <p:txBody>
+          <a:bodyPr wrap="square" lIns="0" tIns="0" rIns="0" bIns="0" rtlCol="0" anchor="ctr"/>
+          <a:lstStyle/>
+          <a:p>
+            <a:pPr indent="0" marL="0">
+              <a:lnSpc>
+                <a:spcPct val="125000"/>
+              </a:lnSpc>
+              <a:buNone/>
+            </a:pPr>
+            <a:r>
+              <a:rPr lang="en-US" sz="1100" dirty="0">
+                <a:solidFill>
+                  <a:srgbClr val="475569"/>
+                </a:solidFill>
+                <a:latin typeface="Calibri" pitchFamily="34" charset="0"/>
+                <a:ea typeface="Calibri" pitchFamily="34" charset="-122"/>
+                <a:cs typeface="Calibri" pitchFamily="34" charset="-120"/>
+              </a:rPr>
+              <a:t>Engenheiros sênior validam o que é canônico. Gaps são declarados explicitamente — ausência de conteúdo é informação válida.</a:t>
+            </a:r>
+            <a:endParaRPr lang="en-US" sz="1100" dirty="0"/>
+          </a:p>
+        </p:txBody>
+      </p:sp>
+      <p:sp>
+        <p:nvSpPr>
+          <p:cNvPr id="18" name="Text 16"/>
+          <p:cNvSpPr txBox="1"/>
+          <p:nvPr/>
+        </p:nvSpPr>
+        <p:spPr>
+          <a:xfrm>
+            <a:off x="5971032" y="2679192"/>
+            <a:ext cx="201168" cy="320040"/>
+          </a:xfrm>
+          <a:prstGeom prst="rect">
+            <a:avLst/>
+          </a:prstGeom>
+          <a:noFill/>
+          <a:ln/>
+        </p:spPr>
+        <p:txBody>
+          <a:bodyPr wrap="square" lIns="0" tIns="0" rIns="0" bIns="0" rtlCol="0" anchor="ctr"/>
+          <a:lstStyle/>
+          <a:p>
+            <a:pPr algn="ctr" indent="0" marL="0">
+              <a:buNone/>
+            </a:pPr>
+            <a:r>
+              <a:rPr lang="en-US" sz="1300" dirty="0">
+                <a:solidFill>
+                  <a:srgbClr val="94A3B8"/>
+                </a:solidFill>
+                <a:latin typeface="Calibri" pitchFamily="34" charset="0"/>
+                <a:ea typeface="Calibri" pitchFamily="34" charset="-122"/>
+                <a:cs typeface="Calibri" pitchFamily="34" charset="-120"/>
+              </a:rPr>
+              <a:t>▶</a:t>
+            </a:r>
+            <a:endParaRPr lang="en-US" sz="1300" dirty="0"/>
+          </a:p>
+        </p:txBody>
+      </p:sp>
+      <p:sp>
+        <p:nvSpPr>
+          <p:cNvPr id="19" name="Shape 17"/>
+          <p:cNvSpPr/>
+          <p:nvPr/>
+        </p:nvSpPr>
+        <p:spPr>
+          <a:xfrm>
+            <a:off x="6217920" y="2011680"/>
+            <a:ext cx="2514600" cy="1691640"/>
+          </a:xfrm>
+          <a:prstGeom prst="roundRect">
+            <a:avLst>
+              <a:gd name="adj" fmla="val 4324"/>
+            </a:avLst>
+          </a:prstGeom>
+          <a:solidFill>
+            <a:srgbClr val="F0FDF4"/>
+          </a:solidFill>
+          <a:ln/>
+          <a:effectLst>
+            <a:outerShdw sx="100000" sy="100000" kx="0" ky="0" algn="bl" rotWithShape="0" blurRad="50800" dist="25400" dir="2700000">
+              <a:srgbClr val="000000">
+                <a:alpha val="8000"/>
+              </a:srgbClr>
+            </a:outerShdw>
+          </a:effectLst>
+        </p:spPr>
+      </p:sp>
+      <p:sp>
+        <p:nvSpPr>
+          <p:cNvPr id="20" name="Text 18"/>
+          <p:cNvSpPr txBox="1"/>
+          <p:nvPr/>
+        </p:nvSpPr>
+        <p:spPr>
+          <a:xfrm>
+            <a:off x="6355080" y="2084832"/>
+            <a:ext cx="2240280" cy="274320"/>
+          </a:xfrm>
+          <a:prstGeom prst="rect">
+            <a:avLst/>
+          </a:prstGeom>
+          <a:noFill/>
+          <a:ln/>
+        </p:spPr>
+        <p:txBody>
+          <a:bodyPr wrap="square" lIns="0" tIns="0" rIns="0" bIns="0" rtlCol="0" anchor="ctr"/>
+          <a:lstStyle/>
+          <a:p>
+            <a:pPr indent="0" marL="0">
+              <a:buNone/>
+            </a:pPr>
+            <a:r>
+              <a:rPr lang="en-US" sz="1300" b="1" dirty="0">
+                <a:solidFill>
+                  <a:srgbClr val="059669"/>
+                </a:solidFill>
+                <a:latin typeface="Calibri" pitchFamily="34" charset="0"/>
+                <a:ea typeface="Calibri" pitchFamily="34" charset="-122"/>
+                <a:cs typeface="Calibri" pitchFamily="34" charset="-120"/>
+              </a:rPr>
+              <a:t>Fase 0-C</a:t>
+            </a:r>
+            <a:endParaRPr lang="en-US" sz="1300" dirty="0"/>
+          </a:p>
+        </p:txBody>
+      </p:sp>
+      <p:sp>
+        <p:nvSpPr>
+          <p:cNvPr id="21" name="Text 19"/>
+          <p:cNvSpPr txBox="1"/>
+          <p:nvPr/>
+        </p:nvSpPr>
+        <p:spPr>
+          <a:xfrm>
+            <a:off x="6355080" y="2340864"/>
+            <a:ext cx="2240280" cy="228600"/>
+          </a:xfrm>
+          <a:prstGeom prst="rect">
+            <a:avLst/>
+          </a:prstGeom>
+          <a:noFill/>
+          <a:ln/>
+        </p:spPr>
+        <p:txBody>
+          <a:bodyPr wrap="square" lIns="0" tIns="0" rIns="0" bIns="0" rtlCol="0" anchor="ctr"/>
+          <a:lstStyle/>
+          <a:p>
+            <a:pPr indent="0" marL="0">
+              <a:buNone/>
+            </a:pPr>
+            <a:r>
+              <a:rPr lang="en-US" sz="1100" b="1" dirty="0">
+                <a:solidFill>
+                  <a:srgbClr val="0F172A"/>
+                </a:solidFill>
+                <a:latin typeface="Calibri" pitchFamily="34" charset="0"/>
+                <a:ea typeface="Calibri" pitchFamily="34" charset="-122"/>
+                <a:cs typeface="Calibri" pitchFamily="34" charset="-120"/>
+              </a:rPr>
+              <a:t>Dono + Manutenção</a:t>
+            </a:r>
+            <a:endParaRPr lang="en-US" sz="1100" dirty="0"/>
+          </a:p>
+        </p:txBody>
+      </p:sp>
+      <p:sp>
+        <p:nvSpPr>
+          <p:cNvPr id="22" name="Text 20"/>
+          <p:cNvSpPr txBox="1"/>
+          <p:nvPr/>
+        </p:nvSpPr>
+        <p:spPr>
+          <a:xfrm>
+            <a:off x="6355080" y="2606040"/>
+            <a:ext cx="2240280" cy="1005840"/>
+          </a:xfrm>
+          <a:prstGeom prst="rect">
+            <a:avLst/>
+          </a:prstGeom>
+          <a:noFill/>
+          <a:ln/>
+        </p:spPr>
+        <p:txBody>
+          <a:bodyPr wrap="square" lIns="0" tIns="0" rIns="0" bIns="0" rtlCol="0" anchor="ctr"/>
+          <a:lstStyle/>
+          <a:p>
+            <a:pPr indent="0" marL="0">
+              <a:lnSpc>
+                <a:spcPct val="125000"/>
+              </a:lnSpc>
+              <a:buNone/>
+            </a:pPr>
+            <a:r>
+              <a:rPr lang="en-US" sz="1100" dirty="0">
+                <a:solidFill>
+                  <a:srgbClr val="475569"/>
+                </a:solidFill>
+                <a:latin typeface="Calibri" pitchFamily="34" charset="0"/>
+                <a:ea typeface="Calibri" pitchFamily="34" charset="-122"/>
+                <a:cs typeface="Calibri" pitchFamily="34" charset="-120"/>
+              </a:rPr>
+              <a:t>Cada skill tem um responsável e um processo de atualização definidos. Sem isso, a skill não é publicada.</a:t>
+            </a:r>
+            <a:endParaRPr lang="en-US" sz="1100" dirty="0"/>
+          </a:p>
+        </p:txBody>
+      </p:sp>
+      <p:sp>
+        <p:nvSpPr>
+          <p:cNvPr id="23" name="Shape 21"/>
+          <p:cNvSpPr/>
+          <p:nvPr/>
+        </p:nvSpPr>
+        <p:spPr>
+          <a:xfrm>
+            <a:off x="640080" y="3913632"/>
+            <a:ext cx="3794760" cy="658368"/>
+          </a:xfrm>
+          <a:prstGeom prst="roundRect">
+            <a:avLst>
+              <a:gd name="adj" fmla="val 11111"/>
+            </a:avLst>
+          </a:prstGeom>
+          <a:solidFill>
+            <a:srgbClr val="FFF7ED"/>
+          </a:solidFill>
+          <a:ln/>
+          <a:effectLst>
+            <a:outerShdw sx="100000" sy="100000" kx="0" ky="0" algn="bl" rotWithShape="0" blurRad="50800" dist="25400" dir="2700000">
+              <a:srgbClr val="000000">
+                <a:alpha val="8000"/>
+              </a:srgbClr>
+            </a:outerShdw>
+          </a:effectLst>
+        </p:spPr>
+      </p:sp>
+      <p:sp>
+        <p:nvSpPr>
+          <p:cNvPr id="24" name="Text 22"/>
+          <p:cNvSpPr txBox="1"/>
+          <p:nvPr/>
+        </p:nvSpPr>
+        <p:spPr>
+          <a:xfrm>
+            <a:off x="822960" y="3913632"/>
+            <a:ext cx="3474720" cy="658368"/>
+          </a:xfrm>
+          <a:prstGeom prst="rect">
+            <a:avLst/>
+          </a:prstGeom>
+          <a:noFill/>
+          <a:ln/>
+        </p:spPr>
+        <p:txBody>
+          <a:bodyPr wrap="square" lIns="0" tIns="0" rIns="0" bIns="0" rtlCol="0" anchor="ctr"/>
+          <a:lstStyle/>
+          <a:p>
+            <a:pPr indent="0" marL="0">
+              <a:buNone/>
+            </a:pPr>
+            <a:r>
+              <a:rPr lang="en-US" sz="1100" dirty="0">
                 <a:solidFill>
                   <a:srgbClr val="D97706"/>
                 </a:solidFill>
@@ -2858,9 +3223,77 @@
                 <a:ea typeface="Calibri" pitchFamily="34" charset="-122"/>
                 <a:cs typeface="Calibri" pitchFamily="34" charset="-120"/>
               </a:rPr>
-              <a:t>⚠  Decisão em aberto (ADR-009): o mecanismo de distribuição para muitos repos descentralizados — MCP central, pacote npm ou híbrido.</a:t>
-            </a:r>
-            <a:endParaRPr lang="en-US" sz="1200" dirty="0"/>
+              <a:t>⚠  ADR-009: mecanismo de distribuição (MCP central, npm ou híbrido) — bloqueia a produção da Fase 0.</a:t>
+            </a:r>
+            <a:endParaRPr lang="en-US" sz="1100" dirty="0"/>
+          </a:p>
+        </p:txBody>
+      </p:sp>
+      <p:sp>
+        <p:nvSpPr>
+          <p:cNvPr id="25" name="Shape 23"/>
+          <p:cNvSpPr/>
+          <p:nvPr/>
+        </p:nvSpPr>
+        <p:spPr>
+          <a:xfrm>
+            <a:off x="4617720" y="3913632"/>
+            <a:ext cx="3840480" cy="658368"/>
+          </a:xfrm>
+          <a:prstGeom prst="roundRect">
+            <a:avLst>
+              <a:gd name="adj" fmla="val 11111"/>
+            </a:avLst>
+          </a:prstGeom>
+          <a:solidFill>
+            <a:srgbClr val="FEF2F2"/>
+          </a:solidFill>
+          <a:ln/>
+          <a:effectLst>
+            <a:outerShdw sx="100000" sy="100000" kx="0" ky="0" algn="bl" rotWithShape="0" blurRad="50800" dist="25400" dir="2700000">
+              <a:srgbClr val="000000">
+                <a:alpha val="8000"/>
+              </a:srgbClr>
+            </a:outerShdw>
+          </a:effectLst>
+        </p:spPr>
+      </p:sp>
+      <p:sp>
+        <p:nvSpPr>
+          <p:cNvPr id="26" name="Text 24"/>
+          <p:cNvSpPr txBox="1"/>
+          <p:nvPr/>
+        </p:nvSpPr>
+        <p:spPr>
+          <a:xfrm>
+            <a:off x="4754880" y="3913632"/>
+            <a:ext cx="3520440" cy="658368"/>
+          </a:xfrm>
+          <a:prstGeom prst="rect">
+            <a:avLst/>
+          </a:prstGeom>
+          <a:noFill/>
+          <a:ln/>
+        </p:spPr>
+        <p:txBody>
+          <a:bodyPr wrap="square" lIns="0" tIns="0" rIns="0" bIns="0" rtlCol="0" anchor="ctr"/>
+          <a:lstStyle/>
+          <a:p>
+            <a:pPr indent="0" marL="0">
+              <a:buNone/>
+            </a:pPr>
+            <a:r>
+              <a:rPr lang="en-US" sz="1100" dirty="0">
+                <a:solidFill>
+                  <a:srgbClr val="DC2626"/>
+                </a:solidFill>
+                <a:latin typeface="Calibri" pitchFamily="34" charset="0"/>
+                <a:ea typeface="Calibri" pitchFamily="34" charset="-122"/>
+                <a:cs typeface="Calibri" pitchFamily="34" charset="-120"/>
+              </a:rPr>
+              <a:t>⚠  ADR-012: documentação atual desatualizada — auditoria precede o bootstrap de qualquer skill.</a:t>
+            </a:r>
+            <a:endParaRPr lang="en-US" sz="1100" dirty="0"/>
           </a:p>
         </p:txBody>
       </p:sp>

</xml_diff>

<commit_message>
fix(pitch): corrigir pptx corrompido e reaplicar atualizacoes slide 09
Repacking via .NET ZipFile.CreateFromDirectory corrompeu a estrutura do ZIP.
Restaurado o original do commit anterior e aplicado as mesmas alteracoes
de texto (Skills -> MCP / injecao) usando Python zipfile que preserva a
ordem e metadados originais das entradas.

Co-Authored-By: Claude Sonnet 4.6 <noreply@anthropic.com>
</commit_message>
<xml_diff>
--- a/esteira-agentica-pitch.pptx
+++ b/esteira-agentica-pitch.pptx
@@ -1,1754 +1,5 @@
 
-<file path=docProps\app.xml><?xml version="1.0" encoding="utf-8"?>
-<Properties xmlns="http://schemas.openxmlformats.org/officeDocument/2006/extended-properties" xmlns:vt="http://schemas.openxmlformats.org/officeDocument/2006/docPropsVTypes">
-  <TotalTime>0</TotalTime>
-  <Words>0</Words>
-  <Application>Microsoft Office PowerPoint</Application>
-  <PresentationFormat>On-screen Show (16:9)</PresentationFormat>
-  <Paragraphs>0</Paragraphs>
-  <Slides>15</Slides>
-  <Notes>15</Notes>
-  <HiddenSlides>0</HiddenSlides>
-  <MMClips>0</MMClips>
-  <ScaleCrop>false</ScaleCrop>
-  <HeadingPairs>
-    <vt:vector size="6" baseType="variant">
-      <vt:variant>
-        <vt:lpstr>Fonts Used</vt:lpstr>
-      </vt:variant>
-      <vt:variant>
-        <vt:i4>2</vt:i4>
-      </vt:variant>
-      <vt:variant>
-        <vt:lpstr>Theme</vt:lpstr>
-      </vt:variant>
-      <vt:variant>
-        <vt:i4>1</vt:i4>
-      </vt:variant>
-      <vt:variant>
-        <vt:lpstr>Slide Titles</vt:lpstr>
-      </vt:variant>
-      <vt:variant>
-        <vt:i4>15</vt:i4>
-      </vt:variant>
-    </vt:vector>
-  </HeadingPairs>
-  <TitlesOfParts>
-    <vt:vector size="18" baseType="lpstr">
-      <vt:lpstr>Arial</vt:lpstr>
-      <vt:lpstr>Calibri</vt:lpstr>
-      <vt:lpstr>Office Theme</vt:lpstr>
-      <vt:lpstr>Slide 1</vt:lpstr>
-      <vt:lpstr>Slide 2</vt:lpstr>
-      <vt:lpstr>Slide 3</vt:lpstr>
-      <vt:lpstr>Slide 4</vt:lpstr>
-      <vt:lpstr>Slide 5</vt:lpstr>
-      <vt:lpstr>Slide 6</vt:lpstr>
-      <vt:lpstr>Slide 7</vt:lpstr>
-      <vt:lpstr>Slide 8</vt:lpstr>
-      <vt:lpstr>Slide 9</vt:lpstr>
-      <vt:lpstr>Slide 10</vt:lpstr>
-      <vt:lpstr>Slide 11</vt:lpstr>
-      <vt:lpstr>Slide 12</vt:lpstr>
-      <vt:lpstr>Slide 13</vt:lpstr>
-      <vt:lpstr>Slide 14</vt:lpstr>
-      <vt:lpstr>Slide 15</vt:lpstr>
-    </vt:vector>
-  </TitlesOfParts>
-  <Company>PptxGenJS</Company>
-  <LinksUpToDate>false</LinksUpToDate>
-  <SharedDoc>false</SharedDoc>
-  <HyperlinksChanged>false</HyperlinksChanged>
-  <AppVersion>16.0000</AppVersion>
-</Properties>
-</file>
-
-<file path=docProps\core.xml><?xml version="1.0" encoding="utf-8"?>
-<cp:coreProperties xmlns:cp="http://schemas.openxmlformats.org/package/2006/metadata/core-properties" xmlns:dc="http://purl.org/dc/elements/1.1/" xmlns:dcterms="http://purl.org/dc/terms/" xmlns:dcmitype="http://purl.org/dc/dcmitype/" xmlns:xsi="http://www.w3.org/2001/XMLSchema-instance">
-  <dc:title>PptxGenJS Presentation</dc:title>
-  <dc:subject>PptxGenJS Presentation</dc:subject>
-  <dc:creator>PptxGenJS</dc:creator>
-  <cp:lastModifiedBy>PptxGenJS</cp:lastModifiedBy>
-  <cp:revision>1</cp:revision>
-  <dcterms:created xsi:type="dcterms:W3CDTF">2026-09-09T15:31:41Z</dcterms:created>
-  <dcterms:modified xsi:type="dcterms:W3CDTF">2026-09-09T15:31:41Z</dcterms:modified>
-</cp:coreProperties>
-</file>
-
-<file path=ppt\notesMasters\notesMaster1.xml><?xml version="1.0" encoding="utf-8"?>
-<p:notesMaster xmlns:a="http://schemas.openxmlformats.org/drawingml/2006/main" xmlns:r="http://schemas.openxmlformats.org/officeDocument/2006/relationships" xmlns:p="http://schemas.openxmlformats.org/presentationml/2006/main">
-  <p:cSld>
-    <p:bg>
-      <p:bgRef idx="1001">
-        <a:schemeClr val="bg1"/>
-      </p:bgRef>
-    </p:bg>
-    <p:spTree>
-      <p:nvGrpSpPr>
-        <p:cNvPr id="1" name=""/>
-        <p:cNvGrpSpPr/>
-        <p:nvPr/>
-      </p:nvGrpSpPr>
-      <p:grpSpPr>
-        <a:xfrm>
-          <a:off x="0" y="0"/>
-          <a:ext cx="0" cy="0"/>
-          <a:chOff x="0" y="0"/>
-          <a:chExt cx="0" cy="0"/>
-        </a:xfrm>
-      </p:grpSpPr>
-      <p:sp>
-        <p:nvSpPr>
-          <p:cNvPr id="2" name="Header Placeholder 1"/>
-          <p:cNvSpPr>
-            <a:spLocks noGrp="1"/>
-          </p:cNvSpPr>
-          <p:nvPr>
-            <p:ph type="hdr" sz="quarter"/>
-          </p:nvPr>
-        </p:nvSpPr>
-        <p:spPr>
-          <a:xfrm>
-            <a:off x="0" y="0"/>
-            <a:ext cx="2971800" cy="458788"/>
-          </a:xfrm>
-          <a:prstGeom prst="rect">
-            <a:avLst/>
-          </a:prstGeom>
-        </p:spPr>
-        <p:txBody>
-          <a:bodyPr vert="horz" lIns="91440" tIns="45720" rIns="91440" bIns="45720" rtlCol="0"/>
-          <a:lstStyle>
-            <a:lvl1pPr algn="l">
-              <a:defRPr sz="1200"/>
-            </a:lvl1pPr>
-          </a:lstStyle>
-          <a:p>
-            <a:endParaRPr lang="en-US"/>
-          </a:p>
-        </p:txBody>
-      </p:sp>
-      <p:sp>
-        <p:nvSpPr>
-          <p:cNvPr id="3" name="Date Placeholder 2"/>
-          <p:cNvSpPr>
-            <a:spLocks noGrp="1"/>
-          </p:cNvSpPr>
-          <p:nvPr>
-            <p:ph type="dt" idx="1"/>
-          </p:nvPr>
-        </p:nvSpPr>
-        <p:spPr>
-          <a:xfrm>
-            <a:off x="3884613" y="0"/>
-            <a:ext cx="2971800" cy="458788"/>
-          </a:xfrm>
-          <a:prstGeom prst="rect">
-            <a:avLst/>
-          </a:prstGeom>
-        </p:spPr>
-        <p:txBody>
-          <a:bodyPr vert="horz" lIns="91440" tIns="45720" rIns="91440" bIns="45720" rtlCol="0"/>
-          <a:lstStyle>
-            <a:lvl1pPr algn="r">
-              <a:defRPr sz="1200"/>
-            </a:lvl1pPr>
-          </a:lstStyle>
-          <a:p>
-            <a:fld id="{5282F153-3F37-0F45-9E97-73ACFA13230C}" type="datetimeFigureOut">
-              <a:rPr lang="en-US"/>
-              <a:t>7/23/19</a:t>
-            </a:fld>
-            <a:endParaRPr lang="en-US"/>
-          </a:p>
-        </p:txBody>
-      </p:sp>
-      <p:sp>
-        <p:nvSpPr>
-          <p:cNvPr id="4" name="Slide Image Placeholder 3"/>
-          <p:cNvSpPr>
-            <a:spLocks noGrp="1" noRot="1" noChangeAspect="1"/>
-          </p:cNvSpPr>
-          <p:nvPr>
-            <p:ph type="sldImg" idx="2"/>
-          </p:nvPr>
-        </p:nvSpPr>
-        <p:spPr>
-          <a:xfrm>
-            <a:off x="685800" y="1143000"/>
-            <a:ext cx="5486400" cy="3086100"/>
-          </a:xfrm>
-          <a:prstGeom prst="rect">
-            <a:avLst/>
-          </a:prstGeom>
-          <a:noFill/>
-          <a:ln w="12700">
-            <a:solidFill>
-              <a:prstClr val="black"/>
-            </a:solidFill>
-          </a:ln>
-        </p:spPr>
-        <p:txBody>
-          <a:bodyPr vert="horz" lIns="91440" tIns="45720" rIns="91440" bIns="45720" rtlCol="0" anchor="ctr"/>
-          <a:lstStyle/>
-          <a:p>
-            <a:endParaRPr lang="en-US"/>
-          </a:p>
-        </p:txBody>
-      </p:sp>
-      <p:sp>
-        <p:nvSpPr>
-          <p:cNvPr id="5" name="Notes Placeholder 4"/>
-          <p:cNvSpPr>
-            <a:spLocks noGrp="1"/>
-          </p:cNvSpPr>
-          <p:nvPr>
-            <p:ph type="body" sz="quarter" idx="3"/>
-          </p:nvPr>
-        </p:nvSpPr>
-        <p:spPr>
-          <a:xfrm>
-            <a:off x="685800" y="4400550"/>
-            <a:ext cx="5486400" cy="3600450"/>
-          </a:xfrm>
-          <a:prstGeom prst="rect">
-            <a:avLst/>
-          </a:prstGeom>
-        </p:spPr>
-        <p:txBody>
-          <a:bodyPr vert="horz" lIns="91440" tIns="45720" rIns="91440" bIns="45720" rtlCol="0"/>
-          <a:lstStyle/>
-          <a:p>
-            <a:pPr lvl="0"/>
-            <a:r>
-              <a:rPr lang="en-US"/>
-              <a:t>Click to edit Master text styles</a:t>
-            </a:r>
-          </a:p>
-          <a:p>
-            <a:pPr lvl="1"/>
-            <a:r>
-              <a:rPr lang="en-US"/>
-              <a:t>Second level</a:t>
-            </a:r>
-          </a:p>
-          <a:p>
-            <a:pPr lvl="2"/>
-            <a:r>
-              <a:rPr lang="en-US"/>
-              <a:t>Third level</a:t>
-            </a:r>
-          </a:p>
-          <a:p>
-            <a:pPr lvl="3"/>
-            <a:r>
-              <a:rPr lang="en-US"/>
-              <a:t>Fourth level</a:t>
-            </a:r>
-          </a:p>
-          <a:p>
-            <a:pPr lvl="4"/>
-            <a:r>
-              <a:rPr lang="en-US"/>
-              <a:t>Fifth level</a:t>
-            </a:r>
-          </a:p>
-        </p:txBody>
-      </p:sp>
-      <p:sp>
-        <p:nvSpPr>
-          <p:cNvPr id="6" name="Footer Placeholder 5"/>
-          <p:cNvSpPr>
-            <a:spLocks noGrp="1"/>
-          </p:cNvSpPr>
-          <p:nvPr>
-            <p:ph type="ftr" sz="quarter" idx="4"/>
-          </p:nvPr>
-        </p:nvSpPr>
-        <p:spPr>
-          <a:xfrm>
-            <a:off x="0" y="8685213"/>
-            <a:ext cx="2971800" cy="458787"/>
-          </a:xfrm>
-          <a:prstGeom prst="rect">
-            <a:avLst/>
-          </a:prstGeom>
-        </p:spPr>
-        <p:txBody>
-          <a:bodyPr vert="horz" lIns="91440" tIns="45720" rIns="91440" bIns="45720" rtlCol="0" anchor="b"/>
-          <a:lstStyle>
-            <a:lvl1pPr algn="l">
-              <a:defRPr sz="1200"/>
-            </a:lvl1pPr>
-          </a:lstStyle>
-          <a:p>
-            <a:endParaRPr lang="en-US"/>
-          </a:p>
-        </p:txBody>
-      </p:sp>
-      <p:sp>
-        <p:nvSpPr>
-          <p:cNvPr id="7" name="Slide Number Placeholder 6"/>
-          <p:cNvSpPr>
-            <a:spLocks noGrp="1"/>
-          </p:cNvSpPr>
-          <p:nvPr>
-            <p:ph type="sldNum" sz="quarter" idx="5"/>
-          </p:nvPr>
-        </p:nvSpPr>
-        <p:spPr>
-          <a:xfrm>
-            <a:off x="3884613" y="8685213"/>
-            <a:ext cx="2971800" cy="458787"/>
-          </a:xfrm>
-          <a:prstGeom prst="rect">
-            <a:avLst/>
-          </a:prstGeom>
-        </p:spPr>
-        <p:txBody>
-          <a:bodyPr vert="horz" lIns="91440" tIns="45720" rIns="91440" bIns="45720" rtlCol="0" anchor="b"/>
-          <a:lstStyle>
-            <a:lvl1pPr algn="r">
-              <a:defRPr sz="1200"/>
-            </a:lvl1pPr>
-          </a:lstStyle>
-          <a:p>
-            <a:fld id="{CE5E9CC1-C706-0F49-92D6-E571CC5EEA8F}" type="slidenum">
-              <a:rPr lang="en-US"/>
-              <a:t>‹#›</a:t>
-            </a:fld>
-            <a:endParaRPr lang="en-US"/>
-          </a:p>
-        </p:txBody>
-      </p:sp>
-    </p:spTree>
-    <p:extLst>
-      <p:ext uri="{BB962C8B-B14F-4D97-AF65-F5344CB8AC3E}">
-        <p14:creationId xmlns:p14="http://schemas.microsoft.com/office/powerpoint/2010/main" val="1024086991"/>
-      </p:ext>
-    </p:extLst>
-  </p:cSld>
-  <p:clrMap bg1="lt1" tx1="dk1" bg2="lt2" tx2="dk2" accent1="accent1" accent2="accent2" accent3="accent3" accent4="accent4" accent5="accent5" accent6="accent6" hlink="hlink" folHlink="folHlink"/>
-  <p:notesStyle>
-    <a:lvl1pPr marL="0" algn="l" defTabSz="914400" rtl="0" eaLnBrk="1" latinLnBrk="0" hangingPunct="1">
-      <a:defRPr sz="1200" kern="1200">
-        <a:solidFill>
-          <a:schemeClr val="tx1"/>
-        </a:solidFill>
-        <a:latin typeface="+mn-lt"/>
-        <a:ea typeface="+mn-ea"/>
-        <a:cs typeface="+mn-cs"/>
-      </a:defRPr>
-    </a:lvl1pPr>
-    <a:lvl2pPr marL="457200" algn="l" defTabSz="914400" rtl="0" eaLnBrk="1" latinLnBrk="0" hangingPunct="1">
-      <a:defRPr sz="1200" kern="1200">
-        <a:solidFill>
-          <a:schemeClr val="tx1"/>
-        </a:solidFill>
-        <a:latin typeface="+mn-lt"/>
-        <a:ea typeface="+mn-ea"/>
-        <a:cs typeface="+mn-cs"/>
-      </a:defRPr>
-    </a:lvl2pPr>
-    <a:lvl3pPr marL="914400" algn="l" defTabSz="914400" rtl="0" eaLnBrk="1" latinLnBrk="0" hangingPunct="1">
-      <a:defRPr sz="1200" kern="1200">
-        <a:solidFill>
-          <a:schemeClr val="tx1"/>
-        </a:solidFill>
-        <a:latin typeface="+mn-lt"/>
-        <a:ea typeface="+mn-ea"/>
-        <a:cs typeface="+mn-cs"/>
-      </a:defRPr>
-    </a:lvl3pPr>
-    <a:lvl4pPr marL="1371600" algn="l" defTabSz="914400" rtl="0" eaLnBrk="1" latinLnBrk="0" hangingPunct="1">
-      <a:defRPr sz="1200" kern="1200">
-        <a:solidFill>
-          <a:schemeClr val="tx1"/>
-        </a:solidFill>
-        <a:latin typeface="+mn-lt"/>
-        <a:ea typeface="+mn-ea"/>
-        <a:cs typeface="+mn-cs"/>
-      </a:defRPr>
-    </a:lvl4pPr>
-    <a:lvl5pPr marL="1828800" algn="l" defTabSz="914400" rtl="0" eaLnBrk="1" latinLnBrk="0" hangingPunct="1">
-      <a:defRPr sz="1200" kern="1200">
-        <a:solidFill>
-          <a:schemeClr val="tx1"/>
-        </a:solidFill>
-        <a:latin typeface="+mn-lt"/>
-        <a:ea typeface="+mn-ea"/>
-        <a:cs typeface="+mn-cs"/>
-      </a:defRPr>
-    </a:lvl5pPr>
-    <a:lvl6pPr marL="2286000" algn="l" defTabSz="914400" rtl="0" eaLnBrk="1" latinLnBrk="0" hangingPunct="1">
-      <a:defRPr sz="1200" kern="1200">
-        <a:solidFill>
-          <a:schemeClr val="tx1"/>
-        </a:solidFill>
-        <a:latin typeface="+mn-lt"/>
-        <a:ea typeface="+mn-ea"/>
-        <a:cs typeface="+mn-cs"/>
-      </a:defRPr>
-    </a:lvl6pPr>
-    <a:lvl7pPr marL="2743200" algn="l" defTabSz="914400" rtl="0" eaLnBrk="1" latinLnBrk="0" hangingPunct="1">
-      <a:defRPr sz="1200" kern="1200">
-        <a:solidFill>
-          <a:schemeClr val="tx1"/>
-        </a:solidFill>
-        <a:latin typeface="+mn-lt"/>
-        <a:ea typeface="+mn-ea"/>
-        <a:cs typeface="+mn-cs"/>
-      </a:defRPr>
-    </a:lvl7pPr>
-    <a:lvl8pPr marL="3200400" algn="l" defTabSz="914400" rtl="0" eaLnBrk="1" latinLnBrk="0" hangingPunct="1">
-      <a:defRPr sz="1200" kern="1200">
-        <a:solidFill>
-          <a:schemeClr val="tx1"/>
-        </a:solidFill>
-        <a:latin typeface="+mn-lt"/>
-        <a:ea typeface="+mn-ea"/>
-        <a:cs typeface="+mn-cs"/>
-      </a:defRPr>
-    </a:lvl8pPr>
-    <a:lvl9pPr marL="3657600" algn="l" defTabSz="914400" rtl="0" eaLnBrk="1" latinLnBrk="0" hangingPunct="1">
-      <a:defRPr sz="1200" kern="1200">
-        <a:solidFill>
-          <a:schemeClr val="tx1"/>
-        </a:solidFill>
-        <a:latin typeface="+mn-lt"/>
-        <a:ea typeface="+mn-ea"/>
-        <a:cs typeface="+mn-cs"/>
-      </a:defRPr>
-    </a:lvl9pPr>
-  </p:notesStyle>
-</p:notesMaster>
-</file>
-
-<file path=ppt\notesSlides\notesSlide1.xml><?xml version="1.0" encoding="utf-8"?>
-<p:notes xmlns:a="http://schemas.openxmlformats.org/drawingml/2006/main" xmlns:r="http://schemas.openxmlformats.org/officeDocument/2006/relationships" xmlns:p="http://schemas.openxmlformats.org/presentationml/2006/main">
-  <p:cSld>
-    <p:spTree>
-      <p:nvGrpSpPr>
-        <p:cNvPr id="1" name=""/>
-        <p:cNvGrpSpPr/>
-        <p:nvPr/>
-      </p:nvGrpSpPr>
-      <p:grpSpPr>
-        <a:xfrm>
-          <a:off x="0" y="0"/>
-          <a:ext cx="0" cy="0"/>
-          <a:chOff x="0" y="0"/>
-          <a:chExt cx="0" cy="0"/>
-        </a:xfrm>
-      </p:grpSpPr>
-      <p:sp>
-        <p:nvSpPr>
-          <p:cNvPr id="2" name="Slide Image Placeholder 1"/>
-          <p:cNvSpPr>
-            <a:spLocks noGrp="1" noRot="1" noChangeAspect="1"/>
-          </p:cNvSpPr>
-          <p:nvPr>
-            <p:ph type="sldImg"/>
-          </p:nvPr>
-        </p:nvSpPr>
-        <p:spPr/>
-      </p:sp>
-      <p:sp>
-        <p:nvSpPr>
-          <p:cNvPr id="3" name="Notes Placeholder 2"/>
-          <p:cNvSpPr>
-            <a:spLocks noGrp="1"/>
-          </p:cNvSpPr>
-          <p:nvPr>
-            <p:ph type="body" idx="1"/>
-          </p:nvPr>
-        </p:nvSpPr>
-        <p:spPr/>
-        <p:txBody>
-          <a:bodyPr/>
-          <a:lstStyle/>
-          <a:p>
-            <a:r>
-              <a:rPr lang="en-US" dirty="0"/>
-              <a:t>Abertura: apresentar a proposta de esteira AI-native SDLC para plataforma mobile. Baseada no playbook da Anthropic, adaptada para GitHub Copilot Enterprise + React Native multi-bundle.</a:t>
-            </a:r>
-            <a:endParaRPr lang="en-US" dirty="0"/>
-          </a:p>
-        </p:txBody>
-      </p:sp>
-      <p:sp>
-        <p:nvSpPr>
-          <p:cNvPr id="4" name="Slide Number Placeholder 3"/>
-          <p:cNvSpPr>
-            <a:spLocks noGrp="1"/>
-          </p:cNvSpPr>
-          <p:nvPr>
-            <p:ph type="sldNum" sz="quarter" idx="10"/>
-          </p:nvPr>
-        </p:nvSpPr>
-        <p:spPr/>
-        <p:txBody>
-          <a:bodyPr/>
-          <a:lstStyle/>
-          <a:p>
-            <a:fld id="{F7021451-1387-4CA6-816F-3879F97B5CBC}" type="slidenum">
-              <a:rPr lang="en-US"/>
-              <a:t>1</a:t>
-            </a:fld>
-            <a:endParaRPr lang="en-US"/>
-          </a:p>
-        </p:txBody>
-      </p:sp>
-    </p:spTree>
-    <p:extLst>
-      <p:ext uri="{BB962C8B-B14F-4D97-AF65-F5344CB8AC3E}">
-        <p14:creationId xmlns:p14="http://schemas.microsoft.com/office/powerpoint/2010/main" val="1024086991"/>
-      </p:ext>
-    </p:extLst>
-  </p:cSld>
-  <p:clrMapOvr>
-    <a:masterClrMapping/>
-  </p:clrMapOvr>
-</p:notes>
-</file>
-
-<file path=ppt\notesSlides\notesSlide10.xml><?xml version="1.0" encoding="utf-8"?>
-<p:notes xmlns:a="http://schemas.openxmlformats.org/drawingml/2006/main" xmlns:r="http://schemas.openxmlformats.org/officeDocument/2006/relationships" xmlns:p="http://schemas.openxmlformats.org/presentationml/2006/main">
-  <p:cSld>
-    <p:spTree>
-      <p:nvGrpSpPr>
-        <p:cNvPr id="1" name=""/>
-        <p:cNvGrpSpPr/>
-        <p:nvPr/>
-      </p:nvGrpSpPr>
-      <p:grpSpPr>
-        <a:xfrm>
-          <a:off x="0" y="0"/>
-          <a:ext cx="0" cy="0"/>
-          <a:chOff x="0" y="0"/>
-          <a:chExt cx="0" cy="0"/>
-        </a:xfrm>
-      </p:grpSpPr>
-      <p:sp>
-        <p:nvSpPr>
-          <p:cNvPr id="2" name="Slide Image Placeholder 1"/>
-          <p:cNvSpPr>
-            <a:spLocks noGrp="1" noRot="1" noChangeAspect="1"/>
-          </p:cNvSpPr>
-          <p:nvPr>
-            <p:ph type="sldImg"/>
-          </p:nvPr>
-        </p:nvSpPr>
-        <p:spPr/>
-      </p:sp>
-      <p:sp>
-        <p:nvSpPr>
-          <p:cNvPr id="3" name="Notes Placeholder 2"/>
-          <p:cNvSpPr>
-            <a:spLocks noGrp="1"/>
-          </p:cNvSpPr>
-          <p:nvPr>
-            <p:ph type="body" idx="1"/>
-          </p:nvPr>
-        </p:nvSpPr>
-        <p:spPr/>
-        <p:txBody>
-          <a:bodyPr/>
-          <a:lstStyle/>
-          <a:p>
-            <a:r>
-              <a:rPr lang="en-US" dirty="0"/>
-              <a:t>ADR-012 (novo): a documentação de plataforma existente está desatualizada e incompleta. A Fase 0 começa com 3 sub-etapas: inventário (0-A), validação com SMEs (0-B), e definição de dono + processo de manutenção por domínio (0-C). Skills sem fonte de verdade validada não entram em produção. Dois bloqueadores: ADR-009 (distribuição) e ADR-012 (qualidade do conteúdo).</a:t>
-            </a:r>
-            <a:endParaRPr lang="en-US" dirty="0"/>
-          </a:p>
-        </p:txBody>
-      </p:sp>
-      <p:sp>
-        <p:nvSpPr>
-          <p:cNvPr id="4" name="Slide Number Placeholder 3"/>
-          <p:cNvSpPr>
-            <a:spLocks noGrp="1"/>
-          </p:cNvSpPr>
-          <p:nvPr>
-            <p:ph type="sldNum" sz="quarter" idx="10"/>
-          </p:nvPr>
-        </p:nvSpPr>
-        <p:spPr/>
-        <p:txBody>
-          <a:bodyPr/>
-          <a:lstStyle/>
-          <a:p>
-            <a:fld id="{F7021451-1387-4CA6-816F-3879F97B5CBC}" type="slidenum">
-              <a:rPr lang="en-US"/>
-              <a:t>10</a:t>
-            </a:fld>
-            <a:endParaRPr lang="en-US"/>
-          </a:p>
-        </p:txBody>
-      </p:sp>
-    </p:spTree>
-    <p:extLst>
-      <p:ext uri="{BB962C8B-B14F-4D97-AF65-F5344CB8AC3E}">
-        <p14:creationId xmlns:p14="http://schemas.microsoft.com/office/powerpoint/2010/main" val="1024086991"/>
-      </p:ext>
-    </p:extLst>
-  </p:cSld>
-  <p:clrMapOvr>
-    <a:masterClrMapping/>
-  </p:clrMapOvr>
-</p:notes>
-</file>
-
-<file path=ppt\notesSlides\notesSlide11.xml><?xml version="1.0" encoding="utf-8"?>
-<p:notes xmlns:a="http://schemas.openxmlformats.org/drawingml/2006/main" xmlns:r="http://schemas.openxmlformats.org/officeDocument/2006/relationships" xmlns:p="http://schemas.openxmlformats.org/presentationml/2006/main">
-  <p:cSld>
-    <p:spTree>
-      <p:nvGrpSpPr>
-        <p:cNvPr id="1" name=""/>
-        <p:cNvGrpSpPr/>
-        <p:nvPr/>
-      </p:nvGrpSpPr>
-      <p:grpSpPr>
-        <a:xfrm>
-          <a:off x="0" y="0"/>
-          <a:ext cx="0" cy="0"/>
-          <a:chOff x="0" y="0"/>
-          <a:chExt cx="0" cy="0"/>
-        </a:xfrm>
-      </p:grpSpPr>
-      <p:sp>
-        <p:nvSpPr>
-          <p:cNvPr id="2" name="Slide Image Placeholder 1"/>
-          <p:cNvSpPr>
-            <a:spLocks noGrp="1" noRot="1" noChangeAspect="1"/>
-          </p:cNvSpPr>
-          <p:nvPr>
-            <p:ph type="sldImg"/>
-          </p:nvPr>
-        </p:nvSpPr>
-        <p:spPr/>
-      </p:sp>
-      <p:sp>
-        <p:nvSpPr>
-          <p:cNvPr id="3" name="Notes Placeholder 2"/>
-          <p:cNvSpPr>
-            <a:spLocks noGrp="1"/>
-          </p:cNvSpPr>
-          <p:nvPr>
-            <p:ph type="body" idx="1"/>
-          </p:nvPr>
-        </p:nvSpPr>
-        <p:spPr/>
-        <p:txBody>
-          <a:bodyPr/>
-          <a:lstStyle/>
-          <a:p>
-            <a:r>
-              <a:rPr lang="en-US" dirty="0"/>
-              <a:t>Princípio central: nenhum agente aprova seu próprio output. Gates calibrados ao risco. A esteira começa conservadora e pode relaxar gates à medida que evals comprovam confiabilidade.</a:t>
-            </a:r>
-            <a:endParaRPr lang="en-US" dirty="0"/>
-          </a:p>
-        </p:txBody>
-      </p:sp>
-      <p:sp>
-        <p:nvSpPr>
-          <p:cNvPr id="4" name="Slide Number Placeholder 3"/>
-          <p:cNvSpPr>
-            <a:spLocks noGrp="1"/>
-          </p:cNvSpPr>
-          <p:nvPr>
-            <p:ph type="sldNum" sz="quarter" idx="10"/>
-          </p:nvPr>
-        </p:nvSpPr>
-        <p:spPr/>
-        <p:txBody>
-          <a:bodyPr/>
-          <a:lstStyle/>
-          <a:p>
-            <a:fld id="{F7021451-1387-4CA6-816F-3879F97B5CBC}" type="slidenum">
-              <a:rPr lang="en-US"/>
-              <a:t>11</a:t>
-            </a:fld>
-            <a:endParaRPr lang="en-US"/>
-          </a:p>
-        </p:txBody>
-      </p:sp>
-    </p:spTree>
-    <p:extLst>
-      <p:ext uri="{BB962C8B-B14F-4D97-AF65-F5344CB8AC3E}">
-        <p14:creationId xmlns:p14="http://schemas.microsoft.com/office/powerpoint/2010/main" val="1024086991"/>
-      </p:ext>
-    </p:extLst>
-  </p:cSld>
-  <p:clrMapOvr>
-    <a:masterClrMapping/>
-  </p:clrMapOvr>
-</p:notes>
-</file>
-
-<file path=ppt\notesSlides\notesSlide12.xml><?xml version="1.0" encoding="utf-8"?>
-<p:notes xmlns:a="http://schemas.openxmlformats.org/drawingml/2006/main" xmlns:r="http://schemas.openxmlformats.org/officeDocument/2006/relationships" xmlns:p="http://schemas.openxmlformats.org/presentationml/2006/main">
-  <p:cSld>
-    <p:spTree>
-      <p:nvGrpSpPr>
-        <p:cNvPr id="1" name=""/>
-        <p:cNvGrpSpPr/>
-        <p:nvPr/>
-      </p:nvGrpSpPr>
-      <p:grpSpPr>
-        <a:xfrm>
-          <a:off x="0" y="0"/>
-          <a:ext cx="0" cy="0"/>
-          <a:chOff x="0" y="0"/>
-          <a:chExt cx="0" cy="0"/>
-        </a:xfrm>
-      </p:grpSpPr>
-      <p:sp>
-        <p:nvSpPr>
-          <p:cNvPr id="2" name="Slide Image Placeholder 1"/>
-          <p:cNvSpPr>
-            <a:spLocks noGrp="1" noRot="1" noChangeAspect="1"/>
-          </p:cNvSpPr>
-          <p:nvPr>
-            <p:ph type="sldImg"/>
-          </p:nvPr>
-        </p:nvSpPr>
-        <p:spPr/>
-      </p:sp>
-      <p:sp>
-        <p:nvSpPr>
-          <p:cNvPr id="3" name="Notes Placeholder 2"/>
-          <p:cNvSpPr>
-            <a:spLocks noGrp="1"/>
-          </p:cNvSpPr>
-          <p:nvPr>
-            <p:ph type="body" idx="1"/>
-          </p:nvPr>
-        </p:nvSpPr>
-        <p:spPr/>
-        <p:txBody>
-          <a:bodyPr/>
-          <a:lstStyle/>
-          <a:p>
-            <a:r>
-              <a:rPr lang="en-US" dirty="0"/>
-              <a:t>ADR-011: O api-contract.md é o handoff formal com backend. O adapter pattern garante zero acoplamento — troca de mock para real é mudança em um arquivo. Feature flag no deploy garante que mock nunca vai a produção exposto.</a:t>
-            </a:r>
-            <a:endParaRPr lang="en-US" dirty="0"/>
-          </a:p>
-        </p:txBody>
-      </p:sp>
-      <p:sp>
-        <p:nvSpPr>
-          <p:cNvPr id="4" name="Slide Number Placeholder 3"/>
-          <p:cNvSpPr>
-            <a:spLocks noGrp="1"/>
-          </p:cNvSpPr>
-          <p:nvPr>
-            <p:ph type="sldNum" sz="quarter" idx="10"/>
-          </p:nvPr>
-        </p:nvSpPr>
-        <p:spPr/>
-        <p:txBody>
-          <a:bodyPr/>
-          <a:lstStyle/>
-          <a:p>
-            <a:fld id="{F7021451-1387-4CA6-816F-3879F97B5CBC}" type="slidenum">
-              <a:rPr lang="en-US"/>
-              <a:t>12</a:t>
-            </a:fld>
-            <a:endParaRPr lang="en-US"/>
-          </a:p>
-        </p:txBody>
-      </p:sp>
-    </p:spTree>
-    <p:extLst>
-      <p:ext uri="{BB962C8B-B14F-4D97-AF65-F5344CB8AC3E}">
-        <p14:creationId xmlns:p14="http://schemas.microsoft.com/office/powerpoint/2010/main" val="1024086991"/>
-      </p:ext>
-    </p:extLst>
-  </p:cSld>
-  <p:clrMapOvr>
-    <a:masterClrMapping/>
-  </p:clrMapOvr>
-</p:notes>
-</file>
-
-<file path=ppt\notesSlides\notesSlide13.xml><?xml version="1.0" encoding="utf-8"?>
-<p:notes xmlns:a="http://schemas.openxmlformats.org/drawingml/2006/main" xmlns:r="http://schemas.openxmlformats.org/officeDocument/2006/relationships" xmlns:p="http://schemas.openxmlformats.org/presentationml/2006/main">
-  <p:cSld>
-    <p:spTree>
-      <p:nvGrpSpPr>
-        <p:cNvPr id="1" name=""/>
-        <p:cNvGrpSpPr/>
-        <p:nvPr/>
-      </p:nvGrpSpPr>
-      <p:grpSpPr>
-        <a:xfrm>
-          <a:off x="0" y="0"/>
-          <a:ext cx="0" cy="0"/>
-          <a:chOff x="0" y="0"/>
-          <a:chExt cx="0" cy="0"/>
-        </a:xfrm>
-      </p:grpSpPr>
-      <p:sp>
-        <p:nvSpPr>
-          <p:cNvPr id="2" name="Slide Image Placeholder 1"/>
-          <p:cNvSpPr>
-            <a:spLocks noGrp="1" noRot="1" noChangeAspect="1"/>
-          </p:cNvSpPr>
-          <p:nvPr>
-            <p:ph type="sldImg"/>
-          </p:nvPr>
-        </p:nvSpPr>
-        <p:spPr/>
-      </p:sp>
-      <p:sp>
-        <p:nvSpPr>
-          <p:cNvPr id="3" name="Notes Placeholder 2"/>
-          <p:cNvSpPr>
-            <a:spLocks noGrp="1"/>
-          </p:cNvSpPr>
-          <p:nvPr>
-            <p:ph type="body" idx="1"/>
-          </p:nvPr>
-        </p:nvSpPr>
-        <p:spPr/>
-        <p:txBody>
-          <a:bodyPr/>
-          <a:lstStyle/>
-          <a:p>
-            <a:r>
-              <a:rPr lang="en-US" dirty="0"/>
-              <a:t>Evals são testes para agentes. Cada mudança em skill ou instrução dispara CI. Pass rate de 85% é o gate — abaixo disso, o merge é bloqueado. Incidentes de produção viram evals permanentes: "não pode acontecer de novo" tem implementação concreta.</a:t>
-            </a:r>
-            <a:endParaRPr lang="en-US" dirty="0"/>
-          </a:p>
-        </p:txBody>
-      </p:sp>
-      <p:sp>
-        <p:nvSpPr>
-          <p:cNvPr id="4" name="Slide Number Placeholder 3"/>
-          <p:cNvSpPr>
-            <a:spLocks noGrp="1"/>
-          </p:cNvSpPr>
-          <p:nvPr>
-            <p:ph type="sldNum" sz="quarter" idx="10"/>
-          </p:nvPr>
-        </p:nvSpPr>
-        <p:spPr/>
-        <p:txBody>
-          <a:bodyPr/>
-          <a:lstStyle/>
-          <a:p>
-            <a:fld id="{F7021451-1387-4CA6-816F-3879F97B5CBC}" type="slidenum">
-              <a:rPr lang="en-US"/>
-              <a:t>13</a:t>
-            </a:fld>
-            <a:endParaRPr lang="en-US"/>
-          </a:p>
-        </p:txBody>
-      </p:sp>
-    </p:spTree>
-    <p:extLst>
-      <p:ext uri="{BB962C8B-B14F-4D97-AF65-F5344CB8AC3E}">
-        <p14:creationId xmlns:p14="http://schemas.microsoft.com/office/powerpoint/2010/main" val="1024086991"/>
-      </p:ext>
-    </p:extLst>
-  </p:cSld>
-  <p:clrMapOvr>
-    <a:masterClrMapping/>
-  </p:clrMapOvr>
-</p:notes>
-</file>
-
-<file path=ppt\notesSlides\notesSlide14.xml><?xml version="1.0" encoding="utf-8"?>
-<p:notes xmlns:a="http://schemas.openxmlformats.org/drawingml/2006/main" xmlns:r="http://schemas.openxmlformats.org/officeDocument/2006/relationships" xmlns:p="http://schemas.openxmlformats.org/presentationml/2006/main">
-  <p:cSld>
-    <p:spTree>
-      <p:nvGrpSpPr>
-        <p:cNvPr id="1" name=""/>
-        <p:cNvGrpSpPr/>
-        <p:nvPr/>
-      </p:nvGrpSpPr>
-      <p:grpSpPr>
-        <a:xfrm>
-          <a:off x="0" y="0"/>
-          <a:ext cx="0" cy="0"/>
-          <a:chOff x="0" y="0"/>
-          <a:chExt cx="0" cy="0"/>
-        </a:xfrm>
-      </p:grpSpPr>
-      <p:sp>
-        <p:nvSpPr>
-          <p:cNvPr id="2" name="Slide Image Placeholder 1"/>
-          <p:cNvSpPr>
-            <a:spLocks noGrp="1" noRot="1" noChangeAspect="1"/>
-          </p:cNvSpPr>
-          <p:nvPr>
-            <p:ph type="sldImg"/>
-          </p:nvPr>
-        </p:nvSpPr>
-        <p:spPr/>
-      </p:sp>
-      <p:sp>
-        <p:nvSpPr>
-          <p:cNvPr id="3" name="Notes Placeholder 2"/>
-          <p:cNvSpPr>
-            <a:spLocks noGrp="1"/>
-          </p:cNvSpPr>
-          <p:nvPr>
-            <p:ph type="body" idx="1"/>
-          </p:nvPr>
-        </p:nvSpPr>
-        <p:spPr/>
-        <p:txBody>
-          <a:bodyPr/>
-          <a:lstStyle/>
-          <a:p>
-            <a:r>
-              <a:rPr lang="en-US" dirty="0"/>
-              <a:t>Agente 07 fecha o loop. Correlação determinística ANTES do Copilot analisar — prevenção de hallucination. Cada branch da árvore é testável em evals. Output sempre: GitHub Issue + PR com intent.md.</a:t>
-            </a:r>
-            <a:endParaRPr lang="en-US" dirty="0"/>
-          </a:p>
-        </p:txBody>
-      </p:sp>
-      <p:sp>
-        <p:nvSpPr>
-          <p:cNvPr id="4" name="Slide Number Placeholder 3"/>
-          <p:cNvSpPr>
-            <a:spLocks noGrp="1"/>
-          </p:cNvSpPr>
-          <p:nvPr>
-            <p:ph type="sldNum" sz="quarter" idx="10"/>
-          </p:nvPr>
-        </p:nvSpPr>
-        <p:spPr/>
-        <p:txBody>
-          <a:bodyPr/>
-          <a:lstStyle/>
-          <a:p>
-            <a:fld id="{F7021451-1387-4CA6-816F-3879F97B5CBC}" type="slidenum">
-              <a:rPr lang="en-US"/>
-              <a:t>14</a:t>
-            </a:fld>
-            <a:endParaRPr lang="en-US"/>
-          </a:p>
-        </p:txBody>
-      </p:sp>
-    </p:spTree>
-    <p:extLst>
-      <p:ext uri="{BB962C8B-B14F-4D97-AF65-F5344CB8AC3E}">
-        <p14:creationId xmlns:p14="http://schemas.microsoft.com/office/powerpoint/2010/main" val="1024086991"/>
-      </p:ext>
-    </p:extLst>
-  </p:cSld>
-  <p:clrMapOvr>
-    <a:masterClrMapping/>
-  </p:clrMapOvr>
-</p:notes>
-</file>
-
-<file path=ppt\notesSlides\notesSlide15.xml><?xml version="1.0" encoding="utf-8"?>
-<p:notes xmlns:a="http://schemas.openxmlformats.org/drawingml/2006/main" xmlns:r="http://schemas.openxmlformats.org/officeDocument/2006/relationships" xmlns:p="http://schemas.openxmlformats.org/presentationml/2006/main">
-  <p:cSld>
-    <p:spTree>
-      <p:nvGrpSpPr>
-        <p:cNvPr id="1" name=""/>
-        <p:cNvGrpSpPr/>
-        <p:nvPr/>
-      </p:nvGrpSpPr>
-      <p:grpSpPr>
-        <a:xfrm>
-          <a:off x="0" y="0"/>
-          <a:ext cx="0" cy="0"/>
-          <a:chOff x="0" y="0"/>
-          <a:chExt cx="0" cy="0"/>
-        </a:xfrm>
-      </p:grpSpPr>
-      <p:sp>
-        <p:nvSpPr>
-          <p:cNvPr id="2" name="Slide Image Placeholder 1"/>
-          <p:cNvSpPr>
-            <a:spLocks noGrp="1" noRot="1" noChangeAspect="1"/>
-          </p:cNvSpPr>
-          <p:nvPr>
-            <p:ph type="sldImg"/>
-          </p:nvPr>
-        </p:nvSpPr>
-        <p:spPr/>
-      </p:sp>
-      <p:sp>
-        <p:nvSpPr>
-          <p:cNvPr id="3" name="Notes Placeholder 2"/>
-          <p:cNvSpPr>
-            <a:spLocks noGrp="1"/>
-          </p:cNvSpPr>
-          <p:nvPr>
-            <p:ph type="body" idx="1"/>
-          </p:nvPr>
-        </p:nvSpPr>
-        <p:spPr/>
-        <p:txBody>
-          <a:bodyPr/>
-          <a:lstStyle/>
-          <a:p>
-            <a:r>
-              <a:rPr lang="en-US" dirty="0"/>
-              <a:t>Resumo: 6 decisões tomadas, 1 em aberto que bloqueia Fase 0. Próximo passo: definir a arquitetura de distribuição de conhecimento com plataforma, arquitetura e segurança. Sem isso, a Fase 0 não entra em produção.</a:t>
-            </a:r>
-            <a:endParaRPr lang="en-US" dirty="0"/>
-          </a:p>
-        </p:txBody>
-      </p:sp>
-      <p:sp>
-        <p:nvSpPr>
-          <p:cNvPr id="4" name="Slide Number Placeholder 3"/>
-          <p:cNvSpPr>
-            <a:spLocks noGrp="1"/>
-          </p:cNvSpPr>
-          <p:nvPr>
-            <p:ph type="sldNum" sz="quarter" idx="10"/>
-          </p:nvPr>
-        </p:nvSpPr>
-        <p:spPr/>
-        <p:txBody>
-          <a:bodyPr/>
-          <a:lstStyle/>
-          <a:p>
-            <a:fld id="{F7021451-1387-4CA6-816F-3879F97B5CBC}" type="slidenum">
-              <a:rPr lang="en-US"/>
-              <a:t>15</a:t>
-            </a:fld>
-            <a:endParaRPr lang="en-US"/>
-          </a:p>
-        </p:txBody>
-      </p:sp>
-    </p:spTree>
-    <p:extLst>
-      <p:ext uri="{BB962C8B-B14F-4D97-AF65-F5344CB8AC3E}">
-        <p14:creationId xmlns:p14="http://schemas.microsoft.com/office/powerpoint/2010/main" val="1024086991"/>
-      </p:ext>
-    </p:extLst>
-  </p:cSld>
-  <p:clrMapOvr>
-    <a:masterClrMapping/>
-  </p:clrMapOvr>
-</p:notes>
-</file>
-
-<file path=ppt\notesSlides\notesSlide2.xml><?xml version="1.0" encoding="utf-8"?>
-<p:notes xmlns:a="http://schemas.openxmlformats.org/drawingml/2006/main" xmlns:r="http://schemas.openxmlformats.org/officeDocument/2006/relationships" xmlns:p="http://schemas.openxmlformats.org/presentationml/2006/main">
-  <p:cSld>
-    <p:spTree>
-      <p:nvGrpSpPr>
-        <p:cNvPr id="1" name=""/>
-        <p:cNvGrpSpPr/>
-        <p:nvPr/>
-      </p:nvGrpSpPr>
-      <p:grpSpPr>
-        <a:xfrm>
-          <a:off x="0" y="0"/>
-          <a:ext cx="0" cy="0"/>
-          <a:chOff x="0" y="0"/>
-          <a:chExt cx="0" cy="0"/>
-        </a:xfrm>
-      </p:grpSpPr>
-      <p:sp>
-        <p:nvSpPr>
-          <p:cNvPr id="2" name="Slide Image Placeholder 1"/>
-          <p:cNvSpPr>
-            <a:spLocks noGrp="1" noRot="1" noChangeAspect="1"/>
-          </p:cNvSpPr>
-          <p:nvPr>
-            <p:ph type="sldImg"/>
-          </p:nvPr>
-        </p:nvSpPr>
-        <p:spPr/>
-      </p:sp>
-      <p:sp>
-        <p:nvSpPr>
-          <p:cNvPr id="3" name="Notes Placeholder 2"/>
-          <p:cNvSpPr>
-            <a:spLocks noGrp="1"/>
-          </p:cNvSpPr>
-          <p:nvPr>
-            <p:ph type="body" idx="1"/>
-          </p:nvPr>
-        </p:nvSpPr>
-        <p:spPr/>
-        <p:txBody>
-          <a:bodyPr/>
-          <a:lstStyle/>
-          <a:p>
-            <a:r>
-              <a:rPr lang="en-US" dirty="0"/>
-              <a:t>Mensagem central: o Copilot já está contratado, mas uso individual não escala. Precisamos de uma estrutura organizacional — artefatos, contexto, gates, métricas — para converter adoção em vantagem competitiva.</a:t>
-            </a:r>
-            <a:endParaRPr lang="en-US" dirty="0"/>
-          </a:p>
-        </p:txBody>
-      </p:sp>
-      <p:sp>
-        <p:nvSpPr>
-          <p:cNvPr id="4" name="Slide Number Placeholder 3"/>
-          <p:cNvSpPr>
-            <a:spLocks noGrp="1"/>
-          </p:cNvSpPr>
-          <p:nvPr>
-            <p:ph type="sldNum" sz="quarter" idx="10"/>
-          </p:nvPr>
-        </p:nvSpPr>
-        <p:spPr/>
-        <p:txBody>
-          <a:bodyPr/>
-          <a:lstStyle/>
-          <a:p>
-            <a:fld id="{F7021451-1387-4CA6-816F-3879F97B5CBC}" type="slidenum">
-              <a:rPr lang="en-US"/>
-              <a:t>2</a:t>
-            </a:fld>
-            <a:endParaRPr lang="en-US"/>
-          </a:p>
-        </p:txBody>
-      </p:sp>
-    </p:spTree>
-    <p:extLst>
-      <p:ext uri="{BB962C8B-B14F-4D97-AF65-F5344CB8AC3E}">
-        <p14:creationId xmlns:p14="http://schemas.microsoft.com/office/powerpoint/2010/main" val="1024086991"/>
-      </p:ext>
-    </p:extLst>
-  </p:cSld>
-  <p:clrMapOvr>
-    <a:masterClrMapping/>
-  </p:clrMapOvr>
-</p:notes>
-</file>
-
-<file path=ppt\notesSlides\notesSlide3.xml><?xml version="1.0" encoding="utf-8"?>
-<p:notes xmlns:a="http://schemas.openxmlformats.org/drawingml/2006/main" xmlns:r="http://schemas.openxmlformats.org/officeDocument/2006/relationships" xmlns:p="http://schemas.openxmlformats.org/presentationml/2006/main">
-  <p:cSld>
-    <p:spTree>
-      <p:nvGrpSpPr>
-        <p:cNvPr id="1" name=""/>
-        <p:cNvGrpSpPr/>
-        <p:nvPr/>
-      </p:nvGrpSpPr>
-      <p:grpSpPr>
-        <a:xfrm>
-          <a:off x="0" y="0"/>
-          <a:ext cx="0" cy="0"/>
-          <a:chOff x="0" y="0"/>
-          <a:chExt cx="0" cy="0"/>
-        </a:xfrm>
-      </p:grpSpPr>
-      <p:sp>
-        <p:nvSpPr>
-          <p:cNvPr id="2" name="Slide Image Placeholder 1"/>
-          <p:cNvSpPr>
-            <a:spLocks noGrp="1" noRot="1" noChangeAspect="1"/>
-          </p:cNvSpPr>
-          <p:nvPr>
-            <p:ph type="sldImg"/>
-          </p:nvPr>
-        </p:nvSpPr>
-        <p:spPr/>
-      </p:sp>
-      <p:sp>
-        <p:nvSpPr>
-          <p:cNvPr id="3" name="Notes Placeholder 2"/>
-          <p:cNvSpPr>
-            <a:spLocks noGrp="1"/>
-          </p:cNvSpPr>
-          <p:nvPr>
-            <p:ph type="body" idx="1"/>
-          </p:nvPr>
-        </p:nvSpPr>
-        <p:spPr/>
-        <p:txBody>
-          <a:bodyPr/>
-          <a:lstStyle/>
-          <a:p>
-            <a:r>
-              <a:rPr lang="en-US" dirty="0"/>
-              <a:t>A proposta em uma frase. Enfatizar: usamos o runtime que já existe (Copilot Enterprise), sem nova ferramenta. Artefatos Markdown em git = rastreáveis, diff-áveis, auditáveis.</a:t>
-            </a:r>
-            <a:endParaRPr lang="en-US" dirty="0"/>
-          </a:p>
-        </p:txBody>
-      </p:sp>
-      <p:sp>
-        <p:nvSpPr>
-          <p:cNvPr id="4" name="Slide Number Placeholder 3"/>
-          <p:cNvSpPr>
-            <a:spLocks noGrp="1"/>
-          </p:cNvSpPr>
-          <p:nvPr>
-            <p:ph type="sldNum" sz="quarter" idx="10"/>
-          </p:nvPr>
-        </p:nvSpPr>
-        <p:spPr/>
-        <p:txBody>
-          <a:bodyPr/>
-          <a:lstStyle/>
-          <a:p>
-            <a:fld id="{F7021451-1387-4CA6-816F-3879F97B5CBC}" type="slidenum">
-              <a:rPr lang="en-US"/>
-              <a:t>3</a:t>
-            </a:fld>
-            <a:endParaRPr lang="en-US"/>
-          </a:p>
-        </p:txBody>
-      </p:sp>
-    </p:spTree>
-    <p:extLst>
-      <p:ext uri="{BB962C8B-B14F-4D97-AF65-F5344CB8AC3E}">
-        <p14:creationId xmlns:p14="http://schemas.microsoft.com/office/powerpoint/2010/main" val="1024086991"/>
-      </p:ext>
-    </p:extLst>
-  </p:cSld>
-  <p:clrMapOvr>
-    <a:masterClrMapping/>
-  </p:clrMapOvr>
-</p:notes>
-</file>
-
-<file path=ppt\notesSlides\notesSlide4.xml><?xml version="1.0" encoding="utf-8"?>
-<p:notes xmlns:a="http://schemas.openxmlformats.org/drawingml/2006/main" xmlns:r="http://schemas.openxmlformats.org/officeDocument/2006/relationships" xmlns:p="http://schemas.openxmlformats.org/presentationml/2006/main">
-  <p:cSld>
-    <p:spTree>
-      <p:nvGrpSpPr>
-        <p:cNvPr id="1" name=""/>
-        <p:cNvGrpSpPr/>
-        <p:nvPr/>
-      </p:nvGrpSpPr>
-      <p:grpSpPr>
-        <a:xfrm>
-          <a:off x="0" y="0"/>
-          <a:ext cx="0" cy="0"/>
-          <a:chOff x="0" y="0"/>
-          <a:chExt cx="0" cy="0"/>
-        </a:xfrm>
-      </p:grpSpPr>
-      <p:sp>
-        <p:nvSpPr>
-          <p:cNvPr id="2" name="Slide Image Placeholder 1"/>
-          <p:cNvSpPr>
-            <a:spLocks noGrp="1" noRot="1" noChangeAspect="1"/>
-          </p:cNvSpPr>
-          <p:nvPr>
-            <p:ph type="sldImg"/>
-          </p:nvPr>
-        </p:nvSpPr>
-        <p:spPr/>
-      </p:sp>
-      <p:sp>
-        <p:nvSpPr>
-          <p:cNvPr id="3" name="Notes Placeholder 2"/>
-          <p:cNvSpPr>
-            <a:spLocks noGrp="1"/>
-          </p:cNvSpPr>
-          <p:nvPr>
-            <p:ph type="body" idx="1"/>
-          </p:nvPr>
-        </p:nvSpPr>
-        <p:spPr/>
-        <p:txBody>
-          <a:bodyPr/>
-          <a:lstStyle/>
-          <a:p>
-            <a:r>
-              <a:rPr lang="en-US" dirty="0"/>
-              <a:t>Agente = Copilot contextualizado. Não é um processo externo. Skills são o mecanismo de conhecimento — determinísticas, versionadas, portáveis entre runtimes.</a:t>
-            </a:r>
-            <a:endParaRPr lang="en-US" dirty="0"/>
-          </a:p>
-        </p:txBody>
-      </p:sp>
-      <p:sp>
-        <p:nvSpPr>
-          <p:cNvPr id="4" name="Slide Number Placeholder 3"/>
-          <p:cNvSpPr>
-            <a:spLocks noGrp="1"/>
-          </p:cNvSpPr>
-          <p:nvPr>
-            <p:ph type="sldNum" sz="quarter" idx="10"/>
-          </p:nvPr>
-        </p:nvSpPr>
-        <p:spPr/>
-        <p:txBody>
-          <a:bodyPr/>
-          <a:lstStyle/>
-          <a:p>
-            <a:fld id="{F7021451-1387-4CA6-816F-3879F97B5CBC}" type="slidenum">
-              <a:rPr lang="en-US"/>
-              <a:t>4</a:t>
-            </a:fld>
-            <a:endParaRPr lang="en-US"/>
-          </a:p>
-        </p:txBody>
-      </p:sp>
-    </p:spTree>
-    <p:extLst>
-      <p:ext uri="{BB962C8B-B14F-4D97-AF65-F5344CB8AC3E}">
-        <p14:creationId xmlns:p14="http://schemas.microsoft.com/office/powerpoint/2010/main" val="1024086991"/>
-      </p:ext>
-    </p:extLst>
-  </p:cSld>
-  <p:clrMapOvr>
-    <a:masterClrMapping/>
-  </p:clrMapOvr>
-</p:notes>
-</file>
-
-<file path=ppt\notesSlides\notesSlide5.xml><?xml version="1.0" encoding="utf-8"?>
-<p:notes xmlns:a="http://schemas.openxmlformats.org/drawingml/2006/main" xmlns:r="http://schemas.openxmlformats.org/officeDocument/2006/relationships" xmlns:p="http://schemas.openxmlformats.org/presentationml/2006/main">
-  <p:cSld>
-    <p:spTree>
-      <p:nvGrpSpPr>
-        <p:cNvPr id="1" name=""/>
-        <p:cNvGrpSpPr/>
-        <p:nvPr/>
-      </p:nvGrpSpPr>
-      <p:grpSpPr>
-        <a:xfrm>
-          <a:off x="0" y="0"/>
-          <a:ext cx="0" cy="0"/>
-          <a:chOff x="0" y="0"/>
-          <a:chExt cx="0" cy="0"/>
-        </a:xfrm>
-      </p:grpSpPr>
-      <p:sp>
-        <p:nvSpPr>
-          <p:cNvPr id="2" name="Slide Image Placeholder 1"/>
-          <p:cNvSpPr>
-            <a:spLocks noGrp="1" noRot="1" noChangeAspect="1"/>
-          </p:cNvSpPr>
-          <p:nvPr>
-            <p:ph type="sldImg"/>
-          </p:nvPr>
-        </p:nvSpPr>
-        <p:spPr/>
-      </p:sp>
-      <p:sp>
-        <p:nvSpPr>
-          <p:cNvPr id="3" name="Notes Placeholder 2"/>
-          <p:cNvSpPr>
-            <a:spLocks noGrp="1"/>
-          </p:cNvSpPr>
-          <p:nvPr>
-            <p:ph type="body" idx="1"/>
-          </p:nvPr>
-        </p:nvSpPr>
-        <p:spPr/>
-        <p:txBody>
-          <a:bodyPr/>
-          <a:lstStyle/>
-          <a:p>
-            <a:r>
-              <a:rPr lang="en-US" dirty="0"/>
-              <a:t>Macrofluxo em loop: sentido horário. Top: Negocial (externo, âmbar)→02 Spec→03 Plan. Desce à direita. Bottom (dir→esq): 04 Build→05 Test→06 Deploy→07 Maintain. Sobe à esquerda: 07 gera intent.md que re-entra no pipeline. O loop fecha. Negocial está em âmbar para indicar que é externo ao time de plataforma mobile.</a:t>
-            </a:r>
-            <a:endParaRPr lang="en-US" dirty="0"/>
-          </a:p>
-        </p:txBody>
-      </p:sp>
-      <p:sp>
-        <p:nvSpPr>
-          <p:cNvPr id="4" name="Slide Number Placeholder 3"/>
-          <p:cNvSpPr>
-            <a:spLocks noGrp="1"/>
-          </p:cNvSpPr>
-          <p:nvPr>
-            <p:ph type="sldNum" sz="quarter" idx="10"/>
-          </p:nvPr>
-        </p:nvSpPr>
-        <p:spPr/>
-        <p:txBody>
-          <a:bodyPr/>
-          <a:lstStyle/>
-          <a:p>
-            <a:fld id="{F7021451-1387-4CA6-816F-3879F97B5CBC}" type="slidenum">
-              <a:rPr lang="en-US"/>
-              <a:t>5</a:t>
-            </a:fld>
-            <a:endParaRPr lang="en-US"/>
-          </a:p>
-        </p:txBody>
-      </p:sp>
-    </p:spTree>
-    <p:extLst>
-      <p:ext uri="{BB962C8B-B14F-4D97-AF65-F5344CB8AC3E}">
-        <p14:creationId xmlns:p14="http://schemas.microsoft.com/office/powerpoint/2010/main" val="1024086991"/>
-      </p:ext>
-    </p:extLst>
-  </p:cSld>
-  <p:clrMapOvr>
-    <a:masterClrMapping/>
-  </p:clrMapOvr>
-</p:notes>
-</file>
-
-<file path=ppt\notesSlides\notesSlide6.xml><?xml version="1.0" encoding="utf-8"?>
-<p:notes xmlns:a="http://schemas.openxmlformats.org/drawingml/2006/main" xmlns:r="http://schemas.openxmlformats.org/officeDocument/2006/relationships" xmlns:p="http://schemas.openxmlformats.org/presentationml/2006/main">
-  <p:cSld>
-    <p:spTree>
-      <p:nvGrpSpPr>
-        <p:cNvPr id="1" name=""/>
-        <p:cNvGrpSpPr/>
-        <p:nvPr/>
-      </p:nvGrpSpPr>
-      <p:grpSpPr>
-        <a:xfrm>
-          <a:off x="0" y="0"/>
-          <a:ext cx="0" cy="0"/>
-          <a:chOff x="0" y="0"/>
-          <a:chExt cx="0" cy="0"/>
-        </a:xfrm>
-      </p:grpSpPr>
-      <p:sp>
-        <p:nvSpPr>
-          <p:cNvPr id="2" name="Slide Image Placeholder 1"/>
-          <p:cNvSpPr>
-            <a:spLocks noGrp="1" noRot="1" noChangeAspect="1"/>
-          </p:cNvSpPr>
-          <p:nvPr>
-            <p:ph type="sldImg"/>
-          </p:nvPr>
-        </p:nvSpPr>
-        <p:spPr/>
-      </p:sp>
-      <p:sp>
-        <p:nvSpPr>
-          <p:cNvPr id="3" name="Notes Placeholder 2"/>
-          <p:cNvSpPr>
-            <a:spLocks noGrp="1"/>
-          </p:cNvSpPr>
-          <p:nvPr>
-            <p:ph type="body" idx="1"/>
-          </p:nvPr>
-        </p:nvSpPr>
-        <p:spPr/>
-        <p:txBody>
-          <a:bodyPr/>
-          <a:lstStyle/>
-          <a:p>
-            <a:r>
-              <a:rPr lang="en-US" dirty="0"/>
-              <a:t>Os artefatos não são burocracia — são o mecanismo que cria contexto, governa decisões e permite rastreabilidade. Sem eles, o agente opera sem contexto e o humano sem registro.</a:t>
-            </a:r>
-            <a:endParaRPr lang="en-US" dirty="0"/>
-          </a:p>
-        </p:txBody>
-      </p:sp>
-      <p:sp>
-        <p:nvSpPr>
-          <p:cNvPr id="4" name="Slide Number Placeholder 3"/>
-          <p:cNvSpPr>
-            <a:spLocks noGrp="1"/>
-          </p:cNvSpPr>
-          <p:nvPr>
-            <p:ph type="sldNum" sz="quarter" idx="10"/>
-          </p:nvPr>
-        </p:nvSpPr>
-        <p:spPr/>
-        <p:txBody>
-          <a:bodyPr/>
-          <a:lstStyle/>
-          <a:p>
-            <a:fld id="{F7021451-1387-4CA6-816F-3879F97B5CBC}" type="slidenum">
-              <a:rPr lang="en-US"/>
-              <a:t>6</a:t>
-            </a:fld>
-            <a:endParaRPr lang="en-US"/>
-          </a:p>
-        </p:txBody>
-      </p:sp>
-    </p:spTree>
-    <p:extLst>
-      <p:ext uri="{BB962C8B-B14F-4D97-AF65-F5344CB8AC3E}">
-        <p14:creationId xmlns:p14="http://schemas.microsoft.com/office/powerpoint/2010/main" val="1024086991"/>
-      </p:ext>
-    </p:extLst>
-  </p:cSld>
-  <p:clrMapOvr>
-    <a:masterClrMapping/>
-  </p:clrMapOvr>
-</p:notes>
-</file>
-
-<file path=ppt\notesSlides\notesSlide7.xml><?xml version="1.0" encoding="utf-8"?>
-<p:notes xmlns:a="http://schemas.openxmlformats.org/drawingml/2006/main" xmlns:r="http://schemas.openxmlformats.org/officeDocument/2006/relationships" xmlns:p="http://schemas.openxmlformats.org/presentationml/2006/main">
-  <p:cSld>
-    <p:spTree>
-      <p:nvGrpSpPr>
-        <p:cNvPr id="1" name=""/>
-        <p:cNvGrpSpPr/>
-        <p:nvPr/>
-      </p:nvGrpSpPr>
-      <p:grpSpPr>
-        <a:xfrm>
-          <a:off x="0" y="0"/>
-          <a:ext cx="0" cy="0"/>
-          <a:chOff x="0" y="0"/>
-          <a:chExt cx="0" cy="0"/>
-        </a:xfrm>
-      </p:grpSpPr>
-      <p:sp>
-        <p:nvSpPr>
-          <p:cNvPr id="2" name="Slide Image Placeholder 1"/>
-          <p:cNvSpPr>
-            <a:spLocks noGrp="1" noRot="1" noChangeAspect="1"/>
-          </p:cNvSpPr>
-          <p:nvPr>
-            <p:ph type="sldImg"/>
-          </p:nvPr>
-        </p:nvSpPr>
-        <p:spPr/>
-      </p:sp>
-      <p:sp>
-        <p:nvSpPr>
-          <p:cNvPr id="3" name="Notes Placeholder 2"/>
-          <p:cNvSpPr>
-            <a:spLocks noGrp="1"/>
-          </p:cNvSpPr>
-          <p:nvPr>
-            <p:ph type="body" idx="1"/>
-          </p:nvPr>
-        </p:nvSpPr>
-        <p:spPr/>
-        <p:txBody>
-          <a:bodyPr/>
-          <a:lstStyle/>
-          <a:p>
-            <a:r>
-              <a:rPr lang="en-US" dirty="0"/>
-              <a:t>Arquitetura em 3 camadas que operam em paralelo: pipeline de artefatos, infraestrutura de conhecimento (skills), e monitoramento contínuo. Todas as integrações usam sistemas existentes.</a:t>
-            </a:r>
-            <a:endParaRPr lang="en-US" dirty="0"/>
-          </a:p>
-        </p:txBody>
-      </p:sp>
-      <p:sp>
-        <p:nvSpPr>
-          <p:cNvPr id="4" name="Slide Number Placeholder 3"/>
-          <p:cNvSpPr>
-            <a:spLocks noGrp="1"/>
-          </p:cNvSpPr>
-          <p:nvPr>
-            <p:ph type="sldNum" sz="quarter" idx="10"/>
-          </p:nvPr>
-        </p:nvSpPr>
-        <p:spPr/>
-        <p:txBody>
-          <a:bodyPr/>
-          <a:lstStyle/>
-          <a:p>
-            <a:fld id="{F7021451-1387-4CA6-816F-3879F97B5CBC}" type="slidenum">
-              <a:rPr lang="en-US"/>
-              <a:t>7</a:t>
-            </a:fld>
-            <a:endParaRPr lang="en-US"/>
-          </a:p>
-        </p:txBody>
-      </p:sp>
-    </p:spTree>
-    <p:extLst>
-      <p:ext uri="{BB962C8B-B14F-4D97-AF65-F5344CB8AC3E}">
-        <p14:creationId xmlns:p14="http://schemas.microsoft.com/office/powerpoint/2010/main" val="1024086991"/>
-      </p:ext>
-    </p:extLst>
-  </p:cSld>
-  <p:clrMapOvr>
-    <a:masterClrMapping/>
-  </p:clrMapOvr>
-</p:notes>
-</file>
-
-<file path=ppt\notesSlides\notesSlide8.xml><?xml version="1.0" encoding="utf-8"?>
-<p:notes xmlns:a="http://schemas.openxmlformats.org/drawingml/2006/main" xmlns:r="http://schemas.openxmlformats.org/officeDocument/2006/relationships" xmlns:p="http://schemas.openxmlformats.org/presentationml/2006/main">
-  <p:cSld>
-    <p:spTree>
-      <p:nvGrpSpPr>
-        <p:cNvPr id="1" name=""/>
-        <p:cNvGrpSpPr/>
-        <p:nvPr/>
-      </p:nvGrpSpPr>
-      <p:grpSpPr>
-        <a:xfrm>
-          <a:off x="0" y="0"/>
-          <a:ext cx="0" cy="0"/>
-          <a:chOff x="0" y="0"/>
-          <a:chExt cx="0" cy="0"/>
-        </a:xfrm>
-      </p:grpSpPr>
-      <p:sp>
-        <p:nvSpPr>
-          <p:cNvPr id="2" name="Slide Image Placeholder 1"/>
-          <p:cNvSpPr>
-            <a:spLocks noGrp="1" noRot="1" noChangeAspect="1"/>
-          </p:cNvSpPr>
-          <p:nvPr>
-            <p:ph type="sldImg"/>
-          </p:nvPr>
-        </p:nvSpPr>
-        <p:spPr/>
-      </p:sp>
-      <p:sp>
-        <p:nvSpPr>
-          <p:cNvPr id="3" name="Notes Placeholder 2"/>
-          <p:cNvSpPr>
-            <a:spLocks noGrp="1"/>
-          </p:cNvSpPr>
-          <p:nvPr>
-            <p:ph type="body" idx="1"/>
-          </p:nvPr>
-        </p:nvSpPr>
-        <p:spPr/>
-        <p:txBody>
-          <a:bodyPr/>
-          <a:lstStyle/>
-          <a:p>
-            <a:r>
-              <a:rPr lang="en-US" dirty="0"/>
-              <a:t>Enfatizar: nenhuma ferramenta nova. A esteira roda sobre a infraestrutura que já existe. O investimento é em conhecimento (skills) e processo (artefatos), não em ferramentas.</a:t>
-            </a:r>
-            <a:endParaRPr lang="en-US" dirty="0"/>
-          </a:p>
-        </p:txBody>
-      </p:sp>
-      <p:sp>
-        <p:nvSpPr>
-          <p:cNvPr id="4" name="Slide Number Placeholder 3"/>
-          <p:cNvSpPr>
-            <a:spLocks noGrp="1"/>
-          </p:cNvSpPr>
-          <p:nvPr>
-            <p:ph type="sldNum" sz="quarter" idx="10"/>
-          </p:nvPr>
-        </p:nvSpPr>
-        <p:spPr/>
-        <p:txBody>
-          <a:bodyPr/>
-          <a:lstStyle/>
-          <a:p>
-            <a:fld id="{F7021451-1387-4CA6-816F-3879F97B5CBC}" type="slidenum">
-              <a:rPr lang="en-US"/>
-              <a:t>8</a:t>
-            </a:fld>
-            <a:endParaRPr lang="en-US"/>
-          </a:p>
-        </p:txBody>
-      </p:sp>
-    </p:spTree>
-    <p:extLst>
-      <p:ext uri="{BB962C8B-B14F-4D97-AF65-F5344CB8AC3E}">
-        <p14:creationId xmlns:p14="http://schemas.microsoft.com/office/powerpoint/2010/main" val="1024086991"/>
-      </p:ext>
-    </p:extLst>
-  </p:cSld>
-  <p:clrMapOvr>
-    <a:masterClrMapping/>
-  </p:clrMapOvr>
-</p:notes>
-</file>
-
-<file path=ppt\notesSlides\notesSlide9.xml><?xml version="1.0" encoding="utf-8"?>
-<p:notes xmlns:a="http://schemas.openxmlformats.org/drawingml/2006/main" xmlns:r="http://schemas.openxmlformats.org/officeDocument/2006/relationships" xmlns:p="http://schemas.openxmlformats.org/presentationml/2006/main">
-  <p:cSld>
-    <p:spTree>
-      <p:nvGrpSpPr>
-        <p:cNvPr id="1" name=""/>
-        <p:cNvGrpSpPr/>
-        <p:nvPr/>
-      </p:nvGrpSpPr>
-      <p:grpSpPr>
-        <a:xfrm>
-          <a:off x="0" y="0"/>
-          <a:ext cx="0" cy="0"/>
-          <a:chOff x="0" y="0"/>
-          <a:chExt cx="0" cy="0"/>
-        </a:xfrm>
-      </p:grpSpPr>
-      <p:sp>
-        <p:nvSpPr>
-          <p:cNvPr id="2" name="Slide Image Placeholder 1"/>
-          <p:cNvSpPr>
-            <a:spLocks noGrp="1" noRot="1" noChangeAspect="1"/>
-          </p:cNvSpPr>
-          <p:nvPr>
-            <p:ph type="sldImg"/>
-          </p:nvPr>
-        </p:nvSpPr>
-        <p:spPr/>
-      </p:sp>
-      <p:sp>
-        <p:nvSpPr>
-          <p:cNvPr id="3" name="Notes Placeholder 2"/>
-          <p:cNvSpPr>
-            <a:spLocks noGrp="1"/>
-          </p:cNvSpPr>
-          <p:nvPr>
-            <p:ph type="body" idx="1"/>
-          </p:nvPr>
-        </p:nvSpPr>
-        <p:spPr/>
-        <p:txBody>
-          <a:bodyPr/>
-          <a:lstStyle/>
-          <a:p>
-            <a:r>
-              <a:rPr lang="en-US" dirty="0"/>
-              <a:t>Por que não RAG? RAG é probabilístico — o chunk certo pode não ser retornado. Para segurança e compliance, "às vezes carrega a regra certa" não é aceitável. Skills são determinísticas e testáveis em evals.</a:t>
-            </a:r>
-            <a:endParaRPr lang="en-US" dirty="0"/>
-          </a:p>
-        </p:txBody>
-      </p:sp>
-      <p:sp>
-        <p:nvSpPr>
-          <p:cNvPr id="4" name="Slide Number Placeholder 3"/>
-          <p:cNvSpPr>
-            <a:spLocks noGrp="1"/>
-          </p:cNvSpPr>
-          <p:nvPr>
-            <p:ph type="sldNum" sz="quarter" idx="10"/>
-          </p:nvPr>
-        </p:nvSpPr>
-        <p:spPr/>
-        <p:txBody>
-          <a:bodyPr/>
-          <a:lstStyle/>
-          <a:p>
-            <a:fld id="{F7021451-1387-4CA6-816F-3879F97B5CBC}" type="slidenum">
-              <a:rPr lang="en-US"/>
-              <a:t>9</a:t>
-            </a:fld>
-            <a:endParaRPr lang="en-US"/>
-          </a:p>
-        </p:txBody>
-      </p:sp>
-    </p:spTree>
-    <p:extLst>
-      <p:ext uri="{BB962C8B-B14F-4D97-AF65-F5344CB8AC3E}">
-        <p14:creationId xmlns:p14="http://schemas.microsoft.com/office/powerpoint/2010/main" val="1024086991"/>
-      </p:ext>
-    </p:extLst>
-  </p:cSld>
-  <p:clrMapOvr>
-    <a:masterClrMapping/>
-  </p:clrMapOvr>
-</p:notes>
-</file>
-
-<file path=ppt\presProps.xml><?xml version="1.0" encoding="utf-8"?>
-<p:presentationPr xmlns:a="http://schemas.openxmlformats.org/drawingml/2006/main" xmlns:r="http://schemas.openxmlformats.org/officeDocument/2006/relationships" xmlns:p="http://schemas.openxmlformats.org/presentationml/2006/main"/>
-</file>
-
-<file path=ppt\presentation.xml><?xml version="1.0" encoding="utf-8"?>
+<file path=ppt/presentation.xml><?xml version="1.0" encoding="utf-8"?>
 <p:presentation xmlns:a="http://schemas.openxmlformats.org/drawingml/2006/main" xmlns:r="http://schemas.openxmlformats.org/officeDocument/2006/relationships" xmlns:p="http://schemas.openxmlformats.org/presentationml/2006/main" saveSubsetFonts="1" autoCompressPictures="0">
   <p:sldMasterIdLst>
     <p:sldMasterId id="2147483648" r:id="rId1"/>
@@ -1870,7 +121,1676 @@
 </p:presentation>
 </file>
 
-<file path=ppt\slideLayouts\slideLayout1.xml><?xml version="1.0" encoding="utf-8"?>
+<file path=ppt/notesMasters/notesMaster1.xml><?xml version="1.0" encoding="utf-8"?>
+<p:notesMaster xmlns:a="http://schemas.openxmlformats.org/drawingml/2006/main" xmlns:r="http://schemas.openxmlformats.org/officeDocument/2006/relationships" xmlns:p="http://schemas.openxmlformats.org/presentationml/2006/main">
+  <p:cSld>
+    <p:bg>
+      <p:bgRef idx="1001">
+        <a:schemeClr val="bg1"/>
+      </p:bgRef>
+    </p:bg>
+    <p:spTree>
+      <p:nvGrpSpPr>
+        <p:cNvPr id="1" name=""/>
+        <p:cNvGrpSpPr/>
+        <p:nvPr/>
+      </p:nvGrpSpPr>
+      <p:grpSpPr>
+        <a:xfrm>
+          <a:off x="0" y="0"/>
+          <a:ext cx="0" cy="0"/>
+          <a:chOff x="0" y="0"/>
+          <a:chExt cx="0" cy="0"/>
+        </a:xfrm>
+      </p:grpSpPr>
+      <p:sp>
+        <p:nvSpPr>
+          <p:cNvPr id="2" name="Header Placeholder 1"/>
+          <p:cNvSpPr>
+            <a:spLocks noGrp="1"/>
+          </p:cNvSpPr>
+          <p:nvPr>
+            <p:ph type="hdr" sz="quarter"/>
+          </p:nvPr>
+        </p:nvSpPr>
+        <p:spPr>
+          <a:xfrm>
+            <a:off x="0" y="0"/>
+            <a:ext cx="2971800" cy="458788"/>
+          </a:xfrm>
+          <a:prstGeom prst="rect">
+            <a:avLst/>
+          </a:prstGeom>
+        </p:spPr>
+        <p:txBody>
+          <a:bodyPr vert="horz" lIns="91440" tIns="45720" rIns="91440" bIns="45720" rtlCol="0"/>
+          <a:lstStyle>
+            <a:lvl1pPr algn="l">
+              <a:defRPr sz="1200"/>
+            </a:lvl1pPr>
+          </a:lstStyle>
+          <a:p>
+            <a:endParaRPr lang="en-US"/>
+          </a:p>
+        </p:txBody>
+      </p:sp>
+      <p:sp>
+        <p:nvSpPr>
+          <p:cNvPr id="3" name="Date Placeholder 2"/>
+          <p:cNvSpPr>
+            <a:spLocks noGrp="1"/>
+          </p:cNvSpPr>
+          <p:nvPr>
+            <p:ph type="dt" idx="1"/>
+          </p:nvPr>
+        </p:nvSpPr>
+        <p:spPr>
+          <a:xfrm>
+            <a:off x="3884613" y="0"/>
+            <a:ext cx="2971800" cy="458788"/>
+          </a:xfrm>
+          <a:prstGeom prst="rect">
+            <a:avLst/>
+          </a:prstGeom>
+        </p:spPr>
+        <p:txBody>
+          <a:bodyPr vert="horz" lIns="91440" tIns="45720" rIns="91440" bIns="45720" rtlCol="0"/>
+          <a:lstStyle>
+            <a:lvl1pPr algn="r">
+              <a:defRPr sz="1200"/>
+            </a:lvl1pPr>
+          </a:lstStyle>
+          <a:p>
+            <a:fld id="{5282F153-3F37-0F45-9E97-73ACFA13230C}" type="datetimeFigureOut">
+              <a:rPr lang="en-US"/>
+              <a:t>7/23/19</a:t>
+            </a:fld>
+            <a:endParaRPr lang="en-US"/>
+          </a:p>
+        </p:txBody>
+      </p:sp>
+      <p:sp>
+        <p:nvSpPr>
+          <p:cNvPr id="4" name="Slide Image Placeholder 3"/>
+          <p:cNvSpPr>
+            <a:spLocks noGrp="1" noRot="1" noChangeAspect="1"/>
+          </p:cNvSpPr>
+          <p:nvPr>
+            <p:ph type="sldImg" idx="2"/>
+          </p:nvPr>
+        </p:nvSpPr>
+        <p:spPr>
+          <a:xfrm>
+            <a:off x="685800" y="1143000"/>
+            <a:ext cx="5486400" cy="3086100"/>
+          </a:xfrm>
+          <a:prstGeom prst="rect">
+            <a:avLst/>
+          </a:prstGeom>
+          <a:noFill/>
+          <a:ln w="12700">
+            <a:solidFill>
+              <a:prstClr val="black"/>
+            </a:solidFill>
+          </a:ln>
+        </p:spPr>
+        <p:txBody>
+          <a:bodyPr vert="horz" lIns="91440" tIns="45720" rIns="91440" bIns="45720" rtlCol="0" anchor="ctr"/>
+          <a:lstStyle/>
+          <a:p>
+            <a:endParaRPr lang="en-US"/>
+          </a:p>
+        </p:txBody>
+      </p:sp>
+      <p:sp>
+        <p:nvSpPr>
+          <p:cNvPr id="5" name="Notes Placeholder 4"/>
+          <p:cNvSpPr>
+            <a:spLocks noGrp="1"/>
+          </p:cNvSpPr>
+          <p:nvPr>
+            <p:ph type="body" sz="quarter" idx="3"/>
+          </p:nvPr>
+        </p:nvSpPr>
+        <p:spPr>
+          <a:xfrm>
+            <a:off x="685800" y="4400550"/>
+            <a:ext cx="5486400" cy="3600450"/>
+          </a:xfrm>
+          <a:prstGeom prst="rect">
+            <a:avLst/>
+          </a:prstGeom>
+        </p:spPr>
+        <p:txBody>
+          <a:bodyPr vert="horz" lIns="91440" tIns="45720" rIns="91440" bIns="45720" rtlCol="0"/>
+          <a:lstStyle/>
+          <a:p>
+            <a:pPr lvl="0"/>
+            <a:r>
+              <a:rPr lang="en-US"/>
+              <a:t>Click to edit Master text styles</a:t>
+            </a:r>
+          </a:p>
+          <a:p>
+            <a:pPr lvl="1"/>
+            <a:r>
+              <a:rPr lang="en-US"/>
+              <a:t>Second level</a:t>
+            </a:r>
+          </a:p>
+          <a:p>
+            <a:pPr lvl="2"/>
+            <a:r>
+              <a:rPr lang="en-US"/>
+              <a:t>Third level</a:t>
+            </a:r>
+          </a:p>
+          <a:p>
+            <a:pPr lvl="3"/>
+            <a:r>
+              <a:rPr lang="en-US"/>
+              <a:t>Fourth level</a:t>
+            </a:r>
+          </a:p>
+          <a:p>
+            <a:pPr lvl="4"/>
+            <a:r>
+              <a:rPr lang="en-US"/>
+              <a:t>Fifth level</a:t>
+            </a:r>
+          </a:p>
+        </p:txBody>
+      </p:sp>
+      <p:sp>
+        <p:nvSpPr>
+          <p:cNvPr id="6" name="Footer Placeholder 5"/>
+          <p:cNvSpPr>
+            <a:spLocks noGrp="1"/>
+          </p:cNvSpPr>
+          <p:nvPr>
+            <p:ph type="ftr" sz="quarter" idx="4"/>
+          </p:nvPr>
+        </p:nvSpPr>
+        <p:spPr>
+          <a:xfrm>
+            <a:off x="0" y="8685213"/>
+            <a:ext cx="2971800" cy="458787"/>
+          </a:xfrm>
+          <a:prstGeom prst="rect">
+            <a:avLst/>
+          </a:prstGeom>
+        </p:spPr>
+        <p:txBody>
+          <a:bodyPr vert="horz" lIns="91440" tIns="45720" rIns="91440" bIns="45720" rtlCol="0" anchor="b"/>
+          <a:lstStyle>
+            <a:lvl1pPr algn="l">
+              <a:defRPr sz="1200"/>
+            </a:lvl1pPr>
+          </a:lstStyle>
+          <a:p>
+            <a:endParaRPr lang="en-US"/>
+          </a:p>
+        </p:txBody>
+      </p:sp>
+      <p:sp>
+        <p:nvSpPr>
+          <p:cNvPr id="7" name="Slide Number Placeholder 6"/>
+          <p:cNvSpPr>
+            <a:spLocks noGrp="1"/>
+          </p:cNvSpPr>
+          <p:nvPr>
+            <p:ph type="sldNum" sz="quarter" idx="5"/>
+          </p:nvPr>
+        </p:nvSpPr>
+        <p:spPr>
+          <a:xfrm>
+            <a:off x="3884613" y="8685213"/>
+            <a:ext cx="2971800" cy="458787"/>
+          </a:xfrm>
+          <a:prstGeom prst="rect">
+            <a:avLst/>
+          </a:prstGeom>
+        </p:spPr>
+        <p:txBody>
+          <a:bodyPr vert="horz" lIns="91440" tIns="45720" rIns="91440" bIns="45720" rtlCol="0" anchor="b"/>
+          <a:lstStyle>
+            <a:lvl1pPr algn="r">
+              <a:defRPr sz="1200"/>
+            </a:lvl1pPr>
+          </a:lstStyle>
+          <a:p>
+            <a:fld id="{CE5E9CC1-C706-0F49-92D6-E571CC5EEA8F}" type="slidenum">
+              <a:rPr lang="en-US"/>
+              <a:t>‹#›</a:t>
+            </a:fld>
+            <a:endParaRPr lang="en-US"/>
+          </a:p>
+        </p:txBody>
+      </p:sp>
+    </p:spTree>
+    <p:extLst>
+      <p:ext uri="{BB962C8B-B14F-4D97-AF65-F5344CB8AC3E}">
+        <p14:creationId xmlns:p14="http://schemas.microsoft.com/office/powerpoint/2010/main" val="1024086991"/>
+      </p:ext>
+    </p:extLst>
+  </p:cSld>
+  <p:clrMap bg1="lt1" tx1="dk1" bg2="lt2" tx2="dk2" accent1="accent1" accent2="accent2" accent3="accent3" accent4="accent4" accent5="accent5" accent6="accent6" hlink="hlink" folHlink="folHlink"/>
+  <p:notesStyle>
+    <a:lvl1pPr marL="0" algn="l" defTabSz="914400" rtl="0" eaLnBrk="1" latinLnBrk="0" hangingPunct="1">
+      <a:defRPr sz="1200" kern="1200">
+        <a:solidFill>
+          <a:schemeClr val="tx1"/>
+        </a:solidFill>
+        <a:latin typeface="+mn-lt"/>
+        <a:ea typeface="+mn-ea"/>
+        <a:cs typeface="+mn-cs"/>
+      </a:defRPr>
+    </a:lvl1pPr>
+    <a:lvl2pPr marL="457200" algn="l" defTabSz="914400" rtl="0" eaLnBrk="1" latinLnBrk="0" hangingPunct="1">
+      <a:defRPr sz="1200" kern="1200">
+        <a:solidFill>
+          <a:schemeClr val="tx1"/>
+        </a:solidFill>
+        <a:latin typeface="+mn-lt"/>
+        <a:ea typeface="+mn-ea"/>
+        <a:cs typeface="+mn-cs"/>
+      </a:defRPr>
+    </a:lvl2pPr>
+    <a:lvl3pPr marL="914400" algn="l" defTabSz="914400" rtl="0" eaLnBrk="1" latinLnBrk="0" hangingPunct="1">
+      <a:defRPr sz="1200" kern="1200">
+        <a:solidFill>
+          <a:schemeClr val="tx1"/>
+        </a:solidFill>
+        <a:latin typeface="+mn-lt"/>
+        <a:ea typeface="+mn-ea"/>
+        <a:cs typeface="+mn-cs"/>
+      </a:defRPr>
+    </a:lvl3pPr>
+    <a:lvl4pPr marL="1371600" algn="l" defTabSz="914400" rtl="0" eaLnBrk="1" latinLnBrk="0" hangingPunct="1">
+      <a:defRPr sz="1200" kern="1200">
+        <a:solidFill>
+          <a:schemeClr val="tx1"/>
+        </a:solidFill>
+        <a:latin typeface="+mn-lt"/>
+        <a:ea typeface="+mn-ea"/>
+        <a:cs typeface="+mn-cs"/>
+      </a:defRPr>
+    </a:lvl4pPr>
+    <a:lvl5pPr marL="1828800" algn="l" defTabSz="914400" rtl="0" eaLnBrk="1" latinLnBrk="0" hangingPunct="1">
+      <a:defRPr sz="1200" kern="1200">
+        <a:solidFill>
+          <a:schemeClr val="tx1"/>
+        </a:solidFill>
+        <a:latin typeface="+mn-lt"/>
+        <a:ea typeface="+mn-ea"/>
+        <a:cs typeface="+mn-cs"/>
+      </a:defRPr>
+    </a:lvl5pPr>
+    <a:lvl6pPr marL="2286000" algn="l" defTabSz="914400" rtl="0" eaLnBrk="1" latinLnBrk="0" hangingPunct="1">
+      <a:defRPr sz="1200" kern="1200">
+        <a:solidFill>
+          <a:schemeClr val="tx1"/>
+        </a:solidFill>
+        <a:latin typeface="+mn-lt"/>
+        <a:ea typeface="+mn-ea"/>
+        <a:cs typeface="+mn-cs"/>
+      </a:defRPr>
+    </a:lvl6pPr>
+    <a:lvl7pPr marL="2743200" algn="l" defTabSz="914400" rtl="0" eaLnBrk="1" latinLnBrk="0" hangingPunct="1">
+      <a:defRPr sz="1200" kern="1200">
+        <a:solidFill>
+          <a:schemeClr val="tx1"/>
+        </a:solidFill>
+        <a:latin typeface="+mn-lt"/>
+        <a:ea typeface="+mn-ea"/>
+        <a:cs typeface="+mn-cs"/>
+      </a:defRPr>
+    </a:lvl7pPr>
+    <a:lvl8pPr marL="3200400" algn="l" defTabSz="914400" rtl="0" eaLnBrk="1" latinLnBrk="0" hangingPunct="1">
+      <a:defRPr sz="1200" kern="1200">
+        <a:solidFill>
+          <a:schemeClr val="tx1"/>
+        </a:solidFill>
+        <a:latin typeface="+mn-lt"/>
+        <a:ea typeface="+mn-ea"/>
+        <a:cs typeface="+mn-cs"/>
+      </a:defRPr>
+    </a:lvl8pPr>
+    <a:lvl9pPr marL="3657600" algn="l" defTabSz="914400" rtl="0" eaLnBrk="1" latinLnBrk="0" hangingPunct="1">
+      <a:defRPr sz="1200" kern="1200">
+        <a:solidFill>
+          <a:schemeClr val="tx1"/>
+        </a:solidFill>
+        <a:latin typeface="+mn-lt"/>
+        <a:ea typeface="+mn-ea"/>
+        <a:cs typeface="+mn-cs"/>
+      </a:defRPr>
+    </a:lvl9pPr>
+  </p:notesStyle>
+</p:notesMaster>
+</file>
+
+<file path=ppt/notesSlides/notesSlide1.xml><?xml version="1.0" encoding="utf-8"?>
+<p:notes xmlns:a="http://schemas.openxmlformats.org/drawingml/2006/main" xmlns:r="http://schemas.openxmlformats.org/officeDocument/2006/relationships" xmlns:p="http://schemas.openxmlformats.org/presentationml/2006/main">
+  <p:cSld>
+    <p:spTree>
+      <p:nvGrpSpPr>
+        <p:cNvPr id="1" name=""/>
+        <p:cNvGrpSpPr/>
+        <p:nvPr/>
+      </p:nvGrpSpPr>
+      <p:grpSpPr>
+        <a:xfrm>
+          <a:off x="0" y="0"/>
+          <a:ext cx="0" cy="0"/>
+          <a:chOff x="0" y="0"/>
+          <a:chExt cx="0" cy="0"/>
+        </a:xfrm>
+      </p:grpSpPr>
+      <p:sp>
+        <p:nvSpPr>
+          <p:cNvPr id="2" name="Slide Image Placeholder 1"/>
+          <p:cNvSpPr>
+            <a:spLocks noGrp="1" noRot="1" noChangeAspect="1"/>
+          </p:cNvSpPr>
+          <p:nvPr>
+            <p:ph type="sldImg"/>
+          </p:nvPr>
+        </p:nvSpPr>
+        <p:spPr/>
+      </p:sp>
+      <p:sp>
+        <p:nvSpPr>
+          <p:cNvPr id="3" name="Notes Placeholder 2"/>
+          <p:cNvSpPr>
+            <a:spLocks noGrp="1"/>
+          </p:cNvSpPr>
+          <p:nvPr>
+            <p:ph type="body" idx="1"/>
+          </p:nvPr>
+        </p:nvSpPr>
+        <p:spPr/>
+        <p:txBody>
+          <a:bodyPr/>
+          <a:lstStyle/>
+          <a:p>
+            <a:r>
+              <a:rPr lang="en-US" dirty="0"/>
+              <a:t>Abertura: apresentar a proposta de esteira AI-native SDLC para plataforma mobile. Baseada no playbook da Anthropic, adaptada para GitHub Copilot Enterprise + React Native multi-bundle.</a:t>
+            </a:r>
+            <a:endParaRPr lang="en-US" dirty="0"/>
+          </a:p>
+        </p:txBody>
+      </p:sp>
+      <p:sp>
+        <p:nvSpPr>
+          <p:cNvPr id="4" name="Slide Number Placeholder 3"/>
+          <p:cNvSpPr>
+            <a:spLocks noGrp="1"/>
+          </p:cNvSpPr>
+          <p:nvPr>
+            <p:ph type="sldNum" sz="quarter" idx="10"/>
+          </p:nvPr>
+        </p:nvSpPr>
+        <p:spPr/>
+        <p:txBody>
+          <a:bodyPr/>
+          <a:lstStyle/>
+          <a:p>
+            <a:fld id="{F7021451-1387-4CA6-816F-3879F97B5CBC}" type="slidenum">
+              <a:rPr lang="en-US"/>
+              <a:t>1</a:t>
+            </a:fld>
+            <a:endParaRPr lang="en-US"/>
+          </a:p>
+        </p:txBody>
+      </p:sp>
+    </p:spTree>
+    <p:extLst>
+      <p:ext uri="{BB962C8B-B14F-4D97-AF65-F5344CB8AC3E}">
+        <p14:creationId xmlns:p14="http://schemas.microsoft.com/office/powerpoint/2010/main" val="1024086991"/>
+      </p:ext>
+    </p:extLst>
+  </p:cSld>
+  <p:clrMapOvr>
+    <a:masterClrMapping/>
+  </p:clrMapOvr>
+</p:notes>
+</file>
+
+<file path=ppt/notesSlides/notesSlide10.xml><?xml version="1.0" encoding="utf-8"?>
+<p:notes xmlns:a="http://schemas.openxmlformats.org/drawingml/2006/main" xmlns:r="http://schemas.openxmlformats.org/officeDocument/2006/relationships" xmlns:p="http://schemas.openxmlformats.org/presentationml/2006/main">
+  <p:cSld>
+    <p:spTree>
+      <p:nvGrpSpPr>
+        <p:cNvPr id="1" name=""/>
+        <p:cNvGrpSpPr/>
+        <p:nvPr/>
+      </p:nvGrpSpPr>
+      <p:grpSpPr>
+        <a:xfrm>
+          <a:off x="0" y="0"/>
+          <a:ext cx="0" cy="0"/>
+          <a:chOff x="0" y="0"/>
+          <a:chExt cx="0" cy="0"/>
+        </a:xfrm>
+      </p:grpSpPr>
+      <p:sp>
+        <p:nvSpPr>
+          <p:cNvPr id="2" name="Slide Image Placeholder 1"/>
+          <p:cNvSpPr>
+            <a:spLocks noGrp="1" noRot="1" noChangeAspect="1"/>
+          </p:cNvSpPr>
+          <p:nvPr>
+            <p:ph type="sldImg"/>
+          </p:nvPr>
+        </p:nvSpPr>
+        <p:spPr/>
+      </p:sp>
+      <p:sp>
+        <p:nvSpPr>
+          <p:cNvPr id="3" name="Notes Placeholder 2"/>
+          <p:cNvSpPr>
+            <a:spLocks noGrp="1"/>
+          </p:cNvSpPr>
+          <p:nvPr>
+            <p:ph type="body" idx="1"/>
+          </p:nvPr>
+        </p:nvSpPr>
+        <p:spPr/>
+        <p:txBody>
+          <a:bodyPr/>
+          <a:lstStyle/>
+          <a:p>
+            <a:r>
+              <a:rPr lang="en-US" dirty="0"/>
+              <a:t>ADR-012 (novo): a documentação de plataforma existente está desatualizada e incompleta. A Fase 0 começa com 3 sub-etapas: inventário (0-A), validação com SMEs (0-B), e definição de dono + processo de manutenção por domínio (0-C). Skills sem fonte de verdade validada não entram em produção. Dois bloqueadores: ADR-009 (distribuição) e ADR-012 (qualidade do conteúdo).</a:t>
+            </a:r>
+            <a:endParaRPr lang="en-US" dirty="0"/>
+          </a:p>
+        </p:txBody>
+      </p:sp>
+      <p:sp>
+        <p:nvSpPr>
+          <p:cNvPr id="4" name="Slide Number Placeholder 3"/>
+          <p:cNvSpPr>
+            <a:spLocks noGrp="1"/>
+          </p:cNvSpPr>
+          <p:nvPr>
+            <p:ph type="sldNum" sz="quarter" idx="10"/>
+          </p:nvPr>
+        </p:nvSpPr>
+        <p:spPr/>
+        <p:txBody>
+          <a:bodyPr/>
+          <a:lstStyle/>
+          <a:p>
+            <a:fld id="{F7021451-1387-4CA6-816F-3879F97B5CBC}" type="slidenum">
+              <a:rPr lang="en-US"/>
+              <a:t>10</a:t>
+            </a:fld>
+            <a:endParaRPr lang="en-US"/>
+          </a:p>
+        </p:txBody>
+      </p:sp>
+    </p:spTree>
+    <p:extLst>
+      <p:ext uri="{BB962C8B-B14F-4D97-AF65-F5344CB8AC3E}">
+        <p14:creationId xmlns:p14="http://schemas.microsoft.com/office/powerpoint/2010/main" val="1024086991"/>
+      </p:ext>
+    </p:extLst>
+  </p:cSld>
+  <p:clrMapOvr>
+    <a:masterClrMapping/>
+  </p:clrMapOvr>
+</p:notes>
+</file>
+
+<file path=ppt/notesSlides/notesSlide11.xml><?xml version="1.0" encoding="utf-8"?>
+<p:notes xmlns:a="http://schemas.openxmlformats.org/drawingml/2006/main" xmlns:r="http://schemas.openxmlformats.org/officeDocument/2006/relationships" xmlns:p="http://schemas.openxmlformats.org/presentationml/2006/main">
+  <p:cSld>
+    <p:spTree>
+      <p:nvGrpSpPr>
+        <p:cNvPr id="1" name=""/>
+        <p:cNvGrpSpPr/>
+        <p:nvPr/>
+      </p:nvGrpSpPr>
+      <p:grpSpPr>
+        <a:xfrm>
+          <a:off x="0" y="0"/>
+          <a:ext cx="0" cy="0"/>
+          <a:chOff x="0" y="0"/>
+          <a:chExt cx="0" cy="0"/>
+        </a:xfrm>
+      </p:grpSpPr>
+      <p:sp>
+        <p:nvSpPr>
+          <p:cNvPr id="2" name="Slide Image Placeholder 1"/>
+          <p:cNvSpPr>
+            <a:spLocks noGrp="1" noRot="1" noChangeAspect="1"/>
+          </p:cNvSpPr>
+          <p:nvPr>
+            <p:ph type="sldImg"/>
+          </p:nvPr>
+        </p:nvSpPr>
+        <p:spPr/>
+      </p:sp>
+      <p:sp>
+        <p:nvSpPr>
+          <p:cNvPr id="3" name="Notes Placeholder 2"/>
+          <p:cNvSpPr>
+            <a:spLocks noGrp="1"/>
+          </p:cNvSpPr>
+          <p:nvPr>
+            <p:ph type="body" idx="1"/>
+          </p:nvPr>
+        </p:nvSpPr>
+        <p:spPr/>
+        <p:txBody>
+          <a:bodyPr/>
+          <a:lstStyle/>
+          <a:p>
+            <a:r>
+              <a:rPr lang="en-US" dirty="0"/>
+              <a:t>Princípio central: nenhum agente aprova seu próprio output. Gates calibrados ao risco. A esteira começa conservadora e pode relaxar gates à medida que evals comprovam confiabilidade.</a:t>
+            </a:r>
+            <a:endParaRPr lang="en-US" dirty="0"/>
+          </a:p>
+        </p:txBody>
+      </p:sp>
+      <p:sp>
+        <p:nvSpPr>
+          <p:cNvPr id="4" name="Slide Number Placeholder 3"/>
+          <p:cNvSpPr>
+            <a:spLocks noGrp="1"/>
+          </p:cNvSpPr>
+          <p:nvPr>
+            <p:ph type="sldNum" sz="quarter" idx="10"/>
+          </p:nvPr>
+        </p:nvSpPr>
+        <p:spPr/>
+        <p:txBody>
+          <a:bodyPr/>
+          <a:lstStyle/>
+          <a:p>
+            <a:fld id="{F7021451-1387-4CA6-816F-3879F97B5CBC}" type="slidenum">
+              <a:rPr lang="en-US"/>
+              <a:t>11</a:t>
+            </a:fld>
+            <a:endParaRPr lang="en-US"/>
+          </a:p>
+        </p:txBody>
+      </p:sp>
+    </p:spTree>
+    <p:extLst>
+      <p:ext uri="{BB962C8B-B14F-4D97-AF65-F5344CB8AC3E}">
+        <p14:creationId xmlns:p14="http://schemas.microsoft.com/office/powerpoint/2010/main" val="1024086991"/>
+      </p:ext>
+    </p:extLst>
+  </p:cSld>
+  <p:clrMapOvr>
+    <a:masterClrMapping/>
+  </p:clrMapOvr>
+</p:notes>
+</file>
+
+<file path=ppt/notesSlides/notesSlide12.xml><?xml version="1.0" encoding="utf-8"?>
+<p:notes xmlns:a="http://schemas.openxmlformats.org/drawingml/2006/main" xmlns:r="http://schemas.openxmlformats.org/officeDocument/2006/relationships" xmlns:p="http://schemas.openxmlformats.org/presentationml/2006/main">
+  <p:cSld>
+    <p:spTree>
+      <p:nvGrpSpPr>
+        <p:cNvPr id="1" name=""/>
+        <p:cNvGrpSpPr/>
+        <p:nvPr/>
+      </p:nvGrpSpPr>
+      <p:grpSpPr>
+        <a:xfrm>
+          <a:off x="0" y="0"/>
+          <a:ext cx="0" cy="0"/>
+          <a:chOff x="0" y="0"/>
+          <a:chExt cx="0" cy="0"/>
+        </a:xfrm>
+      </p:grpSpPr>
+      <p:sp>
+        <p:nvSpPr>
+          <p:cNvPr id="2" name="Slide Image Placeholder 1"/>
+          <p:cNvSpPr>
+            <a:spLocks noGrp="1" noRot="1" noChangeAspect="1"/>
+          </p:cNvSpPr>
+          <p:nvPr>
+            <p:ph type="sldImg"/>
+          </p:nvPr>
+        </p:nvSpPr>
+        <p:spPr/>
+      </p:sp>
+      <p:sp>
+        <p:nvSpPr>
+          <p:cNvPr id="3" name="Notes Placeholder 2"/>
+          <p:cNvSpPr>
+            <a:spLocks noGrp="1"/>
+          </p:cNvSpPr>
+          <p:nvPr>
+            <p:ph type="body" idx="1"/>
+          </p:nvPr>
+        </p:nvSpPr>
+        <p:spPr/>
+        <p:txBody>
+          <a:bodyPr/>
+          <a:lstStyle/>
+          <a:p>
+            <a:r>
+              <a:rPr lang="en-US" dirty="0"/>
+              <a:t>ADR-011: O api-contract.md é o handoff formal com backend. O adapter pattern garante zero acoplamento — troca de mock para real é mudança em um arquivo. Feature flag no deploy garante que mock nunca vai a produção exposto.</a:t>
+            </a:r>
+            <a:endParaRPr lang="en-US" dirty="0"/>
+          </a:p>
+        </p:txBody>
+      </p:sp>
+      <p:sp>
+        <p:nvSpPr>
+          <p:cNvPr id="4" name="Slide Number Placeholder 3"/>
+          <p:cNvSpPr>
+            <a:spLocks noGrp="1"/>
+          </p:cNvSpPr>
+          <p:nvPr>
+            <p:ph type="sldNum" sz="quarter" idx="10"/>
+          </p:nvPr>
+        </p:nvSpPr>
+        <p:spPr/>
+        <p:txBody>
+          <a:bodyPr/>
+          <a:lstStyle/>
+          <a:p>
+            <a:fld id="{F7021451-1387-4CA6-816F-3879F97B5CBC}" type="slidenum">
+              <a:rPr lang="en-US"/>
+              <a:t>12</a:t>
+            </a:fld>
+            <a:endParaRPr lang="en-US"/>
+          </a:p>
+        </p:txBody>
+      </p:sp>
+    </p:spTree>
+    <p:extLst>
+      <p:ext uri="{BB962C8B-B14F-4D97-AF65-F5344CB8AC3E}">
+        <p14:creationId xmlns:p14="http://schemas.microsoft.com/office/powerpoint/2010/main" val="1024086991"/>
+      </p:ext>
+    </p:extLst>
+  </p:cSld>
+  <p:clrMapOvr>
+    <a:masterClrMapping/>
+  </p:clrMapOvr>
+</p:notes>
+</file>
+
+<file path=ppt/notesSlides/notesSlide13.xml><?xml version="1.0" encoding="utf-8"?>
+<p:notes xmlns:a="http://schemas.openxmlformats.org/drawingml/2006/main" xmlns:r="http://schemas.openxmlformats.org/officeDocument/2006/relationships" xmlns:p="http://schemas.openxmlformats.org/presentationml/2006/main">
+  <p:cSld>
+    <p:spTree>
+      <p:nvGrpSpPr>
+        <p:cNvPr id="1" name=""/>
+        <p:cNvGrpSpPr/>
+        <p:nvPr/>
+      </p:nvGrpSpPr>
+      <p:grpSpPr>
+        <a:xfrm>
+          <a:off x="0" y="0"/>
+          <a:ext cx="0" cy="0"/>
+          <a:chOff x="0" y="0"/>
+          <a:chExt cx="0" cy="0"/>
+        </a:xfrm>
+      </p:grpSpPr>
+      <p:sp>
+        <p:nvSpPr>
+          <p:cNvPr id="2" name="Slide Image Placeholder 1"/>
+          <p:cNvSpPr>
+            <a:spLocks noGrp="1" noRot="1" noChangeAspect="1"/>
+          </p:cNvSpPr>
+          <p:nvPr>
+            <p:ph type="sldImg"/>
+          </p:nvPr>
+        </p:nvSpPr>
+        <p:spPr/>
+      </p:sp>
+      <p:sp>
+        <p:nvSpPr>
+          <p:cNvPr id="3" name="Notes Placeholder 2"/>
+          <p:cNvSpPr>
+            <a:spLocks noGrp="1"/>
+          </p:cNvSpPr>
+          <p:nvPr>
+            <p:ph type="body" idx="1"/>
+          </p:nvPr>
+        </p:nvSpPr>
+        <p:spPr/>
+        <p:txBody>
+          <a:bodyPr/>
+          <a:lstStyle/>
+          <a:p>
+            <a:r>
+              <a:rPr lang="en-US" dirty="0"/>
+              <a:t>Evals são testes para agentes. Cada mudança em skill ou instrução dispara CI. Pass rate de 85% é o gate — abaixo disso, o merge é bloqueado. Incidentes de produção viram evals permanentes: "não pode acontecer de novo" tem implementação concreta.</a:t>
+            </a:r>
+            <a:endParaRPr lang="en-US" dirty="0"/>
+          </a:p>
+        </p:txBody>
+      </p:sp>
+      <p:sp>
+        <p:nvSpPr>
+          <p:cNvPr id="4" name="Slide Number Placeholder 3"/>
+          <p:cNvSpPr>
+            <a:spLocks noGrp="1"/>
+          </p:cNvSpPr>
+          <p:nvPr>
+            <p:ph type="sldNum" sz="quarter" idx="10"/>
+          </p:nvPr>
+        </p:nvSpPr>
+        <p:spPr/>
+        <p:txBody>
+          <a:bodyPr/>
+          <a:lstStyle/>
+          <a:p>
+            <a:fld id="{F7021451-1387-4CA6-816F-3879F97B5CBC}" type="slidenum">
+              <a:rPr lang="en-US"/>
+              <a:t>13</a:t>
+            </a:fld>
+            <a:endParaRPr lang="en-US"/>
+          </a:p>
+        </p:txBody>
+      </p:sp>
+    </p:spTree>
+    <p:extLst>
+      <p:ext uri="{BB962C8B-B14F-4D97-AF65-F5344CB8AC3E}">
+        <p14:creationId xmlns:p14="http://schemas.microsoft.com/office/powerpoint/2010/main" val="1024086991"/>
+      </p:ext>
+    </p:extLst>
+  </p:cSld>
+  <p:clrMapOvr>
+    <a:masterClrMapping/>
+  </p:clrMapOvr>
+</p:notes>
+</file>
+
+<file path=ppt/notesSlides/notesSlide14.xml><?xml version="1.0" encoding="utf-8"?>
+<p:notes xmlns:a="http://schemas.openxmlformats.org/drawingml/2006/main" xmlns:r="http://schemas.openxmlformats.org/officeDocument/2006/relationships" xmlns:p="http://schemas.openxmlformats.org/presentationml/2006/main">
+  <p:cSld>
+    <p:spTree>
+      <p:nvGrpSpPr>
+        <p:cNvPr id="1" name=""/>
+        <p:cNvGrpSpPr/>
+        <p:nvPr/>
+      </p:nvGrpSpPr>
+      <p:grpSpPr>
+        <a:xfrm>
+          <a:off x="0" y="0"/>
+          <a:ext cx="0" cy="0"/>
+          <a:chOff x="0" y="0"/>
+          <a:chExt cx="0" cy="0"/>
+        </a:xfrm>
+      </p:grpSpPr>
+      <p:sp>
+        <p:nvSpPr>
+          <p:cNvPr id="2" name="Slide Image Placeholder 1"/>
+          <p:cNvSpPr>
+            <a:spLocks noGrp="1" noRot="1" noChangeAspect="1"/>
+          </p:cNvSpPr>
+          <p:nvPr>
+            <p:ph type="sldImg"/>
+          </p:nvPr>
+        </p:nvSpPr>
+        <p:spPr/>
+      </p:sp>
+      <p:sp>
+        <p:nvSpPr>
+          <p:cNvPr id="3" name="Notes Placeholder 2"/>
+          <p:cNvSpPr>
+            <a:spLocks noGrp="1"/>
+          </p:cNvSpPr>
+          <p:nvPr>
+            <p:ph type="body" idx="1"/>
+          </p:nvPr>
+        </p:nvSpPr>
+        <p:spPr/>
+        <p:txBody>
+          <a:bodyPr/>
+          <a:lstStyle/>
+          <a:p>
+            <a:r>
+              <a:rPr lang="en-US" dirty="0"/>
+              <a:t>Agente 07 fecha o loop. Correlação determinística ANTES do Copilot analisar — prevenção de hallucination. Cada branch da árvore é testável em evals. Output sempre: GitHub Issue + PR com intent.md.</a:t>
+            </a:r>
+            <a:endParaRPr lang="en-US" dirty="0"/>
+          </a:p>
+        </p:txBody>
+      </p:sp>
+      <p:sp>
+        <p:nvSpPr>
+          <p:cNvPr id="4" name="Slide Number Placeholder 3"/>
+          <p:cNvSpPr>
+            <a:spLocks noGrp="1"/>
+          </p:cNvSpPr>
+          <p:nvPr>
+            <p:ph type="sldNum" sz="quarter" idx="10"/>
+          </p:nvPr>
+        </p:nvSpPr>
+        <p:spPr/>
+        <p:txBody>
+          <a:bodyPr/>
+          <a:lstStyle/>
+          <a:p>
+            <a:fld id="{F7021451-1387-4CA6-816F-3879F97B5CBC}" type="slidenum">
+              <a:rPr lang="en-US"/>
+              <a:t>14</a:t>
+            </a:fld>
+            <a:endParaRPr lang="en-US"/>
+          </a:p>
+        </p:txBody>
+      </p:sp>
+    </p:spTree>
+    <p:extLst>
+      <p:ext uri="{BB962C8B-B14F-4D97-AF65-F5344CB8AC3E}">
+        <p14:creationId xmlns:p14="http://schemas.microsoft.com/office/powerpoint/2010/main" val="1024086991"/>
+      </p:ext>
+    </p:extLst>
+  </p:cSld>
+  <p:clrMapOvr>
+    <a:masterClrMapping/>
+  </p:clrMapOvr>
+</p:notes>
+</file>
+
+<file path=ppt/notesSlides/notesSlide15.xml><?xml version="1.0" encoding="utf-8"?>
+<p:notes xmlns:a="http://schemas.openxmlformats.org/drawingml/2006/main" xmlns:r="http://schemas.openxmlformats.org/officeDocument/2006/relationships" xmlns:p="http://schemas.openxmlformats.org/presentationml/2006/main">
+  <p:cSld>
+    <p:spTree>
+      <p:nvGrpSpPr>
+        <p:cNvPr id="1" name=""/>
+        <p:cNvGrpSpPr/>
+        <p:nvPr/>
+      </p:nvGrpSpPr>
+      <p:grpSpPr>
+        <a:xfrm>
+          <a:off x="0" y="0"/>
+          <a:ext cx="0" cy="0"/>
+          <a:chOff x="0" y="0"/>
+          <a:chExt cx="0" cy="0"/>
+        </a:xfrm>
+      </p:grpSpPr>
+      <p:sp>
+        <p:nvSpPr>
+          <p:cNvPr id="2" name="Slide Image Placeholder 1"/>
+          <p:cNvSpPr>
+            <a:spLocks noGrp="1" noRot="1" noChangeAspect="1"/>
+          </p:cNvSpPr>
+          <p:nvPr>
+            <p:ph type="sldImg"/>
+          </p:nvPr>
+        </p:nvSpPr>
+        <p:spPr/>
+      </p:sp>
+      <p:sp>
+        <p:nvSpPr>
+          <p:cNvPr id="3" name="Notes Placeholder 2"/>
+          <p:cNvSpPr>
+            <a:spLocks noGrp="1"/>
+          </p:cNvSpPr>
+          <p:nvPr>
+            <p:ph type="body" idx="1"/>
+          </p:nvPr>
+        </p:nvSpPr>
+        <p:spPr/>
+        <p:txBody>
+          <a:bodyPr/>
+          <a:lstStyle/>
+          <a:p>
+            <a:r>
+              <a:rPr lang="en-US" dirty="0"/>
+              <a:t>Resumo: 6 decisões tomadas, 1 em aberto que bloqueia Fase 0. Próximo passo: definir a arquitetura de distribuição de conhecimento com plataforma, arquitetura e segurança. Sem isso, a Fase 0 não entra em produção.</a:t>
+            </a:r>
+            <a:endParaRPr lang="en-US" dirty="0"/>
+          </a:p>
+        </p:txBody>
+      </p:sp>
+      <p:sp>
+        <p:nvSpPr>
+          <p:cNvPr id="4" name="Slide Number Placeholder 3"/>
+          <p:cNvSpPr>
+            <a:spLocks noGrp="1"/>
+          </p:cNvSpPr>
+          <p:nvPr>
+            <p:ph type="sldNum" sz="quarter" idx="10"/>
+          </p:nvPr>
+        </p:nvSpPr>
+        <p:spPr/>
+        <p:txBody>
+          <a:bodyPr/>
+          <a:lstStyle/>
+          <a:p>
+            <a:fld id="{F7021451-1387-4CA6-816F-3879F97B5CBC}" type="slidenum">
+              <a:rPr lang="en-US"/>
+              <a:t>15</a:t>
+            </a:fld>
+            <a:endParaRPr lang="en-US"/>
+          </a:p>
+        </p:txBody>
+      </p:sp>
+    </p:spTree>
+    <p:extLst>
+      <p:ext uri="{BB962C8B-B14F-4D97-AF65-F5344CB8AC3E}">
+        <p14:creationId xmlns:p14="http://schemas.microsoft.com/office/powerpoint/2010/main" val="1024086991"/>
+      </p:ext>
+    </p:extLst>
+  </p:cSld>
+  <p:clrMapOvr>
+    <a:masterClrMapping/>
+  </p:clrMapOvr>
+</p:notes>
+</file>
+
+<file path=ppt/notesSlides/notesSlide2.xml><?xml version="1.0" encoding="utf-8"?>
+<p:notes xmlns:a="http://schemas.openxmlformats.org/drawingml/2006/main" xmlns:r="http://schemas.openxmlformats.org/officeDocument/2006/relationships" xmlns:p="http://schemas.openxmlformats.org/presentationml/2006/main">
+  <p:cSld>
+    <p:spTree>
+      <p:nvGrpSpPr>
+        <p:cNvPr id="1" name=""/>
+        <p:cNvGrpSpPr/>
+        <p:nvPr/>
+      </p:nvGrpSpPr>
+      <p:grpSpPr>
+        <a:xfrm>
+          <a:off x="0" y="0"/>
+          <a:ext cx="0" cy="0"/>
+          <a:chOff x="0" y="0"/>
+          <a:chExt cx="0" cy="0"/>
+        </a:xfrm>
+      </p:grpSpPr>
+      <p:sp>
+        <p:nvSpPr>
+          <p:cNvPr id="2" name="Slide Image Placeholder 1"/>
+          <p:cNvSpPr>
+            <a:spLocks noGrp="1" noRot="1" noChangeAspect="1"/>
+          </p:cNvSpPr>
+          <p:nvPr>
+            <p:ph type="sldImg"/>
+          </p:nvPr>
+        </p:nvSpPr>
+        <p:spPr/>
+      </p:sp>
+      <p:sp>
+        <p:nvSpPr>
+          <p:cNvPr id="3" name="Notes Placeholder 2"/>
+          <p:cNvSpPr>
+            <a:spLocks noGrp="1"/>
+          </p:cNvSpPr>
+          <p:nvPr>
+            <p:ph type="body" idx="1"/>
+          </p:nvPr>
+        </p:nvSpPr>
+        <p:spPr/>
+        <p:txBody>
+          <a:bodyPr/>
+          <a:lstStyle/>
+          <a:p>
+            <a:r>
+              <a:rPr lang="en-US" dirty="0"/>
+              <a:t>Mensagem central: o Copilot já está contratado, mas uso individual não escala. Precisamos de uma estrutura organizacional — artefatos, contexto, gates, métricas — para converter adoção em vantagem competitiva.</a:t>
+            </a:r>
+            <a:endParaRPr lang="en-US" dirty="0"/>
+          </a:p>
+        </p:txBody>
+      </p:sp>
+      <p:sp>
+        <p:nvSpPr>
+          <p:cNvPr id="4" name="Slide Number Placeholder 3"/>
+          <p:cNvSpPr>
+            <a:spLocks noGrp="1"/>
+          </p:cNvSpPr>
+          <p:nvPr>
+            <p:ph type="sldNum" sz="quarter" idx="10"/>
+          </p:nvPr>
+        </p:nvSpPr>
+        <p:spPr/>
+        <p:txBody>
+          <a:bodyPr/>
+          <a:lstStyle/>
+          <a:p>
+            <a:fld id="{F7021451-1387-4CA6-816F-3879F97B5CBC}" type="slidenum">
+              <a:rPr lang="en-US"/>
+              <a:t>2</a:t>
+            </a:fld>
+            <a:endParaRPr lang="en-US"/>
+          </a:p>
+        </p:txBody>
+      </p:sp>
+    </p:spTree>
+    <p:extLst>
+      <p:ext uri="{BB962C8B-B14F-4D97-AF65-F5344CB8AC3E}">
+        <p14:creationId xmlns:p14="http://schemas.microsoft.com/office/powerpoint/2010/main" val="1024086991"/>
+      </p:ext>
+    </p:extLst>
+  </p:cSld>
+  <p:clrMapOvr>
+    <a:masterClrMapping/>
+  </p:clrMapOvr>
+</p:notes>
+</file>
+
+<file path=ppt/notesSlides/notesSlide3.xml><?xml version="1.0" encoding="utf-8"?>
+<p:notes xmlns:a="http://schemas.openxmlformats.org/drawingml/2006/main" xmlns:r="http://schemas.openxmlformats.org/officeDocument/2006/relationships" xmlns:p="http://schemas.openxmlformats.org/presentationml/2006/main">
+  <p:cSld>
+    <p:spTree>
+      <p:nvGrpSpPr>
+        <p:cNvPr id="1" name=""/>
+        <p:cNvGrpSpPr/>
+        <p:nvPr/>
+      </p:nvGrpSpPr>
+      <p:grpSpPr>
+        <a:xfrm>
+          <a:off x="0" y="0"/>
+          <a:ext cx="0" cy="0"/>
+          <a:chOff x="0" y="0"/>
+          <a:chExt cx="0" cy="0"/>
+        </a:xfrm>
+      </p:grpSpPr>
+      <p:sp>
+        <p:nvSpPr>
+          <p:cNvPr id="2" name="Slide Image Placeholder 1"/>
+          <p:cNvSpPr>
+            <a:spLocks noGrp="1" noRot="1" noChangeAspect="1"/>
+          </p:cNvSpPr>
+          <p:nvPr>
+            <p:ph type="sldImg"/>
+          </p:nvPr>
+        </p:nvSpPr>
+        <p:spPr/>
+      </p:sp>
+      <p:sp>
+        <p:nvSpPr>
+          <p:cNvPr id="3" name="Notes Placeholder 2"/>
+          <p:cNvSpPr>
+            <a:spLocks noGrp="1"/>
+          </p:cNvSpPr>
+          <p:nvPr>
+            <p:ph type="body" idx="1"/>
+          </p:nvPr>
+        </p:nvSpPr>
+        <p:spPr/>
+        <p:txBody>
+          <a:bodyPr/>
+          <a:lstStyle/>
+          <a:p>
+            <a:r>
+              <a:rPr lang="en-US" dirty="0"/>
+              <a:t>A proposta em uma frase. Enfatizar: usamos o runtime que já existe (Copilot Enterprise), sem nova ferramenta. Artefatos Markdown em git = rastreáveis, diff-áveis, auditáveis.</a:t>
+            </a:r>
+            <a:endParaRPr lang="en-US" dirty="0"/>
+          </a:p>
+        </p:txBody>
+      </p:sp>
+      <p:sp>
+        <p:nvSpPr>
+          <p:cNvPr id="4" name="Slide Number Placeholder 3"/>
+          <p:cNvSpPr>
+            <a:spLocks noGrp="1"/>
+          </p:cNvSpPr>
+          <p:nvPr>
+            <p:ph type="sldNum" sz="quarter" idx="10"/>
+          </p:nvPr>
+        </p:nvSpPr>
+        <p:spPr/>
+        <p:txBody>
+          <a:bodyPr/>
+          <a:lstStyle/>
+          <a:p>
+            <a:fld id="{F7021451-1387-4CA6-816F-3879F97B5CBC}" type="slidenum">
+              <a:rPr lang="en-US"/>
+              <a:t>3</a:t>
+            </a:fld>
+            <a:endParaRPr lang="en-US"/>
+          </a:p>
+        </p:txBody>
+      </p:sp>
+    </p:spTree>
+    <p:extLst>
+      <p:ext uri="{BB962C8B-B14F-4D97-AF65-F5344CB8AC3E}">
+        <p14:creationId xmlns:p14="http://schemas.microsoft.com/office/powerpoint/2010/main" val="1024086991"/>
+      </p:ext>
+    </p:extLst>
+  </p:cSld>
+  <p:clrMapOvr>
+    <a:masterClrMapping/>
+  </p:clrMapOvr>
+</p:notes>
+</file>
+
+<file path=ppt/notesSlides/notesSlide4.xml><?xml version="1.0" encoding="utf-8"?>
+<p:notes xmlns:a="http://schemas.openxmlformats.org/drawingml/2006/main" xmlns:r="http://schemas.openxmlformats.org/officeDocument/2006/relationships" xmlns:p="http://schemas.openxmlformats.org/presentationml/2006/main">
+  <p:cSld>
+    <p:spTree>
+      <p:nvGrpSpPr>
+        <p:cNvPr id="1" name=""/>
+        <p:cNvGrpSpPr/>
+        <p:nvPr/>
+      </p:nvGrpSpPr>
+      <p:grpSpPr>
+        <a:xfrm>
+          <a:off x="0" y="0"/>
+          <a:ext cx="0" cy="0"/>
+          <a:chOff x="0" y="0"/>
+          <a:chExt cx="0" cy="0"/>
+        </a:xfrm>
+      </p:grpSpPr>
+      <p:sp>
+        <p:nvSpPr>
+          <p:cNvPr id="2" name="Slide Image Placeholder 1"/>
+          <p:cNvSpPr>
+            <a:spLocks noGrp="1" noRot="1" noChangeAspect="1"/>
+          </p:cNvSpPr>
+          <p:nvPr>
+            <p:ph type="sldImg"/>
+          </p:nvPr>
+        </p:nvSpPr>
+        <p:spPr/>
+      </p:sp>
+      <p:sp>
+        <p:nvSpPr>
+          <p:cNvPr id="3" name="Notes Placeholder 2"/>
+          <p:cNvSpPr>
+            <a:spLocks noGrp="1"/>
+          </p:cNvSpPr>
+          <p:nvPr>
+            <p:ph type="body" idx="1"/>
+          </p:nvPr>
+        </p:nvSpPr>
+        <p:spPr/>
+        <p:txBody>
+          <a:bodyPr/>
+          <a:lstStyle/>
+          <a:p>
+            <a:r>
+              <a:rPr lang="en-US" dirty="0"/>
+              <a:t>Agente = Copilot contextualizado. Não é um processo externo. Skills são o mecanismo de conhecimento — determinísticas, versionadas, portáveis entre runtimes.</a:t>
+            </a:r>
+            <a:endParaRPr lang="en-US" dirty="0"/>
+          </a:p>
+        </p:txBody>
+      </p:sp>
+      <p:sp>
+        <p:nvSpPr>
+          <p:cNvPr id="4" name="Slide Number Placeholder 3"/>
+          <p:cNvSpPr>
+            <a:spLocks noGrp="1"/>
+          </p:cNvSpPr>
+          <p:nvPr>
+            <p:ph type="sldNum" sz="quarter" idx="10"/>
+          </p:nvPr>
+        </p:nvSpPr>
+        <p:spPr/>
+        <p:txBody>
+          <a:bodyPr/>
+          <a:lstStyle/>
+          <a:p>
+            <a:fld id="{F7021451-1387-4CA6-816F-3879F97B5CBC}" type="slidenum">
+              <a:rPr lang="en-US"/>
+              <a:t>4</a:t>
+            </a:fld>
+            <a:endParaRPr lang="en-US"/>
+          </a:p>
+        </p:txBody>
+      </p:sp>
+    </p:spTree>
+    <p:extLst>
+      <p:ext uri="{BB962C8B-B14F-4D97-AF65-F5344CB8AC3E}">
+        <p14:creationId xmlns:p14="http://schemas.microsoft.com/office/powerpoint/2010/main" val="1024086991"/>
+      </p:ext>
+    </p:extLst>
+  </p:cSld>
+  <p:clrMapOvr>
+    <a:masterClrMapping/>
+  </p:clrMapOvr>
+</p:notes>
+</file>
+
+<file path=ppt/notesSlides/notesSlide5.xml><?xml version="1.0" encoding="utf-8"?>
+<p:notes xmlns:a="http://schemas.openxmlformats.org/drawingml/2006/main" xmlns:r="http://schemas.openxmlformats.org/officeDocument/2006/relationships" xmlns:p="http://schemas.openxmlformats.org/presentationml/2006/main">
+  <p:cSld>
+    <p:spTree>
+      <p:nvGrpSpPr>
+        <p:cNvPr id="1" name=""/>
+        <p:cNvGrpSpPr/>
+        <p:nvPr/>
+      </p:nvGrpSpPr>
+      <p:grpSpPr>
+        <a:xfrm>
+          <a:off x="0" y="0"/>
+          <a:ext cx="0" cy="0"/>
+          <a:chOff x="0" y="0"/>
+          <a:chExt cx="0" cy="0"/>
+        </a:xfrm>
+      </p:grpSpPr>
+      <p:sp>
+        <p:nvSpPr>
+          <p:cNvPr id="2" name="Slide Image Placeholder 1"/>
+          <p:cNvSpPr>
+            <a:spLocks noGrp="1" noRot="1" noChangeAspect="1"/>
+          </p:cNvSpPr>
+          <p:nvPr>
+            <p:ph type="sldImg"/>
+          </p:nvPr>
+        </p:nvSpPr>
+        <p:spPr/>
+      </p:sp>
+      <p:sp>
+        <p:nvSpPr>
+          <p:cNvPr id="3" name="Notes Placeholder 2"/>
+          <p:cNvSpPr>
+            <a:spLocks noGrp="1"/>
+          </p:cNvSpPr>
+          <p:nvPr>
+            <p:ph type="body" idx="1"/>
+          </p:nvPr>
+        </p:nvSpPr>
+        <p:spPr/>
+        <p:txBody>
+          <a:bodyPr/>
+          <a:lstStyle/>
+          <a:p>
+            <a:r>
+              <a:rPr lang="en-US" dirty="0"/>
+              <a:t>Macrofluxo em loop: sentido horário. Top: Negocial (externo, âmbar)→02 Spec→03 Plan. Desce à direita. Bottom (dir→esq): 04 Build→05 Test→06 Deploy→07 Maintain. Sobe à esquerda: 07 gera intent.md que re-entra no pipeline. O loop fecha. Negocial está em âmbar para indicar que é externo ao time de plataforma mobile.</a:t>
+            </a:r>
+            <a:endParaRPr lang="en-US" dirty="0"/>
+          </a:p>
+        </p:txBody>
+      </p:sp>
+      <p:sp>
+        <p:nvSpPr>
+          <p:cNvPr id="4" name="Slide Number Placeholder 3"/>
+          <p:cNvSpPr>
+            <a:spLocks noGrp="1"/>
+          </p:cNvSpPr>
+          <p:nvPr>
+            <p:ph type="sldNum" sz="quarter" idx="10"/>
+          </p:nvPr>
+        </p:nvSpPr>
+        <p:spPr/>
+        <p:txBody>
+          <a:bodyPr/>
+          <a:lstStyle/>
+          <a:p>
+            <a:fld id="{F7021451-1387-4CA6-816F-3879F97B5CBC}" type="slidenum">
+              <a:rPr lang="en-US"/>
+              <a:t>5</a:t>
+            </a:fld>
+            <a:endParaRPr lang="en-US"/>
+          </a:p>
+        </p:txBody>
+      </p:sp>
+    </p:spTree>
+    <p:extLst>
+      <p:ext uri="{BB962C8B-B14F-4D97-AF65-F5344CB8AC3E}">
+        <p14:creationId xmlns:p14="http://schemas.microsoft.com/office/powerpoint/2010/main" val="1024086991"/>
+      </p:ext>
+    </p:extLst>
+  </p:cSld>
+  <p:clrMapOvr>
+    <a:masterClrMapping/>
+  </p:clrMapOvr>
+</p:notes>
+</file>
+
+<file path=ppt/notesSlides/notesSlide6.xml><?xml version="1.0" encoding="utf-8"?>
+<p:notes xmlns:a="http://schemas.openxmlformats.org/drawingml/2006/main" xmlns:r="http://schemas.openxmlformats.org/officeDocument/2006/relationships" xmlns:p="http://schemas.openxmlformats.org/presentationml/2006/main">
+  <p:cSld>
+    <p:spTree>
+      <p:nvGrpSpPr>
+        <p:cNvPr id="1" name=""/>
+        <p:cNvGrpSpPr/>
+        <p:nvPr/>
+      </p:nvGrpSpPr>
+      <p:grpSpPr>
+        <a:xfrm>
+          <a:off x="0" y="0"/>
+          <a:ext cx="0" cy="0"/>
+          <a:chOff x="0" y="0"/>
+          <a:chExt cx="0" cy="0"/>
+        </a:xfrm>
+      </p:grpSpPr>
+      <p:sp>
+        <p:nvSpPr>
+          <p:cNvPr id="2" name="Slide Image Placeholder 1"/>
+          <p:cNvSpPr>
+            <a:spLocks noGrp="1" noRot="1" noChangeAspect="1"/>
+          </p:cNvSpPr>
+          <p:nvPr>
+            <p:ph type="sldImg"/>
+          </p:nvPr>
+        </p:nvSpPr>
+        <p:spPr/>
+      </p:sp>
+      <p:sp>
+        <p:nvSpPr>
+          <p:cNvPr id="3" name="Notes Placeholder 2"/>
+          <p:cNvSpPr>
+            <a:spLocks noGrp="1"/>
+          </p:cNvSpPr>
+          <p:nvPr>
+            <p:ph type="body" idx="1"/>
+          </p:nvPr>
+        </p:nvSpPr>
+        <p:spPr/>
+        <p:txBody>
+          <a:bodyPr/>
+          <a:lstStyle/>
+          <a:p>
+            <a:r>
+              <a:rPr lang="en-US" dirty="0"/>
+              <a:t>Os artefatos não são burocracia — são o mecanismo que cria contexto, governa decisões e permite rastreabilidade. Sem eles, o agente opera sem contexto e o humano sem registro.</a:t>
+            </a:r>
+            <a:endParaRPr lang="en-US" dirty="0"/>
+          </a:p>
+        </p:txBody>
+      </p:sp>
+      <p:sp>
+        <p:nvSpPr>
+          <p:cNvPr id="4" name="Slide Number Placeholder 3"/>
+          <p:cNvSpPr>
+            <a:spLocks noGrp="1"/>
+          </p:cNvSpPr>
+          <p:nvPr>
+            <p:ph type="sldNum" sz="quarter" idx="10"/>
+          </p:nvPr>
+        </p:nvSpPr>
+        <p:spPr/>
+        <p:txBody>
+          <a:bodyPr/>
+          <a:lstStyle/>
+          <a:p>
+            <a:fld id="{F7021451-1387-4CA6-816F-3879F97B5CBC}" type="slidenum">
+              <a:rPr lang="en-US"/>
+              <a:t>6</a:t>
+            </a:fld>
+            <a:endParaRPr lang="en-US"/>
+          </a:p>
+        </p:txBody>
+      </p:sp>
+    </p:spTree>
+    <p:extLst>
+      <p:ext uri="{BB962C8B-B14F-4D97-AF65-F5344CB8AC3E}">
+        <p14:creationId xmlns:p14="http://schemas.microsoft.com/office/powerpoint/2010/main" val="1024086991"/>
+      </p:ext>
+    </p:extLst>
+  </p:cSld>
+  <p:clrMapOvr>
+    <a:masterClrMapping/>
+  </p:clrMapOvr>
+</p:notes>
+</file>
+
+<file path=ppt/notesSlides/notesSlide7.xml><?xml version="1.0" encoding="utf-8"?>
+<p:notes xmlns:a="http://schemas.openxmlformats.org/drawingml/2006/main" xmlns:r="http://schemas.openxmlformats.org/officeDocument/2006/relationships" xmlns:p="http://schemas.openxmlformats.org/presentationml/2006/main">
+  <p:cSld>
+    <p:spTree>
+      <p:nvGrpSpPr>
+        <p:cNvPr id="1" name=""/>
+        <p:cNvGrpSpPr/>
+        <p:nvPr/>
+      </p:nvGrpSpPr>
+      <p:grpSpPr>
+        <a:xfrm>
+          <a:off x="0" y="0"/>
+          <a:ext cx="0" cy="0"/>
+          <a:chOff x="0" y="0"/>
+          <a:chExt cx="0" cy="0"/>
+        </a:xfrm>
+      </p:grpSpPr>
+      <p:sp>
+        <p:nvSpPr>
+          <p:cNvPr id="2" name="Slide Image Placeholder 1"/>
+          <p:cNvSpPr>
+            <a:spLocks noGrp="1" noRot="1" noChangeAspect="1"/>
+          </p:cNvSpPr>
+          <p:nvPr>
+            <p:ph type="sldImg"/>
+          </p:nvPr>
+        </p:nvSpPr>
+        <p:spPr/>
+      </p:sp>
+      <p:sp>
+        <p:nvSpPr>
+          <p:cNvPr id="3" name="Notes Placeholder 2"/>
+          <p:cNvSpPr>
+            <a:spLocks noGrp="1"/>
+          </p:cNvSpPr>
+          <p:nvPr>
+            <p:ph type="body" idx="1"/>
+          </p:nvPr>
+        </p:nvSpPr>
+        <p:spPr/>
+        <p:txBody>
+          <a:bodyPr/>
+          <a:lstStyle/>
+          <a:p>
+            <a:r>
+              <a:rPr lang="en-US" dirty="0"/>
+              <a:t>Arquitetura em 3 camadas que operam em paralelo: pipeline de artefatos, infraestrutura de conhecimento (skills), e monitoramento contínuo. Todas as integrações usam sistemas existentes.</a:t>
+            </a:r>
+            <a:endParaRPr lang="en-US" dirty="0"/>
+          </a:p>
+        </p:txBody>
+      </p:sp>
+      <p:sp>
+        <p:nvSpPr>
+          <p:cNvPr id="4" name="Slide Number Placeholder 3"/>
+          <p:cNvSpPr>
+            <a:spLocks noGrp="1"/>
+          </p:cNvSpPr>
+          <p:nvPr>
+            <p:ph type="sldNum" sz="quarter" idx="10"/>
+          </p:nvPr>
+        </p:nvSpPr>
+        <p:spPr/>
+        <p:txBody>
+          <a:bodyPr/>
+          <a:lstStyle/>
+          <a:p>
+            <a:fld id="{F7021451-1387-4CA6-816F-3879F97B5CBC}" type="slidenum">
+              <a:rPr lang="en-US"/>
+              <a:t>7</a:t>
+            </a:fld>
+            <a:endParaRPr lang="en-US"/>
+          </a:p>
+        </p:txBody>
+      </p:sp>
+    </p:spTree>
+    <p:extLst>
+      <p:ext uri="{BB962C8B-B14F-4D97-AF65-F5344CB8AC3E}">
+        <p14:creationId xmlns:p14="http://schemas.microsoft.com/office/powerpoint/2010/main" val="1024086991"/>
+      </p:ext>
+    </p:extLst>
+  </p:cSld>
+  <p:clrMapOvr>
+    <a:masterClrMapping/>
+  </p:clrMapOvr>
+</p:notes>
+</file>
+
+<file path=ppt/notesSlides/notesSlide8.xml><?xml version="1.0" encoding="utf-8"?>
+<p:notes xmlns:a="http://schemas.openxmlformats.org/drawingml/2006/main" xmlns:r="http://schemas.openxmlformats.org/officeDocument/2006/relationships" xmlns:p="http://schemas.openxmlformats.org/presentationml/2006/main">
+  <p:cSld>
+    <p:spTree>
+      <p:nvGrpSpPr>
+        <p:cNvPr id="1" name=""/>
+        <p:cNvGrpSpPr/>
+        <p:nvPr/>
+      </p:nvGrpSpPr>
+      <p:grpSpPr>
+        <a:xfrm>
+          <a:off x="0" y="0"/>
+          <a:ext cx="0" cy="0"/>
+          <a:chOff x="0" y="0"/>
+          <a:chExt cx="0" cy="0"/>
+        </a:xfrm>
+      </p:grpSpPr>
+      <p:sp>
+        <p:nvSpPr>
+          <p:cNvPr id="2" name="Slide Image Placeholder 1"/>
+          <p:cNvSpPr>
+            <a:spLocks noGrp="1" noRot="1" noChangeAspect="1"/>
+          </p:cNvSpPr>
+          <p:nvPr>
+            <p:ph type="sldImg"/>
+          </p:nvPr>
+        </p:nvSpPr>
+        <p:spPr/>
+      </p:sp>
+      <p:sp>
+        <p:nvSpPr>
+          <p:cNvPr id="3" name="Notes Placeholder 2"/>
+          <p:cNvSpPr>
+            <a:spLocks noGrp="1"/>
+          </p:cNvSpPr>
+          <p:nvPr>
+            <p:ph type="body" idx="1"/>
+          </p:nvPr>
+        </p:nvSpPr>
+        <p:spPr/>
+        <p:txBody>
+          <a:bodyPr/>
+          <a:lstStyle/>
+          <a:p>
+            <a:r>
+              <a:rPr lang="en-US" dirty="0"/>
+              <a:t>Enfatizar: nenhuma ferramenta nova. A esteira roda sobre a infraestrutura que já existe. O investimento é em conhecimento (skills) e processo (artefatos), não em ferramentas.</a:t>
+            </a:r>
+            <a:endParaRPr lang="en-US" dirty="0"/>
+          </a:p>
+        </p:txBody>
+      </p:sp>
+      <p:sp>
+        <p:nvSpPr>
+          <p:cNvPr id="4" name="Slide Number Placeholder 3"/>
+          <p:cNvSpPr>
+            <a:spLocks noGrp="1"/>
+          </p:cNvSpPr>
+          <p:nvPr>
+            <p:ph type="sldNum" sz="quarter" idx="10"/>
+          </p:nvPr>
+        </p:nvSpPr>
+        <p:spPr/>
+        <p:txBody>
+          <a:bodyPr/>
+          <a:lstStyle/>
+          <a:p>
+            <a:fld id="{F7021451-1387-4CA6-816F-3879F97B5CBC}" type="slidenum">
+              <a:rPr lang="en-US"/>
+              <a:t>8</a:t>
+            </a:fld>
+            <a:endParaRPr lang="en-US"/>
+          </a:p>
+        </p:txBody>
+      </p:sp>
+    </p:spTree>
+    <p:extLst>
+      <p:ext uri="{BB962C8B-B14F-4D97-AF65-F5344CB8AC3E}">
+        <p14:creationId xmlns:p14="http://schemas.microsoft.com/office/powerpoint/2010/main" val="1024086991"/>
+      </p:ext>
+    </p:extLst>
+  </p:cSld>
+  <p:clrMapOvr>
+    <a:masterClrMapping/>
+  </p:clrMapOvr>
+</p:notes>
+</file>
+
+<file path=ppt/notesSlides/notesSlide9.xml><?xml version="1.0" encoding="utf-8"?>
+<p:notes xmlns:a="http://schemas.openxmlformats.org/drawingml/2006/main" xmlns:r="http://schemas.openxmlformats.org/officeDocument/2006/relationships" xmlns:p="http://schemas.openxmlformats.org/presentationml/2006/main">
+  <p:cSld>
+    <p:spTree>
+      <p:nvGrpSpPr>
+        <p:cNvPr id="1" name=""/>
+        <p:cNvGrpSpPr/>
+        <p:nvPr/>
+      </p:nvGrpSpPr>
+      <p:grpSpPr>
+        <a:xfrm>
+          <a:off x="0" y="0"/>
+          <a:ext cx="0" cy="0"/>
+          <a:chOff x="0" y="0"/>
+          <a:chExt cx="0" cy="0"/>
+        </a:xfrm>
+      </p:grpSpPr>
+      <p:sp>
+        <p:nvSpPr>
+          <p:cNvPr id="2" name="Slide Image Placeholder 1"/>
+          <p:cNvSpPr>
+            <a:spLocks noGrp="1" noRot="1" noChangeAspect="1"/>
+          </p:cNvSpPr>
+          <p:nvPr>
+            <p:ph type="sldImg"/>
+          </p:nvPr>
+        </p:nvSpPr>
+        <p:spPr/>
+      </p:sp>
+      <p:sp>
+        <p:nvSpPr>
+          <p:cNvPr id="3" name="Notes Placeholder 2"/>
+          <p:cNvSpPr>
+            <a:spLocks noGrp="1"/>
+          </p:cNvSpPr>
+          <p:nvPr>
+            <p:ph type="body" idx="1"/>
+          </p:nvPr>
+        </p:nvSpPr>
+        <p:spPr/>
+        <p:txBody>
+          <a:bodyPr/>
+          <a:lstStyle/>
+          <a:p>
+            <a:r>
+              <a:rPr lang="en-US" dirty="0"/>
+              <a:t>Por que não RAG? RAG é probabilístico — o chunk certo pode não ser retornado. Para segurança e compliance, "às vezes carrega a regra certa" não é aceitável. Skills são determinísticas e testáveis em evals.</a:t>
+            </a:r>
+            <a:endParaRPr lang="en-US" dirty="0"/>
+          </a:p>
+        </p:txBody>
+      </p:sp>
+      <p:sp>
+        <p:nvSpPr>
+          <p:cNvPr id="4" name="Slide Number Placeholder 3"/>
+          <p:cNvSpPr>
+            <a:spLocks noGrp="1"/>
+          </p:cNvSpPr>
+          <p:nvPr>
+            <p:ph type="sldNum" sz="quarter" idx="10"/>
+          </p:nvPr>
+        </p:nvSpPr>
+        <p:spPr/>
+        <p:txBody>
+          <a:bodyPr/>
+          <a:lstStyle/>
+          <a:p>
+            <a:fld id="{F7021451-1387-4CA6-816F-3879F97B5CBC}" type="slidenum">
+              <a:rPr lang="en-US"/>
+              <a:t>9</a:t>
+            </a:fld>
+            <a:endParaRPr lang="en-US"/>
+          </a:p>
+        </p:txBody>
+      </p:sp>
+    </p:spTree>
+    <p:extLst>
+      <p:ext uri="{BB962C8B-B14F-4D97-AF65-F5344CB8AC3E}">
+        <p14:creationId xmlns:p14="http://schemas.microsoft.com/office/powerpoint/2010/main" val="1024086991"/>
+      </p:ext>
+    </p:extLst>
+  </p:cSld>
+  <p:clrMapOvr>
+    <a:masterClrMapping/>
+  </p:clrMapOvr>
+</p:notes>
+</file>
+
+<file path=ppt/slideLayouts/slideLayout1.xml><?xml version="1.0" encoding="utf-8"?>
 <p:sldLayout xmlns:a="http://schemas.openxmlformats.org/drawingml/2006/main" xmlns:r="http://schemas.openxmlformats.org/officeDocument/2006/relationships" xmlns:p="http://schemas.openxmlformats.org/presentationml/2006/main" preserve="1">
   <p:cSld name="DEFAULT">
     <p:bg>
@@ -1900,7 +1820,7 @@
 </p:sldLayout>
 </file>
 
-<file path=ppt\slideMasters\slideMaster1.xml><?xml version="1.0" encoding="utf-8"?>
+<file path=ppt/slideMasters/slideMaster1.xml><?xml version="1.0" encoding="utf-8"?>
 <p:sldMaster xmlns:a="http://schemas.openxmlformats.org/drawingml/2006/main" xmlns:r="http://schemas.openxmlformats.org/officeDocument/2006/relationships" xmlns:p="http://schemas.openxmlformats.org/presentationml/2006/main">
   <p:cSld>
     <p:spTree>
@@ -2177,7 +2097,7 @@
 </p:sldMaster>
 </file>
 
-<file path=ppt\slides\slide1.xml><?xml version="1.0" encoding="utf-8"?>
+<file path=ppt/slides/slide1.xml><?xml version="1.0" encoding="utf-8"?>
 <p:sld xmlns:a="http://schemas.openxmlformats.org/drawingml/2006/main" xmlns:r="http://schemas.openxmlformats.org/officeDocument/2006/relationships" xmlns:p="http://schemas.openxmlformats.org/presentationml/2006/main">
   <p:cSld name="Slide 1">
     <p:bg>
@@ -2429,7 +2349,7 @@
 </p:sld>
 </file>
 
-<file path=ppt\slides\slide10.xml><?xml version="1.0" encoding="utf-8"?>
+<file path=ppt/slides/slide10.xml><?xml version="1.0" encoding="utf-8"?>
 <p:sld xmlns:a="http://schemas.openxmlformats.org/drawingml/2006/main" xmlns:r="http://schemas.openxmlformats.org/officeDocument/2006/relationships" xmlns:p="http://schemas.openxmlformats.org/presentationml/2006/main">
   <p:cSld name="Slide 10">
     <p:bg>
@@ -3385,7 +3305,7 @@
 </p:sld>
 </file>
 
-<file path=ppt\slides\slide11.xml><?xml version="1.0" encoding="utf-8"?>
+<file path=ppt/slides/slide11.xml><?xml version="1.0" encoding="utf-8"?>
 <p:sld xmlns:a="http://schemas.openxmlformats.org/drawingml/2006/main" xmlns:r="http://schemas.openxmlformats.org/officeDocument/2006/relationships" xmlns:p="http://schemas.openxmlformats.org/presentationml/2006/main">
   <p:cSld name="Slide 11">
     <p:bg>
@@ -5758,7 +5678,7 @@
 </p:sld>
 </file>
 
-<file path=ppt\slides\slide12.xml><?xml version="1.0" encoding="utf-8"?>
+<file path=ppt/slides/slide12.xml><?xml version="1.0" encoding="utf-8"?>
 <p:sld xmlns:a="http://schemas.openxmlformats.org/drawingml/2006/main" xmlns:r="http://schemas.openxmlformats.org/officeDocument/2006/relationships" xmlns:p="http://schemas.openxmlformats.org/presentationml/2006/main">
   <p:cSld name="Slide 12">
     <p:bg>
@@ -6654,7 +6574,7 @@
 </p:sld>
 </file>
 
-<file path=ppt\slides\slide13.xml><?xml version="1.0" encoding="utf-8"?>
+<file path=ppt/slides/slide13.xml><?xml version="1.0" encoding="utf-8"?>
 <p:sld xmlns:a="http://schemas.openxmlformats.org/drawingml/2006/main" xmlns:r="http://schemas.openxmlformats.org/officeDocument/2006/relationships" xmlns:p="http://schemas.openxmlformats.org/presentationml/2006/main">
   <p:cSld name="Slide 13">
     <p:bg>
@@ -7276,7 +7196,7 @@
 </p:sld>
 </file>
 
-<file path=ppt\slides\slide14.xml><?xml version="1.0" encoding="utf-8"?>
+<file path=ppt/slides/slide14.xml><?xml version="1.0" encoding="utf-8"?>
 <p:sld xmlns:a="http://schemas.openxmlformats.org/drawingml/2006/main" xmlns:r="http://schemas.openxmlformats.org/officeDocument/2006/relationships" xmlns:p="http://schemas.openxmlformats.org/presentationml/2006/main">
   <p:cSld name="Slide 14">
     <p:bg>
@@ -8924,7 +8844,7 @@
 </p:sld>
 </file>
 
-<file path=ppt\slides\slide15.xml><?xml version="1.0" encoding="utf-8"?>
+<file path=ppt/slides/slide15.xml><?xml version="1.0" encoding="utf-8"?>
 <p:sld xmlns:a="http://schemas.openxmlformats.org/drawingml/2006/main" xmlns:r="http://schemas.openxmlformats.org/officeDocument/2006/relationships" xmlns:p="http://schemas.openxmlformats.org/presentationml/2006/main">
   <p:cSld name="Slide 15">
     <p:bg>
@@ -9860,7 +9780,7 @@
 </p:sld>
 </file>
 
-<file path=ppt\slides\slide2.xml><?xml version="1.0" encoding="utf-8"?>
+<file path=ppt/slides/slide2.xml><?xml version="1.0" encoding="utf-8"?>
 <p:sld xmlns:a="http://schemas.openxmlformats.org/drawingml/2006/main" xmlns:r="http://schemas.openxmlformats.org/officeDocument/2006/relationships" xmlns:p="http://schemas.openxmlformats.org/presentationml/2006/main">
   <p:cSld name="Slide 2">
     <p:bg>
@@ -10439,7 +10359,7 @@
 </p:sld>
 </file>
 
-<file path=ppt\slides\slide3.xml><?xml version="1.0" encoding="utf-8"?>
+<file path=ppt/slides/slide3.xml><?xml version="1.0" encoding="utf-8"?>
 <p:sld xmlns:a="http://schemas.openxmlformats.org/drawingml/2006/main" xmlns:r="http://schemas.openxmlformats.org/officeDocument/2006/relationships" xmlns:p="http://schemas.openxmlformats.org/presentationml/2006/main">
   <p:cSld name="Slide 3">
     <p:bg>
@@ -10694,7 +10614,7 @@
 </p:sld>
 </file>
 
-<file path=ppt\slides\slide4.xml><?xml version="1.0" encoding="utf-8"?>
+<file path=ppt/slides/slide4.xml><?xml version="1.0" encoding="utf-8"?>
 <p:sld xmlns:a="http://schemas.openxmlformats.org/drawingml/2006/main" xmlns:r="http://schemas.openxmlformats.org/officeDocument/2006/relationships" xmlns:p="http://schemas.openxmlformats.org/presentationml/2006/main">
   <p:cSld name="Slide 4">
     <p:bg>
@@ -11231,7 +11151,7 @@
 </p:sld>
 </file>
 
-<file path=ppt\slides\slide5.xml><?xml version="1.0" encoding="utf-8"?>
+<file path=ppt/slides/slide5.xml><?xml version="1.0" encoding="utf-8"?>
 <p:sld xmlns:a="http://schemas.openxmlformats.org/drawingml/2006/main" xmlns:r="http://schemas.openxmlformats.org/officeDocument/2006/relationships" xmlns:p="http://schemas.openxmlformats.org/presentationml/2006/main">
   <p:cSld name="Slide 5">
     <p:bg>
@@ -12669,7 +12589,7 @@
 </p:sld>
 </file>
 
-<file path=ppt\slides\slide6.xml><?xml version="1.0" encoding="utf-8"?>
+<file path=ppt/slides/slide6.xml><?xml version="1.0" encoding="utf-8"?>
 <p:sld xmlns:a="http://schemas.openxmlformats.org/drawingml/2006/main" xmlns:r="http://schemas.openxmlformats.org/officeDocument/2006/relationships" xmlns:p="http://schemas.openxmlformats.org/presentationml/2006/main">
   <p:cSld name="Slide 6">
     <p:bg>
@@ -13445,7 +13365,7 @@
 </p:sld>
 </file>
 
-<file path=ppt\slides\slide7.xml><?xml version="1.0" encoding="utf-8"?>
+<file path=ppt/slides/slide7.xml><?xml version="1.0" encoding="utf-8"?>
 <p:sld xmlns:a="http://schemas.openxmlformats.org/drawingml/2006/main" xmlns:r="http://schemas.openxmlformats.org/officeDocument/2006/relationships" xmlns:p="http://schemas.openxmlformats.org/presentationml/2006/main">
   <p:cSld name="Slide 7">
     <p:bg>
@@ -14051,7 +13971,7 @@
 </p:sld>
 </file>
 
-<file path=ppt\slides\slide8.xml><?xml version="1.0" encoding="utf-8"?>
+<file path=ppt/slides/slide8.xml><?xml version="1.0" encoding="utf-8"?>
 <p:sld xmlns:a="http://schemas.openxmlformats.org/drawingml/2006/main" xmlns:r="http://schemas.openxmlformats.org/officeDocument/2006/relationships" xmlns:p="http://schemas.openxmlformats.org/presentationml/2006/main">
   <p:cSld name="Slide 8">
     <p:bg>
@@ -15673,7 +15593,7 @@
 </p:sld>
 </file>
 
-<file path=ppt\slides\slide9.xml><?xml version="1.0" encoding="utf-8"?>
+<file path=ppt/slides/slide9.xml><?xml version="1.0" encoding="utf-8"?>
 <p:sld xmlns:a="http://schemas.openxmlformats.org/drawingml/2006/main" xmlns:r="http://schemas.openxmlformats.org/officeDocument/2006/relationships" xmlns:p="http://schemas.openxmlformats.org/presentationml/2006/main">
   <p:cSld name="Slide 9">
     <p:bg>
@@ -17166,11 +17086,7 @@
 </p:sld>
 </file>
 
-<file path=ppt\tableStyles.xml><?xml version="1.0" encoding="utf-8"?>
-<a:tblStyleLst xmlns:a="http://schemas.openxmlformats.org/drawingml/2006/main" def="{5C22544A-7EE6-4342-B048-85BDC9FD1C3A}"/>
-</file>
-
-<file path=ppt\theme\theme1.xml><?xml version="1.0" encoding="utf-8"?>
+<file path=ppt/theme/theme1.xml><?xml version="1.0" encoding="utf-8"?>
 <a:theme xmlns:a="http://schemas.openxmlformats.org/drawingml/2006/main" name="Office Theme">
   <a:themeElements>
     <a:clrScheme name="Office">
@@ -17463,35 +17379,4 @@
     </a:ext>
   </a:extLst>
 </a:theme>
-</file>
-
-<file path=ppt\viewProps.xml><?xml version="1.0" encoding="utf-8"?>
-<p:viewPr xmlns:a="http://schemas.openxmlformats.org/drawingml/2006/main" xmlns:r="http://schemas.openxmlformats.org/officeDocument/2006/relationships" xmlns:p="http://schemas.openxmlformats.org/presentationml/2006/main">
-  <p:normalViewPr horzBarState="maximized">
-    <p:restoredLeft sz="15611"/>
-    <p:restoredTop sz="94610"/>
-  </p:normalViewPr>
-  <p:slideViewPr>
-    <p:cSldViewPr snapToGrid="0" snapToObjects="1">
-      <p:cViewPr varScale="1">
-        <p:scale>
-          <a:sx n="136" d="100"/>
-          <a:sy n="136" d="100"/>
-        </p:scale>
-        <p:origin x="216" y="312"/>
-      </p:cViewPr>
-      <p:guideLst/>
-    </p:cSldViewPr>
-  </p:slideViewPr>
-  <p:notesTextViewPr>
-    <p:cViewPr>
-      <p:scale>
-        <a:sx n="1" d="1"/>
-        <a:sy n="1" d="1"/>
-      </p:scale>
-      <p:origin x="0" y="0"/>
-    </p:cViewPr>
-  </p:notesTextViewPr>
-  <p:gridSpacing cx="76200" cy="76200"/>
-</p:viewPr>
 </file>
</xml_diff>

<commit_message>
fix(pitch): atualizar slide 04 para refletir MCP em vez de skills
Slide 04 (O que e um agente) referenciava skills no diagrama do agente.
Atualizado:
- '+ skill: bbds-api' -> '+ MCP: bbds-api'
- '+ skill: security' -> '+ MCP: security'
- '(carregada por contexto)' -> '(consultado por contexto)'
- Instrucoes: 'Skills carregadas dinamicamente' -> 'contexto de plataforma injetado (MCP)'
- Rodape: 'Skills escritas para Copilot...' -> 'Conteudo de conhecimento portavel...'

Co-Authored-By: Claude Sonnet 4.6 <noreply@anthropic.com>
</commit_message>
<xml_diff>
--- a/esteira-agentica-pitch.pptx
+++ b/esteira-agentica-pitch.pptx
@@ -10828,7 +10828,7 @@
                 <a:ea typeface="Calibri" pitchFamily="34" charset="-122"/>
                 <a:cs typeface="Calibri" pitchFamily="34" charset="-120"/>
               </a:rPr>
-              <a:t>Instruções via copilot-instructions.md + Skills carregadas dinamicamente por contexto</a:t>
+              <a:t>Instruções via copilot-instructions.md + contexto de plataforma injetado (MCP)</a:t>
             </a:r>
             <a:endParaRPr lang="en-US" sz="1200" dirty="0"/>
           </a:p>
@@ -11018,7 +11018,7 @@
                 <a:ea typeface="Courier New" pitchFamily="34" charset="-122"/>
                 <a:cs typeface="Courier New" pitchFamily="34" charset="-120"/>
               </a:rPr>
-              <a:t>  + skill: bbds-api</a:t>
+              <a:t>  + MCP: bbds-api</a:t>
             </a:r>
             <a:endParaRPr lang="en-US" sz="1300" dirty="0"/>
           </a:p>
@@ -11035,7 +11035,7 @@
                 <a:ea typeface="Courier New" pitchFamily="34" charset="-122"/>
                 <a:cs typeface="Courier New" pitchFamily="34" charset="-120"/>
               </a:rPr>
-              <a:t>    (carregada por contexto)</a:t>
+              <a:t>    (consultado por contexto)</a:t>
             </a:r>
             <a:endParaRPr lang="en-US" sz="1300" dirty="0"/>
           </a:p>
@@ -11058,7 +11058,7 @@
                 <a:ea typeface="Courier New" pitchFamily="34" charset="-122"/>
                 <a:cs typeface="Courier New" pitchFamily="34" charset="-120"/>
               </a:rPr>
-              <a:t>  + skill: security</a:t>
+              <a:t>  + MCP: security</a:t>
             </a:r>
             <a:endParaRPr lang="en-US" sz="1300" dirty="0"/>
           </a:p>
@@ -11075,7 +11075,7 @@
                 <a:ea typeface="Courier New" pitchFamily="34" charset="-122"/>
                 <a:cs typeface="Courier New" pitchFamily="34" charset="-120"/>
               </a:rPr>
-              <a:t>    (carregada por contexto)</a:t>
+              <a:t>    (consultado por contexto)</a:t>
             </a:r>
             <a:endParaRPr lang="en-US" sz="1300" dirty="0"/>
           </a:p>
@@ -11137,7 +11137,7 @@
                 <a:ea typeface="Calibri" pitchFamily="34" charset="-122"/>
                 <a:cs typeface="Calibri" pitchFamily="34" charset="-120"/>
               </a:rPr>
-              <a:t>Skills escritas para Copilot funcionam no Claude Code sem modificação — investimento portável.</a:t>
+              <a:t>Conteúdo de conhecimento portável — funciona em Copilot e Claude Code sem modificação.</a:t>
             </a:r>
             <a:endParaRPr lang="en-US" sz="1100" dirty="0"/>
           </a:p>

</xml_diff>

<commit_message>
feat(pitch): remover slide 08 (Infraestrutura existente)
Slide 'Infraestrutura existente' removido a pedido.
- slide8.xml e referencias em presentation.xml, rels e [Content_Types].xml removidos
- Numeracoes atualizadas: slides 09-15 passam para 08-14

Co-Authored-By: Claude Sonnet 4.6 <noreply@anthropic.com>
</commit_message>
<xml_diff>
--- a/esteira-agentica-pitch.pptx
+++ b/esteira-agentica-pitch.pptx
@@ -12,7 +12,6 @@
     <p:sldId id="260" r:id="rId6"/>
     <p:sldId id="261" r:id="rId7"/>
     <p:sldId id="262" r:id="rId8"/>
-    <p:sldId id="263" r:id="rId9"/>
     <p:sldId id="264" r:id="rId10"/>
     <p:sldId id="265" r:id="rId11"/>
     <p:sldId id="266" r:id="rId12"/>
@@ -1596,94 +1595,6 @@
             <a:fld id="{F7021451-1387-4CA6-816F-3879F97B5CBC}" type="slidenum">
               <a:rPr lang="en-US"/>
               <a:t>7</a:t>
-            </a:fld>
-            <a:endParaRPr lang="en-US"/>
-          </a:p>
-        </p:txBody>
-      </p:sp>
-    </p:spTree>
-    <p:extLst>
-      <p:ext uri="{BB962C8B-B14F-4D97-AF65-F5344CB8AC3E}">
-        <p14:creationId xmlns:p14="http://schemas.microsoft.com/office/powerpoint/2010/main" val="1024086991"/>
-      </p:ext>
-    </p:extLst>
-  </p:cSld>
-  <p:clrMapOvr>
-    <a:masterClrMapping/>
-  </p:clrMapOvr>
-</p:notes>
-</file>
-
-<file path=ppt/notesSlides/notesSlide8.xml><?xml version="1.0" encoding="utf-8"?>
-<p:notes xmlns:a="http://schemas.openxmlformats.org/drawingml/2006/main" xmlns:r="http://schemas.openxmlformats.org/officeDocument/2006/relationships" xmlns:p="http://schemas.openxmlformats.org/presentationml/2006/main">
-  <p:cSld>
-    <p:spTree>
-      <p:nvGrpSpPr>
-        <p:cNvPr id="1" name=""/>
-        <p:cNvGrpSpPr/>
-        <p:nvPr/>
-      </p:nvGrpSpPr>
-      <p:grpSpPr>
-        <a:xfrm>
-          <a:off x="0" y="0"/>
-          <a:ext cx="0" cy="0"/>
-          <a:chOff x="0" y="0"/>
-          <a:chExt cx="0" cy="0"/>
-        </a:xfrm>
-      </p:grpSpPr>
-      <p:sp>
-        <p:nvSpPr>
-          <p:cNvPr id="2" name="Slide Image Placeholder 1"/>
-          <p:cNvSpPr>
-            <a:spLocks noGrp="1" noRot="1" noChangeAspect="1"/>
-          </p:cNvSpPr>
-          <p:nvPr>
-            <p:ph type="sldImg"/>
-          </p:nvPr>
-        </p:nvSpPr>
-        <p:spPr/>
-      </p:sp>
-      <p:sp>
-        <p:nvSpPr>
-          <p:cNvPr id="3" name="Notes Placeholder 2"/>
-          <p:cNvSpPr>
-            <a:spLocks noGrp="1"/>
-          </p:cNvSpPr>
-          <p:nvPr>
-            <p:ph type="body" idx="1"/>
-          </p:nvPr>
-        </p:nvSpPr>
-        <p:spPr/>
-        <p:txBody>
-          <a:bodyPr/>
-          <a:lstStyle/>
-          <a:p>
-            <a:r>
-              <a:rPr lang="en-US" dirty="0"/>
-              <a:t>Enfatizar: nenhuma ferramenta nova. A esteira roda sobre a infraestrutura que já existe. O investimento é em conhecimento (skills) e processo (artefatos), não em ferramentas.</a:t>
-            </a:r>
-            <a:endParaRPr lang="en-US" dirty="0"/>
-          </a:p>
-        </p:txBody>
-      </p:sp>
-      <p:sp>
-        <p:nvSpPr>
-          <p:cNvPr id="4" name="Slide Number Placeholder 3"/>
-          <p:cNvSpPr>
-            <a:spLocks noGrp="1"/>
-          </p:cNvSpPr>
-          <p:nvPr>
-            <p:ph type="sldNum" sz="quarter" idx="10"/>
-          </p:nvPr>
-        </p:nvSpPr>
-        <p:spPr/>
-        <p:txBody>
-          <a:bodyPr/>
-          <a:lstStyle/>
-          <a:p>
-            <a:fld id="{F7021451-1387-4CA6-816F-3879F97B5CBC}" type="slidenum">
-              <a:rPr lang="en-US"/>
-              <a:t>8</a:t>
             </a:fld>
             <a:endParaRPr lang="en-US"/>
           </a:p>
@@ -2484,7 +2395,7 @@
                 <a:ea typeface="Calibri" pitchFamily="34" charset="-122"/>
                 <a:cs typeface="Calibri" pitchFamily="34" charset="-120"/>
               </a:rPr>
-              <a:t>10 / 15</a:t>
+              <a:t>09 / 14</a:t>
             </a:r>
             <a:endParaRPr lang="en-US" sz="900" dirty="0"/>
           </a:p>
@@ -3440,7 +3351,7 @@
                 <a:ea typeface="Calibri" pitchFamily="34" charset="-122"/>
                 <a:cs typeface="Calibri" pitchFamily="34" charset="-120"/>
               </a:rPr>
-              <a:t>11 / 15</a:t>
+              <a:t>10 / 14</a:t>
             </a:r>
             <a:endParaRPr lang="en-US" sz="900" dirty="0"/>
           </a:p>
@@ -5813,7 +5724,7 @@
                 <a:ea typeface="Calibri" pitchFamily="34" charset="-122"/>
                 <a:cs typeface="Calibri" pitchFamily="34" charset="-120"/>
               </a:rPr>
-              <a:t>12 / 15</a:t>
+              <a:t>11 / 14</a:t>
             </a:r>
             <a:endParaRPr lang="en-US" sz="900" dirty="0"/>
           </a:p>
@@ -6709,7 +6620,7 @@
                 <a:ea typeface="Calibri" pitchFamily="34" charset="-122"/>
                 <a:cs typeface="Calibri" pitchFamily="34" charset="-120"/>
               </a:rPr>
-              <a:t>13 / 15</a:t>
+              <a:t>12 / 14</a:t>
             </a:r>
             <a:endParaRPr lang="en-US" sz="900" dirty="0"/>
           </a:p>
@@ -7331,7 +7242,7 @@
                 <a:ea typeface="Calibri" pitchFamily="34" charset="-122"/>
                 <a:cs typeface="Calibri" pitchFamily="34" charset="-120"/>
               </a:rPr>
-              <a:t>14 / 15</a:t>
+              <a:t>13 / 14</a:t>
             </a:r>
             <a:endParaRPr lang="en-US" sz="900" dirty="0"/>
           </a:p>
@@ -8940,7 +8851,7 @@
                 <a:ea typeface="Calibri" pitchFamily="34" charset="-122"/>
                 <a:cs typeface="Calibri" pitchFamily="34" charset="-120"/>
               </a:rPr>
-              <a:t>15 / 15</a:t>
+              <a:t>14 / 14</a:t>
             </a:r>
             <a:endParaRPr lang="en-US" sz="900" dirty="0"/>
           </a:p>
@@ -13971,1628 +13882,6 @@
 </p:sld>
 </file>
 
-<file path=ppt/slides/slide8.xml><?xml version="1.0" encoding="utf-8"?>
-<p:sld xmlns:a="http://schemas.openxmlformats.org/drawingml/2006/main" xmlns:r="http://schemas.openxmlformats.org/officeDocument/2006/relationships" xmlns:p="http://schemas.openxmlformats.org/presentationml/2006/main">
-  <p:cSld name="Slide 8">
-    <p:bg>
-      <p:bgPr>
-        <a:solidFill>
-          <a:srgbClr val="FFFFFF"/>
-        </a:solidFill>
-      </p:bgPr>
-    </p:bg>
-    <p:spTree>
-      <p:nvGrpSpPr>
-        <p:cNvPr id="1" name=""/>
-        <p:cNvGrpSpPr/>
-        <p:nvPr/>
-      </p:nvGrpSpPr>
-      <p:grpSpPr>
-        <a:xfrm>
-          <a:off x="0" y="0"/>
-          <a:ext cx="0" cy="0"/>
-          <a:chOff x="0" y="0"/>
-          <a:chExt cx="0" cy="0"/>
-        </a:xfrm>
-      </p:grpSpPr>
-      <p:sp>
-        <p:nvSpPr>
-          <p:cNvPr id="2" name="Text 0"/>
-          <p:cNvSpPr txBox="1"/>
-          <p:nvPr/>
-        </p:nvSpPr>
-        <p:spPr>
-          <a:xfrm>
-            <a:off x="640080" y="320040"/>
-            <a:ext cx="7863840" cy="502920"/>
-          </a:xfrm>
-          <a:prstGeom prst="rect">
-            <a:avLst/>
-          </a:prstGeom>
-          <a:noFill/>
-          <a:ln/>
-        </p:spPr>
-        <p:txBody>
-          <a:bodyPr wrap="square" lIns="0" tIns="0" rIns="0" bIns="0" rtlCol="0" anchor="ctr"/>
-          <a:lstStyle/>
-          <a:p>
-            <a:pPr indent="0" marL="0">
-              <a:buNone/>
-            </a:pPr>
-            <a:r>
-              <a:rPr lang="en-US" sz="2800" b="1" dirty="0">
-                <a:solidFill>
-                  <a:srgbClr val="0F172A"/>
-                </a:solidFill>
-                <a:latin typeface="Calibri" pitchFamily="34" charset="0"/>
-                <a:ea typeface="Calibri" pitchFamily="34" charset="-122"/>
-                <a:cs typeface="Calibri" pitchFamily="34" charset="-120"/>
-              </a:rPr>
-              <a:t>Infraestrutura existente</a:t>
-            </a:r>
-            <a:endParaRPr lang="en-US" sz="2800" dirty="0"/>
-          </a:p>
-        </p:txBody>
-      </p:sp>
-      <p:sp>
-        <p:nvSpPr>
-          <p:cNvPr id="3" name="Text 1"/>
-          <p:cNvSpPr txBox="1"/>
-          <p:nvPr/>
-        </p:nvSpPr>
-        <p:spPr>
-          <a:xfrm>
-            <a:off x="640080" y="822960"/>
-            <a:ext cx="7863840" cy="320040"/>
-          </a:xfrm>
-          <a:prstGeom prst="rect">
-            <a:avLst/>
-          </a:prstGeom>
-          <a:noFill/>
-          <a:ln/>
-        </p:spPr>
-        <p:txBody>
-          <a:bodyPr wrap="square" lIns="0" tIns="0" rIns="0" bIns="0" rtlCol="0" anchor="ctr"/>
-          <a:lstStyle/>
-          <a:p>
-            <a:pPr indent="0" marL="0">
-              <a:buNone/>
-            </a:pPr>
-            <a:r>
-              <a:rPr lang="en-US" sz="1300" dirty="0">
-                <a:solidFill>
-                  <a:srgbClr val="475569"/>
-                </a:solidFill>
-                <a:latin typeface="Calibri" pitchFamily="34" charset="0"/>
-                <a:ea typeface="Calibri" pitchFamily="34" charset="-122"/>
-                <a:cs typeface="Calibri" pitchFamily="34" charset="-120"/>
-              </a:rPr>
-              <a:t>Sem novo onboarding, sem novo contrato — tudo já está disponível</a:t>
-            </a:r>
-            <a:endParaRPr lang="en-US" sz="1300" dirty="0"/>
-          </a:p>
-        </p:txBody>
-      </p:sp>
-      <p:sp>
-        <p:nvSpPr>
-          <p:cNvPr id="4" name="Text 2"/>
-          <p:cNvSpPr txBox="1"/>
-          <p:nvPr/>
-        </p:nvSpPr>
-        <p:spPr>
-          <a:xfrm>
-            <a:off x="7955280" y="4736592"/>
-            <a:ext cx="914400" cy="274320"/>
-          </a:xfrm>
-          <a:prstGeom prst="rect">
-            <a:avLst/>
-          </a:prstGeom>
-          <a:noFill/>
-          <a:ln/>
-        </p:spPr>
-        <p:txBody>
-          <a:bodyPr wrap="square" rtlCol="0" anchor="ctr"/>
-          <a:lstStyle/>
-          <a:p>
-            <a:pPr algn="r" indent="0" marL="0">
-              <a:buNone/>
-            </a:pPr>
-            <a:r>
-              <a:rPr lang="en-US" sz="900" dirty="0">
-                <a:solidFill>
-                  <a:srgbClr val="94A3B8"/>
-                </a:solidFill>
-                <a:latin typeface="Calibri" pitchFamily="34" charset="0"/>
-                <a:ea typeface="Calibri" pitchFamily="34" charset="-122"/>
-                <a:cs typeface="Calibri" pitchFamily="34" charset="-120"/>
-              </a:rPr>
-              <a:t>08 / 15</a:t>
-            </a:r>
-            <a:endParaRPr lang="en-US" sz="900" dirty="0"/>
-          </a:p>
-        </p:txBody>
-      </p:sp>
-      <p:graphicFrame>
-        <p:nvGraphicFramePr>
-          <p:cNvPr id="9" name="Table 0"/>
-          <p:cNvGraphicFramePr>
-            <a:graphicFrameLocks noGrp="1"/>
-          </p:cNvGraphicFramePr>
-          <p:nvPr>
-            <p:extLst>
-              <p:ext uri="{D42A27DB-BD31-4B8C-83A1-F6EECF244321}">
-                <p14:modId xmlns:p14="http://schemas.microsoft.com/office/powerpoint/2010/main" val="1579011935"/>
-              </p:ext>
-            </p:extLst>
-          </p:nvPr>
-        </p:nvGraphicFramePr>
-        <p:xfrm>
-          <a:off x="640080" y="1371600"/>
-          <a:ext cx="7863840" cy="914400"/>
-        </p:xfrm>
-        <a:graphic>
-          <a:graphicData uri="http://schemas.openxmlformats.org/drawingml/2006/table">
-            <a:tbl>
-              <a:tblPr/>
-              <a:tblGrid>
-                <a:gridCol w="1828800"/>
-                <a:gridCol w="2560320"/>
-                <a:gridCol w="3474720"/>
-              </a:tblGrid>
-              <a:tr h="0">
-                <a:tc>
-                  <a:txBody>
-                    <a:bodyPr/>
-                    <a:lstStyle/>
-                    <a:p>
-                      <a:pPr algn="l" indent="0" marL="0">
-                        <a:buNone/>
-                      </a:pPr>
-                      <a:r>
-                        <a:rPr lang="en-US" sz="1200" b="1" dirty="0">
-                          <a:solidFill>
-                            <a:srgbClr val="FFFFFF"/>
-                          </a:solidFill>
-                          <a:latin typeface="Calibri" pitchFamily="34" charset="0"/>
-                          <a:ea typeface="Calibri" pitchFamily="34" charset="-122"/>
-                          <a:cs typeface="Calibri" pitchFamily="34" charset="-120"/>
-                        </a:rPr>
-                        <a:t>Dimensão</a:t>
-                      </a:r>
-                      <a:endParaRPr lang="en-US" sz="1200" dirty="0">
-                        <a:latin typeface="Calibri" charset="0"/>
-                        <a:ea typeface="Calibri" charset="0"/>
-                        <a:cs typeface="Calibri" charset="0"/>
-                      </a:endParaRPr>
-                    </a:p>
-                  </a:txBody>
-                  <a:tcPr marL="101600" marR="101600" marT="50800" marB="50800" anchor="ctr">
-                    <a:lnL w="6350" cap="flat" cmpd="sng" algn="ctr">
-                      <a:solidFill>
-                        <a:srgbClr val="DBEAFE"/>
-                      </a:solidFill>
-                      <a:prstDash val="solid"/>
-                      <a:round/>
-                      <a:headEnd type="none" w="med" len="med"/>
-                      <a:tailEnd type="none" w="med" len="med"/>
-                    </a:lnL>
-                    <a:lnR w="6350" cap="flat" cmpd="sng" algn="ctr">
-                      <a:solidFill>
-                        <a:srgbClr val="DBEAFE"/>
-                      </a:solidFill>
-                      <a:prstDash val="solid"/>
-                      <a:round/>
-                      <a:headEnd type="none" w="med" len="med"/>
-                      <a:tailEnd type="none" w="med" len="med"/>
-                    </a:lnR>
-                    <a:lnT w="6350" cap="flat" cmpd="sng" algn="ctr">
-                      <a:solidFill>
-                        <a:srgbClr val="DBEAFE"/>
-                      </a:solidFill>
-                      <a:prstDash val="solid"/>
-                      <a:round/>
-                      <a:headEnd type="none" w="med" len="med"/>
-                      <a:tailEnd type="none" w="med" len="med"/>
-                    </a:lnT>
-                    <a:lnB w="6350" cap="flat" cmpd="sng" algn="ctr">
-                      <a:solidFill>
-                        <a:srgbClr val="DBEAFE"/>
-                      </a:solidFill>
-                      <a:prstDash val="solid"/>
-                      <a:round/>
-                      <a:headEnd type="none" w="med" len="med"/>
-                      <a:tailEnd type="none" w="med" len="med"/>
-                    </a:lnB>
-                    <a:solidFill>
-                      <a:srgbClr val="2563EB"/>
-                    </a:solidFill>
-                  </a:tcPr>
-                </a:tc>
-                <a:tc>
-                  <a:txBody>
-                    <a:bodyPr/>
-                    <a:lstStyle/>
-                    <a:p>
-                      <a:pPr algn="l" indent="0" marL="0">
-                        <a:buNone/>
-                      </a:pPr>
-                      <a:r>
-                        <a:rPr lang="en-US" sz="1200" b="1" dirty="0">
-                          <a:solidFill>
-                            <a:srgbClr val="FFFFFF"/>
-                          </a:solidFill>
-                          <a:latin typeface="Calibri" pitchFamily="34" charset="0"/>
-                          <a:ea typeface="Calibri" pitchFamily="34" charset="-122"/>
-                          <a:cs typeface="Calibri" pitchFamily="34" charset="-120"/>
-                        </a:rPr>
-                        <a:t>Escolha</a:t>
-                      </a:r>
-                      <a:endParaRPr lang="en-US" sz="1200" dirty="0">
-                        <a:latin typeface="Calibri" charset="0"/>
-                        <a:ea typeface="Calibri" charset="0"/>
-                        <a:cs typeface="Calibri" charset="0"/>
-                      </a:endParaRPr>
-                    </a:p>
-                  </a:txBody>
-                  <a:tcPr marL="101600" marR="101600" marT="50800" marB="50800" anchor="ctr">
-                    <a:lnL w="6350" cap="flat" cmpd="sng" algn="ctr">
-                      <a:solidFill>
-                        <a:srgbClr val="DBEAFE"/>
-                      </a:solidFill>
-                      <a:prstDash val="solid"/>
-                      <a:round/>
-                      <a:headEnd type="none" w="med" len="med"/>
-                      <a:tailEnd type="none" w="med" len="med"/>
-                    </a:lnL>
-                    <a:lnR w="6350" cap="flat" cmpd="sng" algn="ctr">
-                      <a:solidFill>
-                        <a:srgbClr val="DBEAFE"/>
-                      </a:solidFill>
-                      <a:prstDash val="solid"/>
-                      <a:round/>
-                      <a:headEnd type="none" w="med" len="med"/>
-                      <a:tailEnd type="none" w="med" len="med"/>
-                    </a:lnR>
-                    <a:lnT w="6350" cap="flat" cmpd="sng" algn="ctr">
-                      <a:solidFill>
-                        <a:srgbClr val="DBEAFE"/>
-                      </a:solidFill>
-                      <a:prstDash val="solid"/>
-                      <a:round/>
-                      <a:headEnd type="none" w="med" len="med"/>
-                      <a:tailEnd type="none" w="med" len="med"/>
-                    </a:lnT>
-                    <a:lnB w="6350" cap="flat" cmpd="sng" algn="ctr">
-                      <a:solidFill>
-                        <a:srgbClr val="DBEAFE"/>
-                      </a:solidFill>
-                      <a:prstDash val="solid"/>
-                      <a:round/>
-                      <a:headEnd type="none" w="med" len="med"/>
-                      <a:tailEnd type="none" w="med" len="med"/>
-                    </a:lnB>
-                    <a:solidFill>
-                      <a:srgbClr val="2563EB"/>
-                    </a:solidFill>
-                  </a:tcPr>
-                </a:tc>
-                <a:tc>
-                  <a:txBody>
-                    <a:bodyPr/>
-                    <a:lstStyle/>
-                    <a:p>
-                      <a:pPr algn="l" indent="0" marL="0">
-                        <a:buNone/>
-                      </a:pPr>
-                      <a:r>
-                        <a:rPr lang="en-US" sz="1200" b="1" dirty="0">
-                          <a:solidFill>
-                            <a:srgbClr val="FFFFFF"/>
-                          </a:solidFill>
-                          <a:latin typeface="Calibri" pitchFamily="34" charset="0"/>
-                          <a:ea typeface="Calibri" pitchFamily="34" charset="-122"/>
-                          <a:cs typeface="Calibri" pitchFamily="34" charset="-120"/>
-                        </a:rPr>
-                        <a:t>Raciocínio</a:t>
-                      </a:r>
-                      <a:endParaRPr lang="en-US" sz="1200" dirty="0">
-                        <a:latin typeface="Calibri" charset="0"/>
-                        <a:ea typeface="Calibri" charset="0"/>
-                        <a:cs typeface="Calibri" charset="0"/>
-                      </a:endParaRPr>
-                    </a:p>
-                  </a:txBody>
-                  <a:tcPr marL="101600" marR="101600" marT="50800" marB="50800" anchor="ctr">
-                    <a:lnL w="6350" cap="flat" cmpd="sng" algn="ctr">
-                      <a:solidFill>
-                        <a:srgbClr val="DBEAFE"/>
-                      </a:solidFill>
-                      <a:prstDash val="solid"/>
-                      <a:round/>
-                      <a:headEnd type="none" w="med" len="med"/>
-                      <a:tailEnd type="none" w="med" len="med"/>
-                    </a:lnL>
-                    <a:lnR w="6350" cap="flat" cmpd="sng" algn="ctr">
-                      <a:solidFill>
-                        <a:srgbClr val="DBEAFE"/>
-                      </a:solidFill>
-                      <a:prstDash val="solid"/>
-                      <a:round/>
-                      <a:headEnd type="none" w="med" len="med"/>
-                      <a:tailEnd type="none" w="med" len="med"/>
-                    </a:lnR>
-                    <a:lnT w="6350" cap="flat" cmpd="sng" algn="ctr">
-                      <a:solidFill>
-                        <a:srgbClr val="DBEAFE"/>
-                      </a:solidFill>
-                      <a:prstDash val="solid"/>
-                      <a:round/>
-                      <a:headEnd type="none" w="med" len="med"/>
-                      <a:tailEnd type="none" w="med" len="med"/>
-                    </a:lnT>
-                    <a:lnB w="6350" cap="flat" cmpd="sng" algn="ctr">
-                      <a:solidFill>
-                        <a:srgbClr val="DBEAFE"/>
-                      </a:solidFill>
-                      <a:prstDash val="solid"/>
-                      <a:round/>
-                      <a:headEnd type="none" w="med" len="med"/>
-                      <a:tailEnd type="none" w="med" len="med"/>
-                    </a:lnB>
-                    <a:solidFill>
-                      <a:srgbClr val="2563EB"/>
-                    </a:solidFill>
-                  </a:tcPr>
-                </a:tc>
-              </a:tr>
-              <a:tr h="0">
-                <a:tc>
-                  <a:txBody>
-                    <a:bodyPr/>
-                    <a:lstStyle/>
-                    <a:p>
-                      <a:pPr algn="l" indent="0" marL="0">
-                        <a:buNone/>
-                      </a:pPr>
-                      <a:r>
-                        <a:rPr lang="en-US" sz="1200" dirty="0">
-                          <a:solidFill>
-                            <a:srgbClr val="0F172A"/>
-                          </a:solidFill>
-                          <a:latin typeface="Calibri" pitchFamily="34" charset="0"/>
-                          <a:ea typeface="Calibri" pitchFamily="34" charset="-122"/>
-                          <a:cs typeface="Calibri" pitchFamily="34" charset="-120"/>
-                        </a:rPr>
-                        <a:t>Runtime de IA</a:t>
-                      </a:r>
-                      <a:endParaRPr lang="en-US" sz="1200" dirty="0">
-                        <a:latin typeface="Calibri" charset="0"/>
-                        <a:ea typeface="Calibri" charset="0"/>
-                        <a:cs typeface="Calibri" charset="0"/>
-                      </a:endParaRPr>
-                    </a:p>
-                  </a:txBody>
-                  <a:tcPr marL="101600" marR="101600" marT="50800" marB="50800" anchor="ctr">
-                    <a:lnL w="6350" cap="flat" cmpd="sng" algn="ctr">
-                      <a:solidFill>
-                        <a:srgbClr val="DBEAFE"/>
-                      </a:solidFill>
-                      <a:prstDash val="solid"/>
-                      <a:round/>
-                      <a:headEnd type="none" w="med" len="med"/>
-                      <a:tailEnd type="none" w="med" len="med"/>
-                    </a:lnL>
-                    <a:lnR w="6350" cap="flat" cmpd="sng" algn="ctr">
-                      <a:solidFill>
-                        <a:srgbClr val="DBEAFE"/>
-                      </a:solidFill>
-                      <a:prstDash val="solid"/>
-                      <a:round/>
-                      <a:headEnd type="none" w="med" len="med"/>
-                      <a:tailEnd type="none" w="med" len="med"/>
-                    </a:lnR>
-                    <a:lnT w="6350" cap="flat" cmpd="sng" algn="ctr">
-                      <a:solidFill>
-                        <a:srgbClr val="DBEAFE"/>
-                      </a:solidFill>
-                      <a:prstDash val="solid"/>
-                      <a:round/>
-                      <a:headEnd type="none" w="med" len="med"/>
-                      <a:tailEnd type="none" w="med" len="med"/>
-                    </a:lnT>
-                    <a:lnB w="6350" cap="flat" cmpd="sng" algn="ctr">
-                      <a:solidFill>
-                        <a:srgbClr val="DBEAFE"/>
-                      </a:solidFill>
-                      <a:prstDash val="solid"/>
-                      <a:round/>
-                      <a:headEnd type="none" w="med" len="med"/>
-                      <a:tailEnd type="none" w="med" len="med"/>
-                    </a:lnB>
-                    <a:solidFill>
-                      <a:srgbClr val="FFFFFF"/>
-                    </a:solidFill>
-                  </a:tcPr>
-                </a:tc>
-                <a:tc>
-                  <a:txBody>
-                    <a:bodyPr/>
-                    <a:lstStyle/>
-                    <a:p>
-                      <a:pPr algn="l" indent="0" marL="0">
-                        <a:buNone/>
-                      </a:pPr>
-                      <a:r>
-                        <a:rPr lang="en-US" sz="1200" b="1" dirty="0">
-                          <a:solidFill>
-                            <a:srgbClr val="0F172A"/>
-                          </a:solidFill>
-                          <a:latin typeface="Calibri" pitchFamily="34" charset="0"/>
-                          <a:ea typeface="Calibri" pitchFamily="34" charset="-122"/>
-                          <a:cs typeface="Calibri" pitchFamily="34" charset="-120"/>
-                        </a:rPr>
-                        <a:t>GitHub Copilot Enterprise</a:t>
-                      </a:r>
-                      <a:endParaRPr lang="en-US" sz="1200" dirty="0">
-                        <a:latin typeface="Calibri" charset="0"/>
-                        <a:ea typeface="Calibri" charset="0"/>
-                        <a:cs typeface="Calibri" charset="0"/>
-                      </a:endParaRPr>
-                    </a:p>
-                  </a:txBody>
-                  <a:tcPr marL="101600" marR="101600" marT="50800" marB="50800" anchor="ctr">
-                    <a:lnL w="6350" cap="flat" cmpd="sng" algn="ctr">
-                      <a:solidFill>
-                        <a:srgbClr val="DBEAFE"/>
-                      </a:solidFill>
-                      <a:prstDash val="solid"/>
-                      <a:round/>
-                      <a:headEnd type="none" w="med" len="med"/>
-                      <a:tailEnd type="none" w="med" len="med"/>
-                    </a:lnL>
-                    <a:lnR w="6350" cap="flat" cmpd="sng" algn="ctr">
-                      <a:solidFill>
-                        <a:srgbClr val="DBEAFE"/>
-                      </a:solidFill>
-                      <a:prstDash val="solid"/>
-                      <a:round/>
-                      <a:headEnd type="none" w="med" len="med"/>
-                      <a:tailEnd type="none" w="med" len="med"/>
-                    </a:lnR>
-                    <a:lnT w="6350" cap="flat" cmpd="sng" algn="ctr">
-                      <a:solidFill>
-                        <a:srgbClr val="DBEAFE"/>
-                      </a:solidFill>
-                      <a:prstDash val="solid"/>
-                      <a:round/>
-                      <a:headEnd type="none" w="med" len="med"/>
-                      <a:tailEnd type="none" w="med" len="med"/>
-                    </a:lnT>
-                    <a:lnB w="6350" cap="flat" cmpd="sng" algn="ctr">
-                      <a:solidFill>
-                        <a:srgbClr val="DBEAFE"/>
-                      </a:solidFill>
-                      <a:prstDash val="solid"/>
-                      <a:round/>
-                      <a:headEnd type="none" w="med" len="med"/>
-                      <a:tailEnd type="none" w="med" len="med"/>
-                    </a:lnB>
-                    <a:solidFill>
-                      <a:srgbClr val="FFFFFF"/>
-                    </a:solidFill>
-                  </a:tcPr>
-                </a:tc>
-                <a:tc>
-                  <a:txBody>
-                    <a:bodyPr/>
-                    <a:lstStyle/>
-                    <a:p>
-                      <a:pPr algn="l" indent="0" marL="0">
-                        <a:buNone/>
-                      </a:pPr>
-                      <a:r>
-                        <a:rPr lang="en-US" sz="1100" dirty="0">
-                          <a:solidFill>
-                            <a:srgbClr val="475569"/>
-                          </a:solidFill>
-                          <a:latin typeface="Calibri" pitchFamily="34" charset="0"/>
-                          <a:ea typeface="Calibri" pitchFamily="34" charset="-122"/>
-                          <a:cs typeface="Calibri" pitchFamily="34" charset="-120"/>
-                        </a:rPr>
-                        <a:t>Já padronizado na organização</a:t>
-                      </a:r>
-                      <a:endParaRPr lang="en-US" sz="1100" dirty="0">
-                        <a:latin typeface="Calibri" charset="0"/>
-                        <a:ea typeface="Calibri" charset="0"/>
-                        <a:cs typeface="Calibri" charset="0"/>
-                      </a:endParaRPr>
-                    </a:p>
-                  </a:txBody>
-                  <a:tcPr marL="101600" marR="101600" marT="50800" marB="50800" anchor="ctr">
-                    <a:lnL w="6350" cap="flat" cmpd="sng" algn="ctr">
-                      <a:solidFill>
-                        <a:srgbClr val="DBEAFE"/>
-                      </a:solidFill>
-                      <a:prstDash val="solid"/>
-                      <a:round/>
-                      <a:headEnd type="none" w="med" len="med"/>
-                      <a:tailEnd type="none" w="med" len="med"/>
-                    </a:lnL>
-                    <a:lnR w="6350" cap="flat" cmpd="sng" algn="ctr">
-                      <a:solidFill>
-                        <a:srgbClr val="DBEAFE"/>
-                      </a:solidFill>
-                      <a:prstDash val="solid"/>
-                      <a:round/>
-                      <a:headEnd type="none" w="med" len="med"/>
-                      <a:tailEnd type="none" w="med" len="med"/>
-                    </a:lnR>
-                    <a:lnT w="6350" cap="flat" cmpd="sng" algn="ctr">
-                      <a:solidFill>
-                        <a:srgbClr val="DBEAFE"/>
-                      </a:solidFill>
-                      <a:prstDash val="solid"/>
-                      <a:round/>
-                      <a:headEnd type="none" w="med" len="med"/>
-                      <a:tailEnd type="none" w="med" len="med"/>
-                    </a:lnT>
-                    <a:lnB w="6350" cap="flat" cmpd="sng" algn="ctr">
-                      <a:solidFill>
-                        <a:srgbClr val="DBEAFE"/>
-                      </a:solidFill>
-                      <a:prstDash val="solid"/>
-                      <a:round/>
-                      <a:headEnd type="none" w="med" len="med"/>
-                      <a:tailEnd type="none" w="med" len="med"/>
-                    </a:lnB>
-                    <a:solidFill>
-                      <a:srgbClr val="FFFFFF"/>
-                    </a:solidFill>
-                  </a:tcPr>
-                </a:tc>
-              </a:tr>
-              <a:tr h="0">
-                <a:tc>
-                  <a:txBody>
-                    <a:bodyPr/>
-                    <a:lstStyle/>
-                    <a:p>
-                      <a:pPr algn="l" indent="0" marL="0">
-                        <a:buNone/>
-                      </a:pPr>
-                      <a:r>
-                        <a:rPr lang="en-US" sz="1200" dirty="0">
-                          <a:solidFill>
-                            <a:srgbClr val="0F172A"/>
-                          </a:solidFill>
-                          <a:latin typeface="Calibri" pitchFamily="34" charset="0"/>
-                          <a:ea typeface="Calibri" pitchFamily="34" charset="-122"/>
-                          <a:cs typeface="Calibri" pitchFamily="34" charset="-120"/>
-                        </a:rPr>
-                        <a:t>Stack</a:t>
-                      </a:r>
-                      <a:endParaRPr lang="en-US" sz="1200" dirty="0">
-                        <a:latin typeface="Calibri" charset="0"/>
-                        <a:ea typeface="Calibri" charset="0"/>
-                        <a:cs typeface="Calibri" charset="0"/>
-                      </a:endParaRPr>
-                    </a:p>
-                  </a:txBody>
-                  <a:tcPr marL="101600" marR="101600" marT="50800" marB="50800" anchor="ctr">
-                    <a:lnL w="6350" cap="flat" cmpd="sng" algn="ctr">
-                      <a:solidFill>
-                        <a:srgbClr val="DBEAFE"/>
-                      </a:solidFill>
-                      <a:prstDash val="solid"/>
-                      <a:round/>
-                      <a:headEnd type="none" w="med" len="med"/>
-                      <a:tailEnd type="none" w="med" len="med"/>
-                    </a:lnL>
-                    <a:lnR w="6350" cap="flat" cmpd="sng" algn="ctr">
-                      <a:solidFill>
-                        <a:srgbClr val="DBEAFE"/>
-                      </a:solidFill>
-                      <a:prstDash val="solid"/>
-                      <a:round/>
-                      <a:headEnd type="none" w="med" len="med"/>
-                      <a:tailEnd type="none" w="med" len="med"/>
-                    </a:lnR>
-                    <a:lnT w="6350" cap="flat" cmpd="sng" algn="ctr">
-                      <a:solidFill>
-                        <a:srgbClr val="DBEAFE"/>
-                      </a:solidFill>
-                      <a:prstDash val="solid"/>
-                      <a:round/>
-                      <a:headEnd type="none" w="med" len="med"/>
-                      <a:tailEnd type="none" w="med" len="med"/>
-                    </a:lnT>
-                    <a:lnB w="6350" cap="flat" cmpd="sng" algn="ctr">
-                      <a:solidFill>
-                        <a:srgbClr val="DBEAFE"/>
-                      </a:solidFill>
-                      <a:prstDash val="solid"/>
-                      <a:round/>
-                      <a:headEnd type="none" w="med" len="med"/>
-                      <a:tailEnd type="none" w="med" len="med"/>
-                    </a:lnB>
-                    <a:solidFill>
-                      <a:srgbClr val="F8FAFC"/>
-                    </a:solidFill>
-                  </a:tcPr>
-                </a:tc>
-                <a:tc>
-                  <a:txBody>
-                    <a:bodyPr/>
-                    <a:lstStyle/>
-                    <a:p>
-                      <a:pPr algn="l" indent="0" marL="0">
-                        <a:buNone/>
-                      </a:pPr>
-                      <a:r>
-                        <a:rPr lang="en-US" sz="1200" b="1" dirty="0">
-                          <a:solidFill>
-                            <a:srgbClr val="0F172A"/>
-                          </a:solidFill>
-                          <a:latin typeface="Calibri" pitchFamily="34" charset="0"/>
-                          <a:ea typeface="Calibri" pitchFamily="34" charset="-122"/>
-                          <a:cs typeface="Calibri" pitchFamily="34" charset="-120"/>
-                        </a:rPr>
-                        <a:t>React Native multi-bundle</a:t>
-                      </a:r>
-                      <a:endParaRPr lang="en-US" sz="1200" dirty="0">
-                        <a:latin typeface="Calibri" charset="0"/>
-                        <a:ea typeface="Calibri" charset="0"/>
-                        <a:cs typeface="Calibri" charset="0"/>
-                      </a:endParaRPr>
-                    </a:p>
-                  </a:txBody>
-                  <a:tcPr marL="101600" marR="101600" marT="50800" marB="50800" anchor="ctr">
-                    <a:lnL w="6350" cap="flat" cmpd="sng" algn="ctr">
-                      <a:solidFill>
-                        <a:srgbClr val="DBEAFE"/>
-                      </a:solidFill>
-                      <a:prstDash val="solid"/>
-                      <a:round/>
-                      <a:headEnd type="none" w="med" len="med"/>
-                      <a:tailEnd type="none" w="med" len="med"/>
-                    </a:lnL>
-                    <a:lnR w="6350" cap="flat" cmpd="sng" algn="ctr">
-                      <a:solidFill>
-                        <a:srgbClr val="DBEAFE"/>
-                      </a:solidFill>
-                      <a:prstDash val="solid"/>
-                      <a:round/>
-                      <a:headEnd type="none" w="med" len="med"/>
-                      <a:tailEnd type="none" w="med" len="med"/>
-                    </a:lnR>
-                    <a:lnT w="6350" cap="flat" cmpd="sng" algn="ctr">
-                      <a:solidFill>
-                        <a:srgbClr val="DBEAFE"/>
-                      </a:solidFill>
-                      <a:prstDash val="solid"/>
-                      <a:round/>
-                      <a:headEnd type="none" w="med" len="med"/>
-                      <a:tailEnd type="none" w="med" len="med"/>
-                    </a:lnT>
-                    <a:lnB w="6350" cap="flat" cmpd="sng" algn="ctr">
-                      <a:solidFill>
-                        <a:srgbClr val="DBEAFE"/>
-                      </a:solidFill>
-                      <a:prstDash val="solid"/>
-                      <a:round/>
-                      <a:headEnd type="none" w="med" len="med"/>
-                      <a:tailEnd type="none" w="med" len="med"/>
-                    </a:lnB>
-                    <a:solidFill>
-                      <a:srgbClr val="F8FAFC"/>
-                    </a:solidFill>
-                  </a:tcPr>
-                </a:tc>
-                <a:tc>
-                  <a:txBody>
-                    <a:bodyPr/>
-                    <a:lstStyle/>
-                    <a:p>
-                      <a:pPr algn="l" indent="0" marL="0">
-                        <a:buNone/>
-                      </a:pPr>
-                      <a:r>
-                        <a:rPr lang="en-US" sz="1100" dirty="0">
-                          <a:solidFill>
-                            <a:srgbClr val="475569"/>
-                          </a:solidFill>
-                          <a:latin typeface="Calibri" pitchFamily="34" charset="0"/>
-                          <a:ea typeface="Calibri" pitchFamily="34" charset="-122"/>
-                          <a:cs typeface="Calibri" pitchFamily="34" charset="-120"/>
-                        </a:rPr>
-                        <a:t>Contexto atual da plataforma</a:t>
-                      </a:r>
-                      <a:endParaRPr lang="en-US" sz="1100" dirty="0">
-                        <a:latin typeface="Calibri" charset="0"/>
-                        <a:ea typeface="Calibri" charset="0"/>
-                        <a:cs typeface="Calibri" charset="0"/>
-                      </a:endParaRPr>
-                    </a:p>
-                  </a:txBody>
-                  <a:tcPr marL="101600" marR="101600" marT="50800" marB="50800" anchor="ctr">
-                    <a:lnL w="6350" cap="flat" cmpd="sng" algn="ctr">
-                      <a:solidFill>
-                        <a:srgbClr val="DBEAFE"/>
-                      </a:solidFill>
-                      <a:prstDash val="solid"/>
-                      <a:round/>
-                      <a:headEnd type="none" w="med" len="med"/>
-                      <a:tailEnd type="none" w="med" len="med"/>
-                    </a:lnL>
-                    <a:lnR w="6350" cap="flat" cmpd="sng" algn="ctr">
-                      <a:solidFill>
-                        <a:srgbClr val="DBEAFE"/>
-                      </a:solidFill>
-                      <a:prstDash val="solid"/>
-                      <a:round/>
-                      <a:headEnd type="none" w="med" len="med"/>
-                      <a:tailEnd type="none" w="med" len="med"/>
-                    </a:lnR>
-                    <a:lnT w="6350" cap="flat" cmpd="sng" algn="ctr">
-                      <a:solidFill>
-                        <a:srgbClr val="DBEAFE"/>
-                      </a:solidFill>
-                      <a:prstDash val="solid"/>
-                      <a:round/>
-                      <a:headEnd type="none" w="med" len="med"/>
-                      <a:tailEnd type="none" w="med" len="med"/>
-                    </a:lnT>
-                    <a:lnB w="6350" cap="flat" cmpd="sng" algn="ctr">
-                      <a:solidFill>
-                        <a:srgbClr val="DBEAFE"/>
-                      </a:solidFill>
-                      <a:prstDash val="solid"/>
-                      <a:round/>
-                      <a:headEnd type="none" w="med" len="med"/>
-                      <a:tailEnd type="none" w="med" len="med"/>
-                    </a:lnB>
-                    <a:solidFill>
-                      <a:srgbClr val="F8FAFC"/>
-                    </a:solidFill>
-                  </a:tcPr>
-                </a:tc>
-              </a:tr>
-              <a:tr h="0">
-                <a:tc>
-                  <a:txBody>
-                    <a:bodyPr/>
-                    <a:lstStyle/>
-                    <a:p>
-                      <a:pPr algn="l" indent="0" marL="0">
-                        <a:buNone/>
-                      </a:pPr>
-                      <a:r>
-                        <a:rPr lang="en-US" sz="1200" dirty="0">
-                          <a:solidFill>
-                            <a:srgbClr val="0F172A"/>
-                          </a:solidFill>
-                          <a:latin typeface="Calibri" pitchFamily="34" charset="0"/>
-                          <a:ea typeface="Calibri" pitchFamily="34" charset="-122"/>
-                          <a:cs typeface="Calibri" pitchFamily="34" charset="-120"/>
-                        </a:rPr>
-                        <a:t>Gestão de backlog</a:t>
-                      </a:r>
-                      <a:endParaRPr lang="en-US" sz="1200" dirty="0">
-                        <a:latin typeface="Calibri" charset="0"/>
-                        <a:ea typeface="Calibri" charset="0"/>
-                        <a:cs typeface="Calibri" charset="0"/>
-                      </a:endParaRPr>
-                    </a:p>
-                  </a:txBody>
-                  <a:tcPr marL="101600" marR="101600" marT="50800" marB="50800" anchor="ctr">
-                    <a:lnL w="6350" cap="flat" cmpd="sng" algn="ctr">
-                      <a:solidFill>
-                        <a:srgbClr val="DBEAFE"/>
-                      </a:solidFill>
-                      <a:prstDash val="solid"/>
-                      <a:round/>
-                      <a:headEnd type="none" w="med" len="med"/>
-                      <a:tailEnd type="none" w="med" len="med"/>
-                    </a:lnL>
-                    <a:lnR w="6350" cap="flat" cmpd="sng" algn="ctr">
-                      <a:solidFill>
-                        <a:srgbClr val="DBEAFE"/>
-                      </a:solidFill>
-                      <a:prstDash val="solid"/>
-                      <a:round/>
-                      <a:headEnd type="none" w="med" len="med"/>
-                      <a:tailEnd type="none" w="med" len="med"/>
-                    </a:lnR>
-                    <a:lnT w="6350" cap="flat" cmpd="sng" algn="ctr">
-                      <a:solidFill>
-                        <a:srgbClr val="DBEAFE"/>
-                      </a:solidFill>
-                      <a:prstDash val="solid"/>
-                      <a:round/>
-                      <a:headEnd type="none" w="med" len="med"/>
-                      <a:tailEnd type="none" w="med" len="med"/>
-                    </a:lnT>
-                    <a:lnB w="6350" cap="flat" cmpd="sng" algn="ctr">
-                      <a:solidFill>
-                        <a:srgbClr val="DBEAFE"/>
-                      </a:solidFill>
-                      <a:prstDash val="solid"/>
-                      <a:round/>
-                      <a:headEnd type="none" w="med" len="med"/>
-                      <a:tailEnd type="none" w="med" len="med"/>
-                    </a:lnB>
-                    <a:solidFill>
-                      <a:srgbClr val="FFFFFF"/>
-                    </a:solidFill>
-                  </a:tcPr>
-                </a:tc>
-                <a:tc>
-                  <a:txBody>
-                    <a:bodyPr/>
-                    <a:lstStyle/>
-                    <a:p>
-                      <a:pPr algn="l" indent="0" marL="0">
-                        <a:buNone/>
-                      </a:pPr>
-                      <a:r>
-                        <a:rPr lang="en-US" sz="1200" b="1" dirty="0">
-                          <a:solidFill>
-                            <a:srgbClr val="0F172A"/>
-                          </a:solidFill>
-                          <a:latin typeface="Calibri" pitchFamily="34" charset="0"/>
-                          <a:ea typeface="Calibri" pitchFamily="34" charset="-122"/>
-                          <a:cs typeface="Calibri" pitchFamily="34" charset="-120"/>
-                        </a:rPr>
-                        <a:t>BusinessMap (MCP existente)</a:t>
-                      </a:r>
-                      <a:endParaRPr lang="en-US" sz="1200" dirty="0">
-                        <a:latin typeface="Calibri" charset="0"/>
-                        <a:ea typeface="Calibri" charset="0"/>
-                        <a:cs typeface="Calibri" charset="0"/>
-                      </a:endParaRPr>
-                    </a:p>
-                  </a:txBody>
-                  <a:tcPr marL="101600" marR="101600" marT="50800" marB="50800" anchor="ctr">
-                    <a:lnL w="6350" cap="flat" cmpd="sng" algn="ctr">
-                      <a:solidFill>
-                        <a:srgbClr val="DBEAFE"/>
-                      </a:solidFill>
-                      <a:prstDash val="solid"/>
-                      <a:round/>
-                      <a:headEnd type="none" w="med" len="med"/>
-                      <a:tailEnd type="none" w="med" len="med"/>
-                    </a:lnL>
-                    <a:lnR w="6350" cap="flat" cmpd="sng" algn="ctr">
-                      <a:solidFill>
-                        <a:srgbClr val="DBEAFE"/>
-                      </a:solidFill>
-                      <a:prstDash val="solid"/>
-                      <a:round/>
-                      <a:headEnd type="none" w="med" len="med"/>
-                      <a:tailEnd type="none" w="med" len="med"/>
-                    </a:lnR>
-                    <a:lnT w="6350" cap="flat" cmpd="sng" algn="ctr">
-                      <a:solidFill>
-                        <a:srgbClr val="DBEAFE"/>
-                      </a:solidFill>
-                      <a:prstDash val="solid"/>
-                      <a:round/>
-                      <a:headEnd type="none" w="med" len="med"/>
-                      <a:tailEnd type="none" w="med" len="med"/>
-                    </a:lnT>
-                    <a:lnB w="6350" cap="flat" cmpd="sng" algn="ctr">
-                      <a:solidFill>
-                        <a:srgbClr val="DBEAFE"/>
-                      </a:solidFill>
-                      <a:prstDash val="solid"/>
-                      <a:round/>
-                      <a:headEnd type="none" w="med" len="med"/>
-                      <a:tailEnd type="none" w="med" len="med"/>
-                    </a:lnB>
-                    <a:solidFill>
-                      <a:srgbClr val="FFFFFF"/>
-                    </a:solidFill>
-                  </a:tcPr>
-                </a:tc>
-                <a:tc>
-                  <a:txBody>
-                    <a:bodyPr/>
-                    <a:lstStyle/>
-                    <a:p>
-                      <a:pPr algn="l" indent="0" marL="0">
-                        <a:buNone/>
-                      </a:pPr>
-                      <a:r>
-                        <a:rPr lang="en-US" sz="1100" dirty="0">
-                          <a:solidFill>
-                            <a:srgbClr val="475569"/>
-                          </a:solidFill>
-                          <a:latin typeface="Calibri" pitchFamily="34" charset="0"/>
-                          <a:ea typeface="Calibri" pitchFamily="34" charset="-122"/>
-                          <a:cs typeface="Calibri" pitchFamily="34" charset="-120"/>
-                        </a:rPr>
-                        <a:t>Integração sem desenvolvimento</a:t>
-                      </a:r>
-                      <a:endParaRPr lang="en-US" sz="1100" dirty="0">
-                        <a:latin typeface="Calibri" charset="0"/>
-                        <a:ea typeface="Calibri" charset="0"/>
-                        <a:cs typeface="Calibri" charset="0"/>
-                      </a:endParaRPr>
-                    </a:p>
-                  </a:txBody>
-                  <a:tcPr marL="101600" marR="101600" marT="50800" marB="50800" anchor="ctr">
-                    <a:lnL w="6350" cap="flat" cmpd="sng" algn="ctr">
-                      <a:solidFill>
-                        <a:srgbClr val="DBEAFE"/>
-                      </a:solidFill>
-                      <a:prstDash val="solid"/>
-                      <a:round/>
-                      <a:headEnd type="none" w="med" len="med"/>
-                      <a:tailEnd type="none" w="med" len="med"/>
-                    </a:lnL>
-                    <a:lnR w="6350" cap="flat" cmpd="sng" algn="ctr">
-                      <a:solidFill>
-                        <a:srgbClr val="DBEAFE"/>
-                      </a:solidFill>
-                      <a:prstDash val="solid"/>
-                      <a:round/>
-                      <a:headEnd type="none" w="med" len="med"/>
-                      <a:tailEnd type="none" w="med" len="med"/>
-                    </a:lnR>
-                    <a:lnT w="6350" cap="flat" cmpd="sng" algn="ctr">
-                      <a:solidFill>
-                        <a:srgbClr val="DBEAFE"/>
-                      </a:solidFill>
-                      <a:prstDash val="solid"/>
-                      <a:round/>
-                      <a:headEnd type="none" w="med" len="med"/>
-                      <a:tailEnd type="none" w="med" len="med"/>
-                    </a:lnT>
-                    <a:lnB w="6350" cap="flat" cmpd="sng" algn="ctr">
-                      <a:solidFill>
-                        <a:srgbClr val="DBEAFE"/>
-                      </a:solidFill>
-                      <a:prstDash val="solid"/>
-                      <a:round/>
-                      <a:headEnd type="none" w="med" len="med"/>
-                      <a:tailEnd type="none" w="med" len="med"/>
-                    </a:lnB>
-                    <a:solidFill>
-                      <a:srgbClr val="FFFFFF"/>
-                    </a:solidFill>
-                  </a:tcPr>
-                </a:tc>
-              </a:tr>
-              <a:tr h="0">
-                <a:tc>
-                  <a:txBody>
-                    <a:bodyPr/>
-                    <a:lstStyle/>
-                    <a:p>
-                      <a:pPr algn="l" indent="0" marL="0">
-                        <a:buNone/>
-                      </a:pPr>
-                      <a:r>
-                        <a:rPr lang="en-US" sz="1200" dirty="0">
-                          <a:solidFill>
-                            <a:srgbClr val="0F172A"/>
-                          </a:solidFill>
-                          <a:latin typeface="Calibri" pitchFamily="34" charset="0"/>
-                          <a:ea typeface="Calibri" pitchFamily="34" charset="-122"/>
-                          <a:cs typeface="Calibri" pitchFamily="34" charset="-120"/>
-                        </a:rPr>
-                        <a:t>Design</a:t>
-                      </a:r>
-                      <a:endParaRPr lang="en-US" sz="1200" dirty="0">
-                        <a:latin typeface="Calibri" charset="0"/>
-                        <a:ea typeface="Calibri" charset="0"/>
-                        <a:cs typeface="Calibri" charset="0"/>
-                      </a:endParaRPr>
-                    </a:p>
-                  </a:txBody>
-                  <a:tcPr marL="101600" marR="101600" marT="50800" marB="50800" anchor="ctr">
-                    <a:lnL w="6350" cap="flat" cmpd="sng" algn="ctr">
-                      <a:solidFill>
-                        <a:srgbClr val="DBEAFE"/>
-                      </a:solidFill>
-                      <a:prstDash val="solid"/>
-                      <a:round/>
-                      <a:headEnd type="none" w="med" len="med"/>
-                      <a:tailEnd type="none" w="med" len="med"/>
-                    </a:lnL>
-                    <a:lnR w="6350" cap="flat" cmpd="sng" algn="ctr">
-                      <a:solidFill>
-                        <a:srgbClr val="DBEAFE"/>
-                      </a:solidFill>
-                      <a:prstDash val="solid"/>
-                      <a:round/>
-                      <a:headEnd type="none" w="med" len="med"/>
-                      <a:tailEnd type="none" w="med" len="med"/>
-                    </a:lnR>
-                    <a:lnT w="6350" cap="flat" cmpd="sng" algn="ctr">
-                      <a:solidFill>
-                        <a:srgbClr val="DBEAFE"/>
-                      </a:solidFill>
-                      <a:prstDash val="solid"/>
-                      <a:round/>
-                      <a:headEnd type="none" w="med" len="med"/>
-                      <a:tailEnd type="none" w="med" len="med"/>
-                    </a:lnT>
-                    <a:lnB w="6350" cap="flat" cmpd="sng" algn="ctr">
-                      <a:solidFill>
-                        <a:srgbClr val="DBEAFE"/>
-                      </a:solidFill>
-                      <a:prstDash val="solid"/>
-                      <a:round/>
-                      <a:headEnd type="none" w="med" len="med"/>
-                      <a:tailEnd type="none" w="med" len="med"/>
-                    </a:lnB>
-                    <a:solidFill>
-                      <a:srgbClr val="F8FAFC"/>
-                    </a:solidFill>
-                  </a:tcPr>
-                </a:tc>
-                <a:tc>
-                  <a:txBody>
-                    <a:bodyPr/>
-                    <a:lstStyle/>
-                    <a:p>
-                      <a:pPr algn="l" indent="0" marL="0">
-                        <a:buNone/>
-                      </a:pPr>
-                      <a:r>
-                        <a:rPr lang="en-US" sz="1200" b="1" dirty="0">
-                          <a:solidFill>
-                            <a:srgbClr val="0F172A"/>
-                          </a:solidFill>
-                          <a:latin typeface="Calibri" pitchFamily="34" charset="0"/>
-                          <a:ea typeface="Calibri" pitchFamily="34" charset="-122"/>
-                          <a:cs typeface="Calibri" pitchFamily="34" charset="-120"/>
-                        </a:rPr>
-                        <a:t>Figma — fluxo preservado</a:t>
-                      </a:r>
-                      <a:endParaRPr lang="en-US" sz="1200" dirty="0">
-                        <a:latin typeface="Calibri" charset="0"/>
-                        <a:ea typeface="Calibri" charset="0"/>
-                        <a:cs typeface="Calibri" charset="0"/>
-                      </a:endParaRPr>
-                    </a:p>
-                  </a:txBody>
-                  <a:tcPr marL="101600" marR="101600" marT="50800" marB="50800" anchor="ctr">
-                    <a:lnL w="6350" cap="flat" cmpd="sng" algn="ctr">
-                      <a:solidFill>
-                        <a:srgbClr val="DBEAFE"/>
-                      </a:solidFill>
-                      <a:prstDash val="solid"/>
-                      <a:round/>
-                      <a:headEnd type="none" w="med" len="med"/>
-                      <a:tailEnd type="none" w="med" len="med"/>
-                    </a:lnL>
-                    <a:lnR w="6350" cap="flat" cmpd="sng" algn="ctr">
-                      <a:solidFill>
-                        <a:srgbClr val="DBEAFE"/>
-                      </a:solidFill>
-                      <a:prstDash val="solid"/>
-                      <a:round/>
-                      <a:headEnd type="none" w="med" len="med"/>
-                      <a:tailEnd type="none" w="med" len="med"/>
-                    </a:lnR>
-                    <a:lnT w="6350" cap="flat" cmpd="sng" algn="ctr">
-                      <a:solidFill>
-                        <a:srgbClr val="DBEAFE"/>
-                      </a:solidFill>
-                      <a:prstDash val="solid"/>
-                      <a:round/>
-                      <a:headEnd type="none" w="med" len="med"/>
-                      <a:tailEnd type="none" w="med" len="med"/>
-                    </a:lnT>
-                    <a:lnB w="6350" cap="flat" cmpd="sng" algn="ctr">
-                      <a:solidFill>
-                        <a:srgbClr val="DBEAFE"/>
-                      </a:solidFill>
-                      <a:prstDash val="solid"/>
-                      <a:round/>
-                      <a:headEnd type="none" w="med" len="med"/>
-                      <a:tailEnd type="none" w="med" len="med"/>
-                    </a:lnB>
-                    <a:solidFill>
-                      <a:srgbClr val="F8FAFC"/>
-                    </a:solidFill>
-                  </a:tcPr>
-                </a:tc>
-                <a:tc>
-                  <a:txBody>
-                    <a:bodyPr/>
-                    <a:lstStyle/>
-                    <a:p>
-                      <a:pPr algn="l" indent="0" marL="0">
-                        <a:buNone/>
-                      </a:pPr>
-                      <a:r>
-                        <a:rPr lang="en-US" sz="1100" dirty="0">
-                          <a:solidFill>
-                            <a:srgbClr val="475569"/>
-                          </a:solidFill>
-                          <a:latin typeface="Calibri" pitchFamily="34" charset="0"/>
-                          <a:ea typeface="Calibri" pitchFamily="34" charset="-122"/>
-                          <a:cs typeface="Calibri" pitchFamily="34" charset="-120"/>
-                        </a:rPr>
-                        <a:t>MCP quando dev mode em escala</a:t>
-                      </a:r>
-                      <a:endParaRPr lang="en-US" sz="1100" dirty="0">
-                        <a:latin typeface="Calibri" charset="0"/>
-                        <a:ea typeface="Calibri" charset="0"/>
-                        <a:cs typeface="Calibri" charset="0"/>
-                      </a:endParaRPr>
-                    </a:p>
-                  </a:txBody>
-                  <a:tcPr marL="101600" marR="101600" marT="50800" marB="50800" anchor="ctr">
-                    <a:lnL w="6350" cap="flat" cmpd="sng" algn="ctr">
-                      <a:solidFill>
-                        <a:srgbClr val="DBEAFE"/>
-                      </a:solidFill>
-                      <a:prstDash val="solid"/>
-                      <a:round/>
-                      <a:headEnd type="none" w="med" len="med"/>
-                      <a:tailEnd type="none" w="med" len="med"/>
-                    </a:lnL>
-                    <a:lnR w="6350" cap="flat" cmpd="sng" algn="ctr">
-                      <a:solidFill>
-                        <a:srgbClr val="DBEAFE"/>
-                      </a:solidFill>
-                      <a:prstDash val="solid"/>
-                      <a:round/>
-                      <a:headEnd type="none" w="med" len="med"/>
-                      <a:tailEnd type="none" w="med" len="med"/>
-                    </a:lnR>
-                    <a:lnT w="6350" cap="flat" cmpd="sng" algn="ctr">
-                      <a:solidFill>
-                        <a:srgbClr val="DBEAFE"/>
-                      </a:solidFill>
-                      <a:prstDash val="solid"/>
-                      <a:round/>
-                      <a:headEnd type="none" w="med" len="med"/>
-                      <a:tailEnd type="none" w="med" len="med"/>
-                    </a:lnT>
-                    <a:lnB w="6350" cap="flat" cmpd="sng" algn="ctr">
-                      <a:solidFill>
-                        <a:srgbClr val="DBEAFE"/>
-                      </a:solidFill>
-                      <a:prstDash val="solid"/>
-                      <a:round/>
-                      <a:headEnd type="none" w="med" len="med"/>
-                      <a:tailEnd type="none" w="med" len="med"/>
-                    </a:lnB>
-                    <a:solidFill>
-                      <a:srgbClr val="F8FAFC"/>
-                    </a:solidFill>
-                  </a:tcPr>
-                </a:tc>
-              </a:tr>
-              <a:tr h="0">
-                <a:tc>
-                  <a:txBody>
-                    <a:bodyPr/>
-                    <a:lstStyle/>
-                    <a:p>
-                      <a:pPr algn="l" indent="0" marL="0">
-                        <a:buNone/>
-                      </a:pPr>
-                      <a:r>
-                        <a:rPr lang="en-US" sz="1200" dirty="0">
-                          <a:solidFill>
-                            <a:srgbClr val="0F172A"/>
-                          </a:solidFill>
-                          <a:latin typeface="Calibri" pitchFamily="34" charset="0"/>
-                          <a:ea typeface="Calibri" pitchFamily="34" charset="-122"/>
-                          <a:cs typeface="Calibri" pitchFamily="34" charset="-120"/>
-                        </a:rPr>
-                        <a:t>Design system</a:t>
-                      </a:r>
-                      <a:endParaRPr lang="en-US" sz="1200" dirty="0">
-                        <a:latin typeface="Calibri" charset="0"/>
-                        <a:ea typeface="Calibri" charset="0"/>
-                        <a:cs typeface="Calibri" charset="0"/>
-                      </a:endParaRPr>
-                    </a:p>
-                  </a:txBody>
-                  <a:tcPr marL="101600" marR="101600" marT="50800" marB="50800" anchor="ctr">
-                    <a:lnL w="6350" cap="flat" cmpd="sng" algn="ctr">
-                      <a:solidFill>
-                        <a:srgbClr val="DBEAFE"/>
-                      </a:solidFill>
-                      <a:prstDash val="solid"/>
-                      <a:round/>
-                      <a:headEnd type="none" w="med" len="med"/>
-                      <a:tailEnd type="none" w="med" len="med"/>
-                    </a:lnL>
-                    <a:lnR w="6350" cap="flat" cmpd="sng" algn="ctr">
-                      <a:solidFill>
-                        <a:srgbClr val="DBEAFE"/>
-                      </a:solidFill>
-                      <a:prstDash val="solid"/>
-                      <a:round/>
-                      <a:headEnd type="none" w="med" len="med"/>
-                      <a:tailEnd type="none" w="med" len="med"/>
-                    </a:lnR>
-                    <a:lnT w="6350" cap="flat" cmpd="sng" algn="ctr">
-                      <a:solidFill>
-                        <a:srgbClr val="DBEAFE"/>
-                      </a:solidFill>
-                      <a:prstDash val="solid"/>
-                      <a:round/>
-                      <a:headEnd type="none" w="med" len="med"/>
-                      <a:tailEnd type="none" w="med" len="med"/>
-                    </a:lnT>
-                    <a:lnB w="6350" cap="flat" cmpd="sng" algn="ctr">
-                      <a:solidFill>
-                        <a:srgbClr val="DBEAFE"/>
-                      </a:solidFill>
-                      <a:prstDash val="solid"/>
-                      <a:round/>
-                      <a:headEnd type="none" w="med" len="med"/>
-                      <a:tailEnd type="none" w="med" len="med"/>
-                    </a:lnB>
-                    <a:solidFill>
-                      <a:srgbClr val="FFFFFF"/>
-                    </a:solidFill>
-                  </a:tcPr>
-                </a:tc>
-                <a:tc>
-                  <a:txBody>
-                    <a:bodyPr/>
-                    <a:lstStyle/>
-                    <a:p>
-                      <a:pPr algn="l" indent="0" marL="0">
-                        <a:buNone/>
-                      </a:pPr>
-                      <a:r>
-                        <a:rPr lang="en-US" sz="1200" b="1" dirty="0">
-                          <a:solidFill>
-                            <a:srgbClr val="0F172A"/>
-                          </a:solidFill>
-                          <a:latin typeface="Calibri" pitchFamily="34" charset="0"/>
-                          <a:ea typeface="Calibri" pitchFamily="34" charset="-122"/>
-                          <a:cs typeface="Calibri" pitchFamily="34" charset="-120"/>
-                        </a:rPr>
-                        <a:t>BBDS — obrigatório</a:t>
-                      </a:r>
-                      <a:endParaRPr lang="en-US" sz="1200" dirty="0">
-                        <a:latin typeface="Calibri" charset="0"/>
-                        <a:ea typeface="Calibri" charset="0"/>
-                        <a:cs typeface="Calibri" charset="0"/>
-                      </a:endParaRPr>
-                    </a:p>
-                  </a:txBody>
-                  <a:tcPr marL="101600" marR="101600" marT="50800" marB="50800" anchor="ctr">
-                    <a:lnL w="6350" cap="flat" cmpd="sng" algn="ctr">
-                      <a:solidFill>
-                        <a:srgbClr val="DBEAFE"/>
-                      </a:solidFill>
-                      <a:prstDash val="solid"/>
-                      <a:round/>
-                      <a:headEnd type="none" w="med" len="med"/>
-                      <a:tailEnd type="none" w="med" len="med"/>
-                    </a:lnL>
-                    <a:lnR w="6350" cap="flat" cmpd="sng" algn="ctr">
-                      <a:solidFill>
-                        <a:srgbClr val="DBEAFE"/>
-                      </a:solidFill>
-                      <a:prstDash val="solid"/>
-                      <a:round/>
-                      <a:headEnd type="none" w="med" len="med"/>
-                      <a:tailEnd type="none" w="med" len="med"/>
-                    </a:lnR>
-                    <a:lnT w="6350" cap="flat" cmpd="sng" algn="ctr">
-                      <a:solidFill>
-                        <a:srgbClr val="DBEAFE"/>
-                      </a:solidFill>
-                      <a:prstDash val="solid"/>
-                      <a:round/>
-                      <a:headEnd type="none" w="med" len="med"/>
-                      <a:tailEnd type="none" w="med" len="med"/>
-                    </a:lnT>
-                    <a:lnB w="6350" cap="flat" cmpd="sng" algn="ctr">
-                      <a:solidFill>
-                        <a:srgbClr val="DBEAFE"/>
-                      </a:solidFill>
-                      <a:prstDash val="solid"/>
-                      <a:round/>
-                      <a:headEnd type="none" w="med" len="med"/>
-                      <a:tailEnd type="none" w="med" len="med"/>
-                    </a:lnB>
-                    <a:solidFill>
-                      <a:srgbClr val="FFFFFF"/>
-                    </a:solidFill>
-                  </a:tcPr>
-                </a:tc>
-                <a:tc>
-                  <a:txBody>
-                    <a:bodyPr/>
-                    <a:lstStyle/>
-                    <a:p>
-                      <a:pPr algn="l" indent="0" marL="0">
-                        <a:buNone/>
-                      </a:pPr>
-                      <a:r>
-                        <a:rPr lang="en-US" sz="1100" dirty="0">
-                          <a:solidFill>
-                            <a:srgbClr val="475569"/>
-                          </a:solidFill>
-                          <a:latin typeface="Calibri" pitchFamily="34" charset="0"/>
-                          <a:ea typeface="Calibri" pitchFamily="34" charset="-122"/>
-                          <a:cs typeface="Calibri" pitchFamily="34" charset="-120"/>
-                        </a:rPr>
-                        <a:t>Padrão existente para novos fluxos</a:t>
-                      </a:r>
-                      <a:endParaRPr lang="en-US" sz="1100" dirty="0">
-                        <a:latin typeface="Calibri" charset="0"/>
-                        <a:ea typeface="Calibri" charset="0"/>
-                        <a:cs typeface="Calibri" charset="0"/>
-                      </a:endParaRPr>
-                    </a:p>
-                  </a:txBody>
-                  <a:tcPr marL="101600" marR="101600" marT="50800" marB="50800" anchor="ctr">
-                    <a:lnL w="6350" cap="flat" cmpd="sng" algn="ctr">
-                      <a:solidFill>
-                        <a:srgbClr val="DBEAFE"/>
-                      </a:solidFill>
-                      <a:prstDash val="solid"/>
-                      <a:round/>
-                      <a:headEnd type="none" w="med" len="med"/>
-                      <a:tailEnd type="none" w="med" len="med"/>
-                    </a:lnL>
-                    <a:lnR w="6350" cap="flat" cmpd="sng" algn="ctr">
-                      <a:solidFill>
-                        <a:srgbClr val="DBEAFE"/>
-                      </a:solidFill>
-                      <a:prstDash val="solid"/>
-                      <a:round/>
-                      <a:headEnd type="none" w="med" len="med"/>
-                      <a:tailEnd type="none" w="med" len="med"/>
-                    </a:lnR>
-                    <a:lnT w="6350" cap="flat" cmpd="sng" algn="ctr">
-                      <a:solidFill>
-                        <a:srgbClr val="DBEAFE"/>
-                      </a:solidFill>
-                      <a:prstDash val="solid"/>
-                      <a:round/>
-                      <a:headEnd type="none" w="med" len="med"/>
-                      <a:tailEnd type="none" w="med" len="med"/>
-                    </a:lnT>
-                    <a:lnB w="6350" cap="flat" cmpd="sng" algn="ctr">
-                      <a:solidFill>
-                        <a:srgbClr val="DBEAFE"/>
-                      </a:solidFill>
-                      <a:prstDash val="solid"/>
-                      <a:round/>
-                      <a:headEnd type="none" w="med" len="med"/>
-                      <a:tailEnd type="none" w="med" len="med"/>
-                    </a:lnB>
-                    <a:solidFill>
-                      <a:srgbClr val="FFFFFF"/>
-                    </a:solidFill>
-                  </a:tcPr>
-                </a:tc>
-              </a:tr>
-              <a:tr h="0">
-                <a:tc>
-                  <a:txBody>
-                    <a:bodyPr/>
-                    <a:lstStyle/>
-                    <a:p>
-                      <a:pPr algn="l" indent="0" marL="0">
-                        <a:buNone/>
-                      </a:pPr>
-                      <a:r>
-                        <a:rPr lang="en-US" sz="1200" dirty="0">
-                          <a:solidFill>
-                            <a:srgbClr val="0F172A"/>
-                          </a:solidFill>
-                          <a:latin typeface="Calibri" pitchFamily="34" charset="0"/>
-                          <a:ea typeface="Calibri" pitchFamily="34" charset="-122"/>
-                          <a:cs typeface="Calibri" pitchFamily="34" charset="-120"/>
-                        </a:rPr>
-                        <a:t>CI/CD</a:t>
-                      </a:r>
-                      <a:endParaRPr lang="en-US" sz="1200" dirty="0">
-                        <a:latin typeface="Calibri" charset="0"/>
-                        <a:ea typeface="Calibri" charset="0"/>
-                        <a:cs typeface="Calibri" charset="0"/>
-                      </a:endParaRPr>
-                    </a:p>
-                  </a:txBody>
-                  <a:tcPr marL="101600" marR="101600" marT="50800" marB="50800" anchor="ctr">
-                    <a:lnL w="6350" cap="flat" cmpd="sng" algn="ctr">
-                      <a:solidFill>
-                        <a:srgbClr val="DBEAFE"/>
-                      </a:solidFill>
-                      <a:prstDash val="solid"/>
-                      <a:round/>
-                      <a:headEnd type="none" w="med" len="med"/>
-                      <a:tailEnd type="none" w="med" len="med"/>
-                    </a:lnL>
-                    <a:lnR w="6350" cap="flat" cmpd="sng" algn="ctr">
-                      <a:solidFill>
-                        <a:srgbClr val="DBEAFE"/>
-                      </a:solidFill>
-                      <a:prstDash val="solid"/>
-                      <a:round/>
-                      <a:headEnd type="none" w="med" len="med"/>
-                      <a:tailEnd type="none" w="med" len="med"/>
-                    </a:lnR>
-                    <a:lnT w="6350" cap="flat" cmpd="sng" algn="ctr">
-                      <a:solidFill>
-                        <a:srgbClr val="DBEAFE"/>
-                      </a:solidFill>
-                      <a:prstDash val="solid"/>
-                      <a:round/>
-                      <a:headEnd type="none" w="med" len="med"/>
-                      <a:tailEnd type="none" w="med" len="med"/>
-                    </a:lnT>
-                    <a:lnB w="6350" cap="flat" cmpd="sng" algn="ctr">
-                      <a:solidFill>
-                        <a:srgbClr val="DBEAFE"/>
-                      </a:solidFill>
-                      <a:prstDash val="solid"/>
-                      <a:round/>
-                      <a:headEnd type="none" w="med" len="med"/>
-                      <a:tailEnd type="none" w="med" len="med"/>
-                    </a:lnB>
-                    <a:solidFill>
-                      <a:srgbClr val="F8FAFC"/>
-                    </a:solidFill>
-                  </a:tcPr>
-                </a:tc>
-                <a:tc>
-                  <a:txBody>
-                    <a:bodyPr/>
-                    <a:lstStyle/>
-                    <a:p>
-                      <a:pPr algn="l" indent="0" marL="0">
-                        <a:buNone/>
-                      </a:pPr>
-                      <a:r>
-                        <a:rPr lang="en-US" sz="1200" b="1" dirty="0">
-                          <a:solidFill>
-                            <a:srgbClr val="0F172A"/>
-                          </a:solidFill>
-                          <a:latin typeface="Calibri" pitchFamily="34" charset="0"/>
-                          <a:ea typeface="Calibri" pitchFamily="34" charset="-122"/>
-                          <a:cs typeface="Calibri" pitchFamily="34" charset="-120"/>
-                        </a:rPr>
-                        <a:t>GitHub Actions + Bitrise</a:t>
-                      </a:r>
-                      <a:endParaRPr lang="en-US" sz="1200" dirty="0">
-                        <a:latin typeface="Calibri" charset="0"/>
-                        <a:ea typeface="Calibri" charset="0"/>
-                        <a:cs typeface="Calibri" charset="0"/>
-                      </a:endParaRPr>
-                    </a:p>
-                  </a:txBody>
-                  <a:tcPr marL="101600" marR="101600" marT="50800" marB="50800" anchor="ctr">
-                    <a:lnL w="6350" cap="flat" cmpd="sng" algn="ctr">
-                      <a:solidFill>
-                        <a:srgbClr val="DBEAFE"/>
-                      </a:solidFill>
-                      <a:prstDash val="solid"/>
-                      <a:round/>
-                      <a:headEnd type="none" w="med" len="med"/>
-                      <a:tailEnd type="none" w="med" len="med"/>
-                    </a:lnL>
-                    <a:lnR w="6350" cap="flat" cmpd="sng" algn="ctr">
-                      <a:solidFill>
-                        <a:srgbClr val="DBEAFE"/>
-                      </a:solidFill>
-                      <a:prstDash val="solid"/>
-                      <a:round/>
-                      <a:headEnd type="none" w="med" len="med"/>
-                      <a:tailEnd type="none" w="med" len="med"/>
-                    </a:lnR>
-                    <a:lnT w="6350" cap="flat" cmpd="sng" algn="ctr">
-                      <a:solidFill>
-                        <a:srgbClr val="DBEAFE"/>
-                      </a:solidFill>
-                      <a:prstDash val="solid"/>
-                      <a:round/>
-                      <a:headEnd type="none" w="med" len="med"/>
-                      <a:tailEnd type="none" w="med" len="med"/>
-                    </a:lnT>
-                    <a:lnB w="6350" cap="flat" cmpd="sng" algn="ctr">
-                      <a:solidFill>
-                        <a:srgbClr val="DBEAFE"/>
-                      </a:solidFill>
-                      <a:prstDash val="solid"/>
-                      <a:round/>
-                      <a:headEnd type="none" w="med" len="med"/>
-                      <a:tailEnd type="none" w="med" len="med"/>
-                    </a:lnB>
-                    <a:solidFill>
-                      <a:srgbClr val="F8FAFC"/>
-                    </a:solidFill>
-                  </a:tcPr>
-                </a:tc>
-                <a:tc>
-                  <a:txBody>
-                    <a:bodyPr/>
-                    <a:lstStyle/>
-                    <a:p>
-                      <a:pPr algn="l" indent="0" marL="0">
-                        <a:buNone/>
-                      </a:pPr>
-                      <a:r>
-                        <a:rPr lang="en-US" sz="1100" dirty="0">
-                          <a:solidFill>
-                            <a:srgbClr val="475569"/>
-                          </a:solidFill>
-                          <a:latin typeface="Calibri" pitchFamily="34" charset="0"/>
-                          <a:ea typeface="Calibri" pitchFamily="34" charset="-122"/>
-                          <a:cs typeface="Calibri" pitchFamily="34" charset="-120"/>
-                        </a:rPr>
-                        <a:t>Infraestrutura existente</a:t>
-                      </a:r>
-                      <a:endParaRPr lang="en-US" sz="1100" dirty="0">
-                        <a:latin typeface="Calibri" charset="0"/>
-                        <a:ea typeface="Calibri" charset="0"/>
-                        <a:cs typeface="Calibri" charset="0"/>
-                      </a:endParaRPr>
-                    </a:p>
-                  </a:txBody>
-                  <a:tcPr marL="101600" marR="101600" marT="50800" marB="50800" anchor="ctr">
-                    <a:lnL w="6350" cap="flat" cmpd="sng" algn="ctr">
-                      <a:solidFill>
-                        <a:srgbClr val="DBEAFE"/>
-                      </a:solidFill>
-                      <a:prstDash val="solid"/>
-                      <a:round/>
-                      <a:headEnd type="none" w="med" len="med"/>
-                      <a:tailEnd type="none" w="med" len="med"/>
-                    </a:lnL>
-                    <a:lnR w="6350" cap="flat" cmpd="sng" algn="ctr">
-                      <a:solidFill>
-                        <a:srgbClr val="DBEAFE"/>
-                      </a:solidFill>
-                      <a:prstDash val="solid"/>
-                      <a:round/>
-                      <a:headEnd type="none" w="med" len="med"/>
-                      <a:tailEnd type="none" w="med" len="med"/>
-                    </a:lnR>
-                    <a:lnT w="6350" cap="flat" cmpd="sng" algn="ctr">
-                      <a:solidFill>
-                        <a:srgbClr val="DBEAFE"/>
-                      </a:solidFill>
-                      <a:prstDash val="solid"/>
-                      <a:round/>
-                      <a:headEnd type="none" w="med" len="med"/>
-                      <a:tailEnd type="none" w="med" len="med"/>
-                    </a:lnT>
-                    <a:lnB w="6350" cap="flat" cmpd="sng" algn="ctr">
-                      <a:solidFill>
-                        <a:srgbClr val="DBEAFE"/>
-                      </a:solidFill>
-                      <a:prstDash val="solid"/>
-                      <a:round/>
-                      <a:headEnd type="none" w="med" len="med"/>
-                      <a:tailEnd type="none" w="med" len="med"/>
-                    </a:lnB>
-                    <a:solidFill>
-                      <a:srgbClr val="F8FAFC"/>
-                    </a:solidFill>
-                  </a:tcPr>
-                </a:tc>
-              </a:tr>
-            </a:tbl>
-          </a:graphicData>
-        </a:graphic>
-      </p:graphicFrame>
-    </p:spTree>
-  </p:cSld>
-  <p:clrMapOvr>
-    <a:masterClrMapping/>
-  </p:clrMapOvr>
-</p:sld>
-</file>
-
 <file path=ppt/slides/slide9.xml><?xml version="1.0" encoding="utf-8"?>
 <p:sld xmlns:a="http://schemas.openxmlformats.org/drawingml/2006/main" xmlns:r="http://schemas.openxmlformats.org/officeDocument/2006/relationships" xmlns:p="http://schemas.openxmlformats.org/presentationml/2006/main">
   <p:cSld name="Slide 9">
@@ -15728,7 +14017,7 @@
                 <a:ea typeface="Calibri" pitchFamily="34" charset="-122"/>
                 <a:cs typeface="Calibri" pitchFamily="34" charset="-120"/>
               </a:rPr>
-              <a:t>09 / 15</a:t>
+              <a:t>08 / 14</a:t>
             </a:r>
             <a:endParaRPr lang="en-US" sz="900" dirty="0"/>
           </a:p>

</xml_diff>

<commit_message>
fix(pitch): aumentar fontes nos slides de detalhe dos agentes
Conteúdo das colunas: 9.8pt → 13pt
Labels das colunas: 8.8pt → 11pt
Tagline: 11.5pt → 14pt
Footer (GATE / O QUE MUDA): 9.3pt → 12pt
Runtime/Stage: 7.8pt → 9.5pt / 9pt → 11pt

Co-Authored-By: Claude Sonnet 4.6 <noreply@anthropic.com>
</commit_message>
<xml_diff>
--- a/esteira-agentica-pitch.pptx
+++ b/esteira-agentica-pitch.pptx
@@ -9840,7 +9840,7 @@
               <a:buNone/>
             </a:pPr>
             <a:r>
-              <a:rPr lang="pt-BR" sz="900" b="1" dirty="0">
+              <a:rPr lang="pt-BR" sz="1100" b="1" dirty="0">
                 <a:solidFill>
                   <a:srgbClr val="FFFFFF"/>
                 </a:solidFill>
@@ -9876,7 +9876,7 @@
               <a:buNone/>
             </a:pPr>
             <a:r>
-              <a:rPr lang="pt-BR" sz="780" b="0" i="1" dirty="0">
+              <a:rPr lang="pt-BR" sz="950" b="0" i="1" dirty="0">
                 <a:solidFill>
                   <a:srgbClr val="FFFFFF"/>
                 </a:solidFill>
@@ -9932,7 +9932,7 @@
               <a:buNone/>
             </a:pPr>
             <a:r>
-              <a:rPr lang="pt-BR" sz="1150" b="0" i="1" dirty="0">
+              <a:rPr lang="pt-BR" sz="1400" b="0" i="1" dirty="0">
                 <a:solidFill>
                   <a:srgbClr val="D97706"/>
                 </a:solidFill>
@@ -10010,7 +10010,7 @@
               <a:buNone/>
             </a:pPr>
             <a:r>
-              <a:rPr lang="pt-BR" sz="880" b="1" dirty="0">
+              <a:rPr lang="pt-BR" sz="1100" b="1" dirty="0">
                 <a:solidFill>
                   <a:srgbClr val="FFFFFF"/>
                 </a:solidFill>
@@ -10046,7 +10046,7 @@
               <a:buNone/>
             </a:pPr>
             <a:r>
-              <a:rPr lang="pt-BR" sz="980" b="0" dirty="0">
+              <a:rPr lang="pt-BR" sz="1300" b="0" dirty="0">
                 <a:solidFill>
                   <a:srgbClr val="1E293B"/>
                 </a:solidFill>
@@ -10060,7 +10060,7 @@
               <a:buNone/>
             </a:pPr>
             <a:r>
-              <a:rPr lang="pt-BR" sz="980" b="0" dirty="0">
+              <a:rPr lang="pt-BR" sz="1300" b="0" dirty="0">
                 <a:solidFill>
                   <a:srgbClr val="1E293B"/>
                 </a:solidFill>
@@ -10074,7 +10074,7 @@
               <a:buNone/>
             </a:pPr>
             <a:r>
-              <a:rPr lang="pt-BR" sz="980" b="0" dirty="0">
+              <a:rPr lang="pt-BR" sz="1300" b="0" dirty="0">
                 <a:solidFill>
                   <a:srgbClr val="1E293B"/>
                 </a:solidFill>
@@ -10088,7 +10088,7 @@
               <a:buNone/>
             </a:pPr>
             <a:r>
-              <a:rPr lang="pt-BR" sz="980" b="0" dirty="0">
+              <a:rPr lang="pt-BR" sz="1300" b="0" dirty="0">
                 <a:solidFill>
                   <a:srgbClr val="1E293B"/>
                 </a:solidFill>
@@ -10102,7 +10102,7 @@
               <a:buNone/>
             </a:pPr>
             <a:r>
-              <a:rPr lang="pt-BR" sz="980" b="0" dirty="0">
+              <a:rPr lang="pt-BR" sz="1300" b="0" dirty="0">
                 <a:solidFill>
                   <a:srgbClr val="1E293B"/>
                 </a:solidFill>
@@ -10116,7 +10116,7 @@
               <a:buNone/>
             </a:pPr>
             <a:r>
-              <a:rPr lang="pt-BR" sz="980" b="0" dirty="0">
+              <a:rPr lang="pt-BR" sz="1300" b="0" dirty="0">
                 <a:solidFill>
                   <a:srgbClr val="1E293B"/>
                 </a:solidFill>
@@ -10194,7 +10194,7 @@
               <a:buNone/>
             </a:pPr>
             <a:r>
-              <a:rPr lang="pt-BR" sz="880" b="1" dirty="0">
+              <a:rPr lang="pt-BR" sz="1100" b="1" dirty="0">
                 <a:solidFill>
                   <a:srgbClr val="FFFFFF"/>
                 </a:solidFill>
@@ -10230,7 +10230,7 @@
               <a:buNone/>
             </a:pPr>
             <a:r>
-              <a:rPr lang="pt-BR" sz="980" b="0" dirty="0">
+              <a:rPr lang="pt-BR" sz="1300" b="0" dirty="0">
                 <a:solidFill>
                   <a:srgbClr val="1E293B"/>
                 </a:solidFill>
@@ -10244,7 +10244,7 @@
               <a:buNone/>
             </a:pPr>
             <a:r>
-              <a:rPr lang="pt-BR" sz="980" b="0" dirty="0">
+              <a:rPr lang="pt-BR" sz="1300" b="0" dirty="0">
                 <a:solidFill>
                   <a:srgbClr val="1E293B"/>
                 </a:solidFill>
@@ -10257,11 +10257,11 @@
             <a:pPr indent="0" marL="0">
               <a:buNone/>
               <a:spcBef>
-                <a:spcPts val="80"/>
+                <a:spcPts val="100"/>
               </a:spcBef>
             </a:pPr>
             <a:r>
-              <a:rPr lang="pt-BR" sz="980" b="0" dirty="0">
+              <a:rPr lang="pt-BR" sz="1300" b="0" dirty="0">
                 <a:solidFill>
                   <a:srgbClr val="1E293B"/>
                 </a:solidFill>
@@ -10275,7 +10275,7 @@
               <a:buNone/>
             </a:pPr>
             <a:r>
-              <a:rPr lang="pt-BR" sz="980" b="0" dirty="0">
+              <a:rPr lang="pt-BR" sz="1300" b="0" dirty="0">
                 <a:solidFill>
                   <a:srgbClr val="1E293B"/>
                 </a:solidFill>
@@ -10288,11 +10288,11 @@
             <a:pPr indent="0" marL="0">
               <a:buNone/>
               <a:spcBef>
-                <a:spcPts val="80"/>
+                <a:spcPts val="100"/>
               </a:spcBef>
             </a:pPr>
             <a:r>
-              <a:rPr lang="pt-BR" sz="980" b="0" dirty="0">
+              <a:rPr lang="pt-BR" sz="1300" b="0" dirty="0">
                 <a:solidFill>
                   <a:srgbClr val="1E293B"/>
                 </a:solidFill>
@@ -10306,7 +10306,7 @@
               <a:buNone/>
             </a:pPr>
             <a:r>
-              <a:rPr lang="pt-BR" sz="980" b="0" dirty="0">
+              <a:rPr lang="pt-BR" sz="1300" b="0" dirty="0">
                 <a:solidFill>
                   <a:srgbClr val="1E293B"/>
                 </a:solidFill>
@@ -10320,7 +10320,7 @@
               <a:buNone/>
             </a:pPr>
             <a:r>
-              <a:rPr lang="pt-BR" sz="980" b="0" dirty="0">
+              <a:rPr lang="pt-BR" sz="1300" b="0" dirty="0">
                 <a:solidFill>
                   <a:srgbClr val="1E293B"/>
                 </a:solidFill>
@@ -10398,7 +10398,7 @@
               <a:buNone/>
             </a:pPr>
             <a:r>
-              <a:rPr lang="pt-BR" sz="880" b="1" dirty="0">
+              <a:rPr lang="pt-BR" sz="1100" b="1" dirty="0">
                 <a:solidFill>
                   <a:srgbClr val="FFFFFF"/>
                 </a:solidFill>
@@ -10434,7 +10434,7 @@
               <a:buNone/>
             </a:pPr>
             <a:r>
-              <a:rPr lang="pt-BR" sz="980" b="0" dirty="0">
+              <a:rPr lang="pt-BR" sz="1300" b="0" dirty="0">
                 <a:solidFill>
                   <a:srgbClr val="1E293B"/>
                 </a:solidFill>
@@ -10448,7 +10448,7 @@
               <a:buNone/>
             </a:pPr>
             <a:r>
-              <a:rPr lang="pt-BR" sz="980" b="0" dirty="0">
+              <a:rPr lang="pt-BR" sz="1300" b="0" dirty="0">
                 <a:solidFill>
                   <a:srgbClr val="1E293B"/>
                 </a:solidFill>
@@ -10462,7 +10462,7 @@
               <a:buNone/>
             </a:pPr>
             <a:r>
-              <a:rPr lang="pt-BR" sz="980" b="0" dirty="0">
+              <a:rPr lang="pt-BR" sz="1300" b="0" dirty="0">
                 <a:solidFill>
                   <a:srgbClr val="1E293B"/>
                 </a:solidFill>
@@ -10476,7 +10476,7 @@
               <a:buNone/>
             </a:pPr>
             <a:r>
-              <a:rPr lang="pt-BR" sz="980" b="0" dirty="0">
+              <a:rPr lang="pt-BR" sz="1300" b="0" dirty="0">
                 <a:solidFill>
                   <a:srgbClr val="1E293B"/>
                 </a:solidFill>
@@ -10490,7 +10490,7 @@
               <a:buNone/>
             </a:pPr>
             <a:r>
-              <a:rPr lang="pt-BR" sz="980" b="0" dirty="0">
+              <a:rPr lang="pt-BR" sz="1300" b="0" dirty="0">
                 <a:solidFill>
                   <a:srgbClr val="1E293B"/>
                 </a:solidFill>
@@ -10503,11 +10503,11 @@
             <a:pPr indent="0" marL="0">
               <a:buNone/>
               <a:spcBef>
-                <a:spcPts val="80"/>
+                <a:spcPts val="100"/>
               </a:spcBef>
             </a:pPr>
             <a:r>
-              <a:rPr lang="pt-BR" sz="980" b="0" dirty="0">
+              <a:rPr lang="pt-BR" sz="1300" b="0" dirty="0">
                 <a:solidFill>
                   <a:srgbClr val="1E293B"/>
                 </a:solidFill>
@@ -10520,11 +10520,11 @@
             <a:pPr indent="0" marL="0">
               <a:buNone/>
               <a:spcBef>
-                <a:spcPts val="80"/>
+                <a:spcPts val="100"/>
               </a:spcBef>
             </a:pPr>
             <a:r>
-              <a:rPr lang="pt-BR" sz="980" b="0" dirty="0">
+              <a:rPr lang="pt-BR" sz="1300" b="0" dirty="0">
                 <a:solidFill>
                   <a:srgbClr val="1E293B"/>
                 </a:solidFill>
@@ -10537,11 +10537,11 @@
             <a:pPr indent="0" marL="0">
               <a:buNone/>
               <a:spcBef>
-                <a:spcPts val="80"/>
+                <a:spcPts val="100"/>
               </a:spcBef>
             </a:pPr>
             <a:r>
-              <a:rPr lang="pt-BR" sz="980" b="0" dirty="0">
+              <a:rPr lang="pt-BR" sz="1300" b="0" dirty="0">
                 <a:solidFill>
                   <a:srgbClr val="1E293B"/>
                 </a:solidFill>
@@ -10617,7 +10617,7 @@
               <a:buNone/>
             </a:pPr>
             <a:r>
-              <a:rPr lang="pt-BR" sz="800" b="1" dirty="0">
+              <a:rPr lang="pt-BR" sz="1000" b="1" dirty="0">
                 <a:solidFill>
                   <a:srgbClr val="D97706"/>
                 </a:solidFill>
@@ -10631,7 +10631,7 @@
               <a:buNone/>
             </a:pPr>
             <a:r>
-              <a:rPr lang="pt-BR" sz="930" b="0" dirty="0">
+              <a:rPr lang="pt-BR" sz="1200" b="0" dirty="0">
                 <a:solidFill>
                   <a:srgbClr val="334155"/>
                 </a:solidFill>
@@ -10667,7 +10667,7 @@
               <a:buNone/>
             </a:pPr>
             <a:r>
-              <a:rPr lang="pt-BR" sz="800" b="1" dirty="0">
+              <a:rPr lang="pt-BR" sz="1000" b="1" dirty="0">
                 <a:solidFill>
                   <a:srgbClr val="D97706"/>
                 </a:solidFill>
@@ -10681,7 +10681,7 @@
               <a:buNone/>
             </a:pPr>
             <a:r>
-              <a:rPr lang="pt-BR" sz="930" b="0" dirty="0">
+              <a:rPr lang="pt-BR" sz="1200" b="0" dirty="0">
                 <a:solidFill>
                   <a:srgbClr val="334155"/>
                 </a:solidFill>
@@ -10877,7 +10877,7 @@
               <a:buNone/>
             </a:pPr>
             <a:r>
-              <a:rPr lang="pt-BR" sz="900" b="1" dirty="0">
+              <a:rPr lang="pt-BR" sz="1100" b="1" dirty="0">
                 <a:solidFill>
                   <a:srgbClr val="FFFFFF"/>
                 </a:solidFill>
@@ -10913,7 +10913,7 @@
               <a:buNone/>
             </a:pPr>
             <a:r>
-              <a:rPr lang="pt-BR" sz="780" b="0" i="1" dirty="0">
+              <a:rPr lang="pt-BR" sz="950" b="0" i="1" dirty="0">
                 <a:solidFill>
                   <a:srgbClr val="FFFFFF"/>
                 </a:solidFill>
@@ -10969,7 +10969,7 @@
               <a:buNone/>
             </a:pPr>
             <a:r>
-              <a:rPr lang="pt-BR" sz="1150" b="0" i="1" dirty="0">
+              <a:rPr lang="pt-BR" sz="1400" b="0" i="1" dirty="0">
                 <a:solidFill>
                   <a:srgbClr val="7C3AED"/>
                 </a:solidFill>
@@ -11047,7 +11047,7 @@
               <a:buNone/>
             </a:pPr>
             <a:r>
-              <a:rPr lang="pt-BR" sz="880" b="1" dirty="0">
+              <a:rPr lang="pt-BR" sz="1100" b="1" dirty="0">
                 <a:solidFill>
                   <a:srgbClr val="FFFFFF"/>
                 </a:solidFill>
@@ -11083,7 +11083,7 @@
               <a:buNone/>
             </a:pPr>
             <a:r>
-              <a:rPr lang="pt-BR" sz="980" b="0" dirty="0">
+              <a:rPr lang="pt-BR" sz="1300" b="0" dirty="0">
                 <a:solidFill>
                   <a:srgbClr val="1E293B"/>
                 </a:solidFill>
@@ -11096,11 +11096,11 @@
             <a:pPr indent="0" marL="0">
               <a:buNone/>
               <a:spcBef>
-                <a:spcPts val="80"/>
+                <a:spcPts val="100"/>
               </a:spcBef>
             </a:pPr>
             <a:r>
-              <a:rPr lang="pt-BR" sz="980" b="0" dirty="0">
+              <a:rPr lang="pt-BR" sz="1300" b="0" dirty="0">
                 <a:solidFill>
                   <a:srgbClr val="1E293B"/>
                 </a:solidFill>
@@ -11114,7 +11114,7 @@
               <a:buNone/>
             </a:pPr>
             <a:r>
-              <a:rPr lang="pt-BR" sz="980" b="0" dirty="0">
+              <a:rPr lang="pt-BR" sz="1300" b="0" dirty="0">
                 <a:solidFill>
                   <a:srgbClr val="1E293B"/>
                 </a:solidFill>
@@ -11127,11 +11127,11 @@
             <a:pPr indent="0" marL="0">
               <a:buNone/>
               <a:spcBef>
-                <a:spcPts val="80"/>
+                <a:spcPts val="100"/>
               </a:spcBef>
             </a:pPr>
             <a:r>
-              <a:rPr lang="pt-BR" sz="980" b="0" dirty="0">
+              <a:rPr lang="pt-BR" sz="1300" b="0" dirty="0">
                 <a:solidFill>
                   <a:srgbClr val="1E293B"/>
                 </a:solidFill>
@@ -11145,7 +11145,7 @@
               <a:buNone/>
             </a:pPr>
             <a:r>
-              <a:rPr lang="pt-BR" sz="980" b="0" dirty="0">
+              <a:rPr lang="pt-BR" sz="1300" b="0" dirty="0">
                 <a:solidFill>
                   <a:srgbClr val="1E293B"/>
                 </a:solidFill>
@@ -11159,7 +11159,7 @@
               <a:buNone/>
             </a:pPr>
             <a:r>
-              <a:rPr lang="pt-BR" sz="980" b="0" dirty="0">
+              <a:rPr lang="pt-BR" sz="1300" b="0" dirty="0">
                 <a:solidFill>
                   <a:srgbClr val="1E293B"/>
                 </a:solidFill>
@@ -11172,11 +11172,11 @@
             <a:pPr indent="0" marL="0">
               <a:buNone/>
               <a:spcBef>
-                <a:spcPts val="80"/>
+                <a:spcPts val="100"/>
               </a:spcBef>
             </a:pPr>
             <a:r>
-              <a:rPr lang="pt-BR" sz="980" b="0" dirty="0">
+              <a:rPr lang="pt-BR" sz="1300" b="0" dirty="0">
                 <a:solidFill>
                   <a:srgbClr val="1E293B"/>
                 </a:solidFill>
@@ -11190,7 +11190,7 @@
               <a:buNone/>
             </a:pPr>
             <a:r>
-              <a:rPr lang="pt-BR" sz="980" b="0" dirty="0">
+              <a:rPr lang="pt-BR" sz="1300" b="0" dirty="0">
                 <a:solidFill>
                   <a:srgbClr val="1E293B"/>
                 </a:solidFill>
@@ -11268,7 +11268,7 @@
               <a:buNone/>
             </a:pPr>
             <a:r>
-              <a:rPr lang="pt-BR" sz="880" b="1" dirty="0">
+              <a:rPr lang="pt-BR" sz="1100" b="1" dirty="0">
                 <a:solidFill>
                   <a:srgbClr val="FFFFFF"/>
                 </a:solidFill>
@@ -11304,7 +11304,7 @@
               <a:buNone/>
             </a:pPr>
             <a:r>
-              <a:rPr lang="pt-BR" sz="980" b="0" dirty="0">
+              <a:rPr lang="pt-BR" sz="1300" b="0" dirty="0">
                 <a:solidFill>
                   <a:srgbClr val="1E293B"/>
                 </a:solidFill>
@@ -11317,11 +11317,11 @@
             <a:pPr indent="0" marL="0">
               <a:buNone/>
               <a:spcBef>
-                <a:spcPts val="80"/>
+                <a:spcPts val="100"/>
               </a:spcBef>
             </a:pPr>
             <a:r>
-              <a:rPr lang="pt-BR" sz="980" b="0" dirty="0">
+              <a:rPr lang="pt-BR" sz="1300" b="0" dirty="0">
                 <a:solidFill>
                   <a:srgbClr val="1E293B"/>
                 </a:solidFill>
@@ -11335,7 +11335,7 @@
               <a:buNone/>
             </a:pPr>
             <a:r>
-              <a:rPr lang="pt-BR" sz="980" b="0" dirty="0">
+              <a:rPr lang="pt-BR" sz="1300" b="0" dirty="0">
                 <a:solidFill>
                   <a:srgbClr val="1E293B"/>
                 </a:solidFill>
@@ -11348,11 +11348,11 @@
             <a:pPr indent="0" marL="0">
               <a:buNone/>
               <a:spcBef>
-                <a:spcPts val="80"/>
+                <a:spcPts val="100"/>
               </a:spcBef>
             </a:pPr>
             <a:r>
-              <a:rPr lang="pt-BR" sz="980" b="0" dirty="0">
+              <a:rPr lang="pt-BR" sz="1300" b="0" dirty="0">
                 <a:solidFill>
                   <a:srgbClr val="1E293B"/>
                 </a:solidFill>
@@ -11366,7 +11366,7 @@
               <a:buNone/>
             </a:pPr>
             <a:r>
-              <a:rPr lang="pt-BR" sz="980" b="0" dirty="0">
+              <a:rPr lang="pt-BR" sz="1300" b="0" dirty="0">
                 <a:solidFill>
                   <a:srgbClr val="1E293B"/>
                 </a:solidFill>
@@ -11379,11 +11379,11 @@
             <a:pPr indent="0" marL="0">
               <a:buNone/>
               <a:spcBef>
-                <a:spcPts val="80"/>
+                <a:spcPts val="100"/>
               </a:spcBef>
             </a:pPr>
             <a:r>
-              <a:rPr lang="pt-BR" sz="980" b="0" dirty="0">
+              <a:rPr lang="pt-BR" sz="1300" b="0" dirty="0">
                 <a:solidFill>
                   <a:srgbClr val="1E293B"/>
                 </a:solidFill>
@@ -11397,7 +11397,7 @@
               <a:buNone/>
             </a:pPr>
             <a:r>
-              <a:rPr lang="pt-BR" sz="980" b="0" dirty="0">
+              <a:rPr lang="pt-BR" sz="1300" b="0" dirty="0">
                 <a:solidFill>
                   <a:srgbClr val="1E293B"/>
                 </a:solidFill>
@@ -11411,7 +11411,7 @@
               <a:buNone/>
             </a:pPr>
             <a:r>
-              <a:rPr lang="pt-BR" sz="980" b="0" dirty="0">
+              <a:rPr lang="pt-BR" sz="1300" b="0" dirty="0">
                 <a:solidFill>
                   <a:srgbClr val="1E293B"/>
                 </a:solidFill>
@@ -11424,11 +11424,11 @@
             <a:pPr indent="0" marL="0">
               <a:buNone/>
               <a:spcBef>
-                <a:spcPts val="80"/>
+                <a:spcPts val="100"/>
               </a:spcBef>
             </a:pPr>
             <a:r>
-              <a:rPr lang="pt-BR" sz="980" b="0" dirty="0">
+              <a:rPr lang="pt-BR" sz="1300" b="0" dirty="0">
                 <a:solidFill>
                   <a:srgbClr val="1E293B"/>
                 </a:solidFill>
@@ -11506,7 +11506,7 @@
               <a:buNone/>
             </a:pPr>
             <a:r>
-              <a:rPr lang="pt-BR" sz="880" b="1" dirty="0">
+              <a:rPr lang="pt-BR" sz="1100" b="1" dirty="0">
                 <a:solidFill>
                   <a:srgbClr val="FFFFFF"/>
                 </a:solidFill>
@@ -11542,7 +11542,7 @@
               <a:buNone/>
             </a:pPr>
             <a:r>
-              <a:rPr lang="pt-BR" sz="980" b="0" dirty="0">
+              <a:rPr lang="pt-BR" sz="1300" b="0" dirty="0">
                 <a:solidFill>
                   <a:srgbClr val="1E293B"/>
                 </a:solidFill>
@@ -11556,7 +11556,7 @@
               <a:buNone/>
             </a:pPr>
             <a:r>
-              <a:rPr lang="pt-BR" sz="980" b="0" dirty="0">
+              <a:rPr lang="pt-BR" sz="1300" b="0" dirty="0">
                 <a:solidFill>
                   <a:srgbClr val="1E293B"/>
                 </a:solidFill>
@@ -11570,7 +11570,7 @@
               <a:buNone/>
             </a:pPr>
             <a:r>
-              <a:rPr lang="pt-BR" sz="980" b="0" dirty="0">
+              <a:rPr lang="pt-BR" sz="1300" b="0" dirty="0">
                 <a:solidFill>
                   <a:srgbClr val="1E293B"/>
                 </a:solidFill>
@@ -11584,7 +11584,7 @@
               <a:buNone/>
             </a:pPr>
             <a:r>
-              <a:rPr lang="pt-BR" sz="980" b="0" dirty="0">
+              <a:rPr lang="pt-BR" sz="1300" b="0" dirty="0">
                 <a:solidFill>
                   <a:srgbClr val="1E293B"/>
                 </a:solidFill>
@@ -11598,7 +11598,7 @@
               <a:buNone/>
             </a:pPr>
             <a:r>
-              <a:rPr lang="pt-BR" sz="980" b="0" dirty="0">
+              <a:rPr lang="pt-BR" sz="1300" b="0" dirty="0">
                 <a:solidFill>
                   <a:srgbClr val="1E293B"/>
                 </a:solidFill>
@@ -11611,11 +11611,11 @@
             <a:pPr indent="0" marL="0">
               <a:buNone/>
               <a:spcBef>
-                <a:spcPts val="80"/>
+                <a:spcPts val="100"/>
               </a:spcBef>
             </a:pPr>
             <a:r>
-              <a:rPr lang="pt-BR" sz="980" b="0" dirty="0">
+              <a:rPr lang="pt-BR" sz="1300" b="0" dirty="0">
                 <a:solidFill>
                   <a:srgbClr val="1E293B"/>
                 </a:solidFill>
@@ -11629,7 +11629,7 @@
               <a:buNone/>
             </a:pPr>
             <a:r>
-              <a:rPr lang="pt-BR" sz="980" b="0" dirty="0">
+              <a:rPr lang="pt-BR" sz="1300" b="0" dirty="0">
                 <a:solidFill>
                   <a:srgbClr val="1E293B"/>
                 </a:solidFill>
@@ -11643,7 +11643,7 @@
               <a:buNone/>
             </a:pPr>
             <a:r>
-              <a:rPr lang="pt-BR" sz="980" b="0" dirty="0">
+              <a:rPr lang="pt-BR" sz="1300" b="0" dirty="0">
                 <a:solidFill>
                   <a:srgbClr val="1E293B"/>
                 </a:solidFill>
@@ -11719,7 +11719,7 @@
               <a:buNone/>
             </a:pPr>
             <a:r>
-              <a:rPr lang="pt-BR" sz="800" b="1" dirty="0">
+              <a:rPr lang="pt-BR" sz="1000" b="1" dirty="0">
                 <a:solidFill>
                   <a:srgbClr val="7C3AED"/>
                 </a:solidFill>
@@ -11733,7 +11733,7 @@
               <a:buNone/>
             </a:pPr>
             <a:r>
-              <a:rPr lang="pt-BR" sz="930" b="0" dirty="0">
+              <a:rPr lang="pt-BR" sz="1200" b="0" dirty="0">
                 <a:solidFill>
                   <a:srgbClr val="334155"/>
                 </a:solidFill>
@@ -11769,7 +11769,7 @@
               <a:buNone/>
             </a:pPr>
             <a:r>
-              <a:rPr lang="pt-BR" sz="800" b="1" dirty="0">
+              <a:rPr lang="pt-BR" sz="1000" b="1" dirty="0">
                 <a:solidFill>
                   <a:srgbClr val="7C3AED"/>
                 </a:solidFill>
@@ -11783,7 +11783,7 @@
               <a:buNone/>
             </a:pPr>
             <a:r>
-              <a:rPr lang="pt-BR" sz="930" b="0" dirty="0">
+              <a:rPr lang="pt-BR" sz="1200" b="0" dirty="0">
                 <a:solidFill>
                   <a:srgbClr val="334155"/>
                 </a:solidFill>
@@ -11979,7 +11979,7 @@
               <a:buNone/>
             </a:pPr>
             <a:r>
-              <a:rPr lang="pt-BR" sz="900" b="1" dirty="0">
+              <a:rPr lang="pt-BR" sz="1100" b="1" dirty="0">
                 <a:solidFill>
                   <a:srgbClr val="FFFFFF"/>
                 </a:solidFill>
@@ -12015,7 +12015,7 @@
               <a:buNone/>
             </a:pPr>
             <a:r>
-              <a:rPr lang="pt-BR" sz="780" b="0" i="1" dirty="0">
+              <a:rPr lang="pt-BR" sz="950" b="0" i="1" dirty="0">
                 <a:solidFill>
                   <a:srgbClr val="FFFFFF"/>
                 </a:solidFill>
@@ -12071,7 +12071,7 @@
               <a:buNone/>
             </a:pPr>
             <a:r>
-              <a:rPr lang="pt-BR" sz="1150" b="0" i="1" dirty="0">
+              <a:rPr lang="pt-BR" sz="1400" b="0" i="1" dirty="0">
                 <a:solidFill>
                   <a:srgbClr val="0891B2"/>
                 </a:solidFill>
@@ -12149,7 +12149,7 @@
               <a:buNone/>
             </a:pPr>
             <a:r>
-              <a:rPr lang="pt-BR" sz="880" b="1" dirty="0">
+              <a:rPr lang="pt-BR" sz="1100" b="1" dirty="0">
                 <a:solidFill>
                   <a:srgbClr val="FFFFFF"/>
                 </a:solidFill>
@@ -12185,7 +12185,7 @@
               <a:buNone/>
             </a:pPr>
             <a:r>
-              <a:rPr lang="pt-BR" sz="980" b="0" dirty="0">
+              <a:rPr lang="pt-BR" sz="1300" b="0" dirty="0">
                 <a:solidFill>
                   <a:srgbClr val="1E293B"/>
                 </a:solidFill>
@@ -12198,11 +12198,11 @@
             <a:pPr indent="0" marL="0">
               <a:buNone/>
               <a:spcBef>
-                <a:spcPts val="80"/>
+                <a:spcPts val="100"/>
               </a:spcBef>
             </a:pPr>
             <a:r>
-              <a:rPr lang="pt-BR" sz="980" b="0" dirty="0">
+              <a:rPr lang="pt-BR" sz="1300" b="0" dirty="0">
                 <a:solidFill>
                   <a:srgbClr val="1E293B"/>
                 </a:solidFill>
@@ -12215,11 +12215,11 @@
             <a:pPr indent="0" marL="0">
               <a:buNone/>
               <a:spcBef>
-                <a:spcPts val="80"/>
+                <a:spcPts val="100"/>
               </a:spcBef>
             </a:pPr>
             <a:r>
-              <a:rPr lang="pt-BR" sz="980" b="0" dirty="0">
+              <a:rPr lang="pt-BR" sz="1300" b="0" dirty="0">
                 <a:solidFill>
                   <a:srgbClr val="1E293B"/>
                 </a:solidFill>
@@ -12233,7 +12233,7 @@
               <a:buNone/>
             </a:pPr>
             <a:r>
-              <a:rPr lang="pt-BR" sz="980" b="0" dirty="0">
+              <a:rPr lang="pt-BR" sz="1300" b="0" dirty="0">
                 <a:solidFill>
                   <a:srgbClr val="1E293B"/>
                 </a:solidFill>
@@ -12247,7 +12247,7 @@
               <a:buNone/>
             </a:pPr>
             <a:r>
-              <a:rPr lang="pt-BR" sz="980" b="0" dirty="0">
+              <a:rPr lang="pt-BR" sz="1300" b="0" dirty="0">
                 <a:solidFill>
                   <a:srgbClr val="1E293B"/>
                 </a:solidFill>
@@ -12261,7 +12261,7 @@
               <a:buNone/>
             </a:pPr>
             <a:r>
-              <a:rPr lang="pt-BR" sz="980" b="0" dirty="0">
+              <a:rPr lang="pt-BR" sz="1300" b="0" dirty="0">
                 <a:solidFill>
                   <a:srgbClr val="1E293B"/>
                 </a:solidFill>
@@ -12275,7 +12275,7 @@
               <a:buNone/>
             </a:pPr>
             <a:r>
-              <a:rPr lang="pt-BR" sz="980" b="0" dirty="0">
+              <a:rPr lang="pt-BR" sz="1300" b="0" dirty="0">
                 <a:solidFill>
                   <a:srgbClr val="1E293B"/>
                 </a:solidFill>
@@ -12353,7 +12353,7 @@
               <a:buNone/>
             </a:pPr>
             <a:r>
-              <a:rPr lang="pt-BR" sz="880" b="1" dirty="0">
+              <a:rPr lang="pt-BR" sz="1100" b="1" dirty="0">
                 <a:solidFill>
                   <a:srgbClr val="FFFFFF"/>
                 </a:solidFill>
@@ -12389,7 +12389,7 @@
               <a:buNone/>
             </a:pPr>
             <a:r>
-              <a:rPr lang="pt-BR" sz="980" b="0" dirty="0">
+              <a:rPr lang="pt-BR" sz="1300" b="0" dirty="0">
                 <a:solidFill>
                   <a:srgbClr val="1E293B"/>
                 </a:solidFill>
@@ -12403,7 +12403,7 @@
               <a:buNone/>
             </a:pPr>
             <a:r>
-              <a:rPr lang="pt-BR" sz="980" b="0" dirty="0">
+              <a:rPr lang="pt-BR" sz="1300" b="0" dirty="0">
                 <a:solidFill>
                   <a:srgbClr val="1E293B"/>
                 </a:solidFill>
@@ -12416,11 +12416,11 @@
             <a:pPr indent="0" marL="0">
               <a:buNone/>
               <a:spcBef>
-                <a:spcPts val="80"/>
+                <a:spcPts val="100"/>
               </a:spcBef>
             </a:pPr>
             <a:r>
-              <a:rPr lang="pt-BR" sz="980" b="0" dirty="0">
+              <a:rPr lang="pt-BR" sz="1300" b="0" dirty="0">
                 <a:solidFill>
                   <a:srgbClr val="1E293B"/>
                 </a:solidFill>
@@ -12434,7 +12434,7 @@
               <a:buNone/>
             </a:pPr>
             <a:r>
-              <a:rPr lang="pt-BR" sz="980" b="0" dirty="0">
+              <a:rPr lang="pt-BR" sz="1300" b="0" dirty="0">
                 <a:solidFill>
                   <a:srgbClr val="1E293B"/>
                 </a:solidFill>
@@ -12448,7 +12448,7 @@
               <a:buNone/>
             </a:pPr>
             <a:r>
-              <a:rPr lang="pt-BR" sz="980" b="0" dirty="0">
+              <a:rPr lang="pt-BR" sz="1300" b="0" dirty="0">
                 <a:solidFill>
                   <a:srgbClr val="1E293B"/>
                 </a:solidFill>
@@ -12461,11 +12461,11 @@
             <a:pPr indent="0" marL="0">
               <a:buNone/>
               <a:spcBef>
-                <a:spcPts val="80"/>
+                <a:spcPts val="100"/>
               </a:spcBef>
             </a:pPr>
             <a:r>
-              <a:rPr lang="pt-BR" sz="980" b="0" dirty="0">
+              <a:rPr lang="pt-BR" sz="1300" b="0" dirty="0">
                 <a:solidFill>
                   <a:srgbClr val="1E293B"/>
                 </a:solidFill>
@@ -12479,7 +12479,7 @@
               <a:buNone/>
             </a:pPr>
             <a:r>
-              <a:rPr lang="pt-BR" sz="980" b="0" dirty="0">
+              <a:rPr lang="pt-BR" sz="1300" b="0" dirty="0">
                 <a:solidFill>
                   <a:srgbClr val="1E293B"/>
                 </a:solidFill>
@@ -12492,11 +12492,11 @@
             <a:pPr indent="0" marL="0">
               <a:buNone/>
               <a:spcBef>
-                <a:spcPts val="80"/>
+                <a:spcPts val="100"/>
               </a:spcBef>
             </a:pPr>
             <a:r>
-              <a:rPr lang="pt-BR" sz="980" b="0" dirty="0">
+              <a:rPr lang="pt-BR" sz="1300" b="0" dirty="0">
                 <a:solidFill>
                   <a:srgbClr val="1E293B"/>
                 </a:solidFill>
@@ -12510,7 +12510,7 @@
               <a:buNone/>
             </a:pPr>
             <a:r>
-              <a:rPr lang="pt-BR" sz="980" b="0" dirty="0">
+              <a:rPr lang="pt-BR" sz="1300" b="0" dirty="0">
                 <a:solidFill>
                   <a:srgbClr val="1E293B"/>
                 </a:solidFill>
@@ -12588,7 +12588,7 @@
               <a:buNone/>
             </a:pPr>
             <a:r>
-              <a:rPr lang="pt-BR" sz="880" b="1" dirty="0">
+              <a:rPr lang="pt-BR" sz="1100" b="1" dirty="0">
                 <a:solidFill>
                   <a:srgbClr val="FFFFFF"/>
                 </a:solidFill>
@@ -12624,7 +12624,7 @@
               <a:buNone/>
             </a:pPr>
             <a:r>
-              <a:rPr lang="pt-BR" sz="980" b="0" dirty="0">
+              <a:rPr lang="pt-BR" sz="1300" b="0" dirty="0">
                 <a:solidFill>
                   <a:srgbClr val="1E293B"/>
                 </a:solidFill>
@@ -12638,7 +12638,7 @@
               <a:buNone/>
             </a:pPr>
             <a:r>
-              <a:rPr lang="pt-BR" sz="980" b="0" dirty="0">
+              <a:rPr lang="pt-BR" sz="1300" b="0" dirty="0">
                 <a:solidFill>
                   <a:srgbClr val="1E293B"/>
                 </a:solidFill>
@@ -12652,7 +12652,7 @@
               <a:buNone/>
             </a:pPr>
             <a:r>
-              <a:rPr lang="pt-BR" sz="980" b="0" dirty="0">
+              <a:rPr lang="pt-BR" sz="1300" b="0" dirty="0">
                 <a:solidFill>
                   <a:srgbClr val="1E293B"/>
                 </a:solidFill>
@@ -12666,7 +12666,7 @@
               <a:buNone/>
             </a:pPr>
             <a:r>
-              <a:rPr lang="pt-BR" sz="980" b="0" dirty="0">
+              <a:rPr lang="pt-BR" sz="1300" b="0" dirty="0">
                 <a:solidFill>
                   <a:srgbClr val="1E293B"/>
                 </a:solidFill>
@@ -12680,7 +12680,7 @@
               <a:buNone/>
             </a:pPr>
             <a:r>
-              <a:rPr lang="pt-BR" sz="980" b="0" dirty="0">
+              <a:rPr lang="pt-BR" sz="1300" b="0" dirty="0">
                 <a:solidFill>
                   <a:srgbClr val="1E293B"/>
                 </a:solidFill>
@@ -12694,7 +12694,7 @@
               <a:buNone/>
             </a:pPr>
             <a:r>
-              <a:rPr lang="pt-BR" sz="980" b="0" dirty="0">
+              <a:rPr lang="pt-BR" sz="1300" b="0" dirty="0">
                 <a:solidFill>
                   <a:srgbClr val="1E293B"/>
                 </a:solidFill>
@@ -12708,7 +12708,7 @@
               <a:buNone/>
             </a:pPr>
             <a:r>
-              <a:rPr lang="pt-BR" sz="980" b="0" dirty="0">
+              <a:rPr lang="pt-BR" sz="1300" b="0" dirty="0">
                 <a:solidFill>
                   <a:srgbClr val="1E293B"/>
                 </a:solidFill>
@@ -12784,7 +12784,7 @@
               <a:buNone/>
             </a:pPr>
             <a:r>
-              <a:rPr lang="pt-BR" sz="800" b="1" dirty="0">
+              <a:rPr lang="pt-BR" sz="1000" b="1" dirty="0">
                 <a:solidFill>
                   <a:srgbClr val="0891B2"/>
                 </a:solidFill>
@@ -12798,7 +12798,7 @@
               <a:buNone/>
             </a:pPr>
             <a:r>
-              <a:rPr lang="pt-BR" sz="930" b="0" dirty="0">
+              <a:rPr lang="pt-BR" sz="1200" b="0" dirty="0">
                 <a:solidFill>
                   <a:srgbClr val="334155"/>
                 </a:solidFill>
@@ -12834,7 +12834,7 @@
               <a:buNone/>
             </a:pPr>
             <a:r>
-              <a:rPr lang="pt-BR" sz="800" b="1" dirty="0">
+              <a:rPr lang="pt-BR" sz="1000" b="1" dirty="0">
                 <a:solidFill>
                   <a:srgbClr val="0891B2"/>
                 </a:solidFill>
@@ -12848,7 +12848,7 @@
               <a:buNone/>
             </a:pPr>
             <a:r>
-              <a:rPr lang="pt-BR" sz="930" b="0" dirty="0">
+              <a:rPr lang="pt-BR" sz="1200" b="0" dirty="0">
                 <a:solidFill>
                   <a:srgbClr val="334155"/>
                 </a:solidFill>
@@ -13044,7 +13044,7 @@
               <a:buNone/>
             </a:pPr>
             <a:r>
-              <a:rPr lang="pt-BR" sz="900" b="1" dirty="0">
+              <a:rPr lang="pt-BR" sz="1100" b="1" dirty="0">
                 <a:solidFill>
                   <a:srgbClr val="FFFFFF"/>
                 </a:solidFill>
@@ -13080,7 +13080,7 @@
               <a:buNone/>
             </a:pPr>
             <a:r>
-              <a:rPr lang="pt-BR" sz="780" b="0" i="1" dirty="0">
+              <a:rPr lang="pt-BR" sz="950" b="0" i="1" dirty="0">
                 <a:solidFill>
                   <a:srgbClr val="FFFFFF"/>
                 </a:solidFill>
@@ -13136,7 +13136,7 @@
               <a:buNone/>
             </a:pPr>
             <a:r>
-              <a:rPr lang="pt-BR" sz="1150" b="0" i="1" dirty="0">
+              <a:rPr lang="pt-BR" sz="1400" b="0" i="1" dirty="0">
                 <a:solidFill>
                   <a:srgbClr val="059669"/>
                 </a:solidFill>
@@ -13214,7 +13214,7 @@
               <a:buNone/>
             </a:pPr>
             <a:r>
-              <a:rPr lang="pt-BR" sz="880" b="1" dirty="0">
+              <a:rPr lang="pt-BR" sz="1100" b="1" dirty="0">
                 <a:solidFill>
                   <a:srgbClr val="FFFFFF"/>
                 </a:solidFill>
@@ -13250,7 +13250,7 @@
               <a:buNone/>
             </a:pPr>
             <a:r>
-              <a:rPr lang="pt-BR" sz="980" b="0" dirty="0">
+              <a:rPr lang="pt-BR" sz="1300" b="0" dirty="0">
                 <a:solidFill>
                   <a:srgbClr val="1E293B"/>
                 </a:solidFill>
@@ -13264,7 +13264,7 @@
               <a:buNone/>
             </a:pPr>
             <a:r>
-              <a:rPr lang="pt-BR" sz="980" b="0" dirty="0">
+              <a:rPr lang="pt-BR" sz="1300" b="0" dirty="0">
                 <a:solidFill>
                   <a:srgbClr val="1E293B"/>
                 </a:solidFill>
@@ -13277,11 +13277,11 @@
             <a:pPr indent="0" marL="0">
               <a:buNone/>
               <a:spcBef>
-                <a:spcPts val="80"/>
+                <a:spcPts val="100"/>
               </a:spcBef>
             </a:pPr>
             <a:r>
-              <a:rPr lang="pt-BR" sz="980" b="0" dirty="0">
+              <a:rPr lang="pt-BR" sz="1300" b="0" dirty="0">
                 <a:solidFill>
                   <a:srgbClr val="1E293B"/>
                 </a:solidFill>
@@ -13294,11 +13294,11 @@
             <a:pPr indent="0" marL="0">
               <a:buNone/>
               <a:spcBef>
-                <a:spcPts val="80"/>
+                <a:spcPts val="100"/>
               </a:spcBef>
             </a:pPr>
             <a:r>
-              <a:rPr lang="pt-BR" sz="980" b="0" dirty="0">
+              <a:rPr lang="pt-BR" sz="1300" b="0" dirty="0">
                 <a:solidFill>
                   <a:srgbClr val="1E293B"/>
                 </a:solidFill>
@@ -13311,11 +13311,11 @@
             <a:pPr indent="0" marL="0">
               <a:buNone/>
               <a:spcBef>
-                <a:spcPts val="80"/>
+                <a:spcPts val="100"/>
               </a:spcBef>
             </a:pPr>
             <a:r>
-              <a:rPr lang="pt-BR" sz="980" b="0" dirty="0">
+              <a:rPr lang="pt-BR" sz="1300" b="0" dirty="0">
                 <a:solidFill>
                   <a:srgbClr val="1E293B"/>
                 </a:solidFill>
@@ -13329,7 +13329,7 @@
               <a:buNone/>
             </a:pPr>
             <a:r>
-              <a:rPr lang="pt-BR" sz="980" b="0" dirty="0">
+              <a:rPr lang="pt-BR" sz="1300" b="0" dirty="0">
                 <a:solidFill>
                   <a:srgbClr val="1E293B"/>
                 </a:solidFill>
@@ -13343,7 +13343,7 @@
               <a:buNone/>
             </a:pPr>
             <a:r>
-              <a:rPr lang="pt-BR" sz="980" b="0" dirty="0">
+              <a:rPr lang="pt-BR" sz="1300" b="0" dirty="0">
                 <a:solidFill>
                   <a:srgbClr val="1E293B"/>
                 </a:solidFill>
@@ -13421,7 +13421,7 @@
               <a:buNone/>
             </a:pPr>
             <a:r>
-              <a:rPr lang="pt-BR" sz="880" b="1" dirty="0">
+              <a:rPr lang="pt-BR" sz="1100" b="1" dirty="0">
                 <a:solidFill>
                   <a:srgbClr val="FFFFFF"/>
                 </a:solidFill>
@@ -13457,7 +13457,7 @@
               <a:buNone/>
             </a:pPr>
             <a:r>
-              <a:rPr lang="pt-BR" sz="980" b="0" dirty="0">
+              <a:rPr lang="pt-BR" sz="1300" b="0" dirty="0">
                 <a:solidFill>
                   <a:srgbClr val="1E293B"/>
                 </a:solidFill>
@@ -13471,7 +13471,7 @@
               <a:buNone/>
             </a:pPr>
             <a:r>
-              <a:rPr lang="pt-BR" sz="980" b="0" dirty="0">
+              <a:rPr lang="pt-BR" sz="1300" b="0" dirty="0">
                 <a:solidFill>
                   <a:srgbClr val="1E293B"/>
                 </a:solidFill>
@@ -13484,11 +13484,11 @@
             <a:pPr indent="0" marL="0">
               <a:buNone/>
               <a:spcBef>
-                <a:spcPts val="80"/>
+                <a:spcPts val="100"/>
               </a:spcBef>
             </a:pPr>
             <a:r>
-              <a:rPr lang="pt-BR" sz="980" b="0" dirty="0">
+              <a:rPr lang="pt-BR" sz="1300" b="0" dirty="0">
                 <a:solidFill>
                   <a:srgbClr val="1E293B"/>
                 </a:solidFill>
@@ -13502,7 +13502,7 @@
               <a:buNone/>
             </a:pPr>
             <a:r>
-              <a:rPr lang="pt-BR" sz="980" b="0" dirty="0">
+              <a:rPr lang="pt-BR" sz="1300" b="0" dirty="0">
                 <a:solidFill>
                   <a:srgbClr val="1E293B"/>
                 </a:solidFill>
@@ -13516,7 +13516,7 @@
               <a:buNone/>
             </a:pPr>
             <a:r>
-              <a:rPr lang="pt-BR" sz="980" b="0" dirty="0">
+              <a:rPr lang="pt-BR" sz="1300" b="0" dirty="0">
                 <a:solidFill>
                   <a:srgbClr val="1E293B"/>
                 </a:solidFill>
@@ -13529,11 +13529,11 @@
             <a:pPr indent="0" marL="0">
               <a:buNone/>
               <a:spcBef>
-                <a:spcPts val="80"/>
+                <a:spcPts val="100"/>
               </a:spcBef>
             </a:pPr>
             <a:r>
-              <a:rPr lang="pt-BR" sz="980" b="0" dirty="0">
+              <a:rPr lang="pt-BR" sz="1300" b="0" dirty="0">
                 <a:solidFill>
                   <a:srgbClr val="1E293B"/>
                 </a:solidFill>
@@ -13547,7 +13547,7 @@
               <a:buNone/>
             </a:pPr>
             <a:r>
-              <a:rPr lang="pt-BR" sz="980" b="0" dirty="0">
+              <a:rPr lang="pt-BR" sz="1300" b="0" dirty="0">
                 <a:solidFill>
                   <a:srgbClr val="1E293B"/>
                 </a:solidFill>
@@ -13561,7 +13561,7 @@
               <a:buNone/>
             </a:pPr>
             <a:r>
-              <a:rPr lang="pt-BR" sz="980" b="0" dirty="0">
+              <a:rPr lang="pt-BR" sz="1300" b="0" dirty="0">
                 <a:solidFill>
                   <a:srgbClr val="1E293B"/>
                 </a:solidFill>
@@ -13574,11 +13574,11 @@
             <a:pPr indent="0" marL="0">
               <a:buNone/>
               <a:spcBef>
-                <a:spcPts val="80"/>
+                <a:spcPts val="100"/>
               </a:spcBef>
             </a:pPr>
             <a:r>
-              <a:rPr lang="pt-BR" sz="980" b="0" dirty="0">
+              <a:rPr lang="pt-BR" sz="1300" b="0" dirty="0">
                 <a:solidFill>
                   <a:srgbClr val="1E293B"/>
                 </a:solidFill>
@@ -13592,7 +13592,7 @@
               <a:buNone/>
             </a:pPr>
             <a:r>
-              <a:rPr lang="pt-BR" sz="980" b="0" dirty="0">
+              <a:rPr lang="pt-BR" sz="1300" b="0" dirty="0">
                 <a:solidFill>
                   <a:srgbClr val="1E293B"/>
                 </a:solidFill>
@@ -13670,7 +13670,7 @@
               <a:buNone/>
             </a:pPr>
             <a:r>
-              <a:rPr lang="pt-BR" sz="880" b="1" dirty="0">
+              <a:rPr lang="pt-BR" sz="1100" b="1" dirty="0">
                 <a:solidFill>
                   <a:srgbClr val="FFFFFF"/>
                 </a:solidFill>
@@ -13706,7 +13706,7 @@
               <a:buNone/>
             </a:pPr>
             <a:r>
-              <a:rPr lang="pt-BR" sz="980" b="0" dirty="0">
+              <a:rPr lang="pt-BR" sz="1300" b="0" dirty="0">
                 <a:solidFill>
                   <a:srgbClr val="1E293B"/>
                 </a:solidFill>
@@ -13719,11 +13719,11 @@
             <a:pPr indent="0" marL="0">
               <a:buNone/>
               <a:spcBef>
-                <a:spcPts val="80"/>
+                <a:spcPts val="100"/>
               </a:spcBef>
             </a:pPr>
             <a:r>
-              <a:rPr lang="pt-BR" sz="980" b="0" dirty="0">
+              <a:rPr lang="pt-BR" sz="1300" b="0" dirty="0">
                 <a:solidFill>
                   <a:srgbClr val="1E293B"/>
                 </a:solidFill>
@@ -13737,7 +13737,7 @@
               <a:buNone/>
             </a:pPr>
             <a:r>
-              <a:rPr lang="pt-BR" sz="980" b="0" dirty="0">
+              <a:rPr lang="pt-BR" sz="1300" b="0" dirty="0">
                 <a:solidFill>
                   <a:srgbClr val="1E293B"/>
                 </a:solidFill>
@@ -13751,7 +13751,7 @@
               <a:buNone/>
             </a:pPr>
             <a:r>
-              <a:rPr lang="pt-BR" sz="980" b="0" dirty="0">
+              <a:rPr lang="pt-BR" sz="1300" b="0" dirty="0">
                 <a:solidFill>
                   <a:srgbClr val="1E293B"/>
                 </a:solidFill>
@@ -13764,11 +13764,11 @@
             <a:pPr indent="0" marL="0">
               <a:buNone/>
               <a:spcBef>
-                <a:spcPts val="80"/>
+                <a:spcPts val="100"/>
               </a:spcBef>
             </a:pPr>
             <a:r>
-              <a:rPr lang="pt-BR" sz="980" b="0" dirty="0">
+              <a:rPr lang="pt-BR" sz="1300" b="0" dirty="0">
                 <a:solidFill>
                   <a:srgbClr val="1E293B"/>
                 </a:solidFill>
@@ -13782,7 +13782,7 @@
               <a:buNone/>
             </a:pPr>
             <a:r>
-              <a:rPr lang="pt-BR" sz="980" b="0" dirty="0">
+              <a:rPr lang="pt-BR" sz="1300" b="0" dirty="0">
                 <a:solidFill>
                   <a:srgbClr val="1E293B"/>
                 </a:solidFill>
@@ -13795,11 +13795,11 @@
             <a:pPr indent="0" marL="0">
               <a:buNone/>
               <a:spcBef>
-                <a:spcPts val="80"/>
+                <a:spcPts val="100"/>
               </a:spcBef>
             </a:pPr>
             <a:r>
-              <a:rPr lang="pt-BR" sz="980" b="0" dirty="0">
+              <a:rPr lang="pt-BR" sz="1300" b="0" dirty="0">
                 <a:solidFill>
                   <a:srgbClr val="1E293B"/>
                 </a:solidFill>
@@ -13875,7 +13875,7 @@
               <a:buNone/>
             </a:pPr>
             <a:r>
-              <a:rPr lang="pt-BR" sz="800" b="1" dirty="0">
+              <a:rPr lang="pt-BR" sz="1000" b="1" dirty="0">
                 <a:solidFill>
                   <a:srgbClr val="059669"/>
                 </a:solidFill>
@@ -13889,7 +13889,7 @@
               <a:buNone/>
             </a:pPr>
             <a:r>
-              <a:rPr lang="pt-BR" sz="930" b="0" dirty="0">
+              <a:rPr lang="pt-BR" sz="1200" b="0" dirty="0">
                 <a:solidFill>
                   <a:srgbClr val="334155"/>
                 </a:solidFill>
@@ -13925,7 +13925,7 @@
               <a:buNone/>
             </a:pPr>
             <a:r>
-              <a:rPr lang="pt-BR" sz="800" b="1" dirty="0">
+              <a:rPr lang="pt-BR" sz="1000" b="1" dirty="0">
                 <a:solidFill>
                   <a:srgbClr val="059669"/>
                 </a:solidFill>
@@ -13939,7 +13939,7 @@
               <a:buNone/>
             </a:pPr>
             <a:r>
-              <a:rPr lang="pt-BR" sz="930" b="0" dirty="0">
+              <a:rPr lang="pt-BR" sz="1200" b="0" dirty="0">
                 <a:solidFill>
                   <a:srgbClr val="334155"/>
                 </a:solidFill>
@@ -14692,7 +14692,7 @@
               <a:buNone/>
             </a:pPr>
             <a:r>
-              <a:rPr lang="pt-BR" sz="1000" b="0" i="1" dirty="0">
+              <a:rPr lang="pt-BR" sz="1200" b="0" i="1" dirty="0">
                 <a:solidFill>
                   <a:srgbClr val="FFFFFF"/>
                 </a:solidFill>
@@ -14728,7 +14728,7 @@
               <a:buNone/>
             </a:pPr>
             <a:r>
-              <a:rPr lang="pt-BR" sz="900" b="1" dirty="0">
+              <a:rPr lang="pt-BR" sz="1100" b="1" dirty="0">
                 <a:solidFill>
                   <a:srgbClr val="FFFFFF"/>
                 </a:solidFill>
@@ -14764,7 +14764,7 @@
               <a:buNone/>
             </a:pPr>
             <a:r>
-              <a:rPr lang="pt-BR" sz="780" b="0" i="1" dirty="0">
+              <a:rPr lang="pt-BR" sz="950" b="0" i="1" dirty="0">
                 <a:solidFill>
                   <a:srgbClr val="FFFFFF"/>
                 </a:solidFill>
@@ -14820,7 +14820,7 @@
               <a:buNone/>
             </a:pPr>
             <a:r>
-              <a:rPr lang="pt-BR" sz="1150" b="0" i="1" dirty="0">
+              <a:rPr lang="pt-BR" sz="1400" b="0" i="1" dirty="0">
                 <a:solidFill>
                   <a:srgbClr val="DC2626"/>
                 </a:solidFill>
@@ -14898,7 +14898,7 @@
               <a:buNone/>
             </a:pPr>
             <a:r>
-              <a:rPr lang="pt-BR" sz="880" b="1" dirty="0">
+              <a:rPr lang="pt-BR" sz="1100" b="1" dirty="0">
                 <a:solidFill>
                   <a:srgbClr val="FFFFFF"/>
                 </a:solidFill>
@@ -14934,7 +14934,7 @@
               <a:buNone/>
             </a:pPr>
             <a:r>
-              <a:rPr lang="pt-BR" sz="980" b="0" dirty="0">
+              <a:rPr lang="pt-BR" sz="1300" b="0" dirty="0">
                 <a:solidFill>
                   <a:srgbClr val="1E293B"/>
                 </a:solidFill>
@@ -14948,7 +14948,7 @@
               <a:buNone/>
             </a:pPr>
             <a:r>
-              <a:rPr lang="pt-BR" sz="980" b="0" dirty="0">
+              <a:rPr lang="pt-BR" sz="1300" b="0" dirty="0">
                 <a:solidFill>
                   <a:srgbClr val="1E293B"/>
                 </a:solidFill>
@@ -14961,11 +14961,11 @@
             <a:pPr indent="0" marL="0">
               <a:buNone/>
               <a:spcBef>
-                <a:spcPts val="80"/>
+                <a:spcPts val="100"/>
               </a:spcBef>
             </a:pPr>
             <a:r>
-              <a:rPr lang="pt-BR" sz="980" b="0" dirty="0">
+              <a:rPr lang="pt-BR" sz="1300" b="0" dirty="0">
                 <a:solidFill>
                   <a:srgbClr val="1E293B"/>
                 </a:solidFill>
@@ -14979,7 +14979,7 @@
               <a:buNone/>
             </a:pPr>
             <a:r>
-              <a:rPr lang="pt-BR" sz="980" b="0" dirty="0">
+              <a:rPr lang="pt-BR" sz="1300" b="0" dirty="0">
                 <a:solidFill>
                   <a:srgbClr val="1E293B"/>
                 </a:solidFill>
@@ -14992,11 +14992,11 @@
             <a:pPr indent="0" marL="0">
               <a:buNone/>
               <a:spcBef>
-                <a:spcPts val="80"/>
+                <a:spcPts val="100"/>
               </a:spcBef>
             </a:pPr>
             <a:r>
-              <a:rPr lang="pt-BR" sz="980" b="0" dirty="0">
+              <a:rPr lang="pt-BR" sz="1300" b="0" dirty="0">
                 <a:solidFill>
                   <a:srgbClr val="1E293B"/>
                 </a:solidFill>
@@ -15010,7 +15010,7 @@
               <a:buNone/>
             </a:pPr>
             <a:r>
-              <a:rPr lang="pt-BR" sz="980" b="0" dirty="0">
+              <a:rPr lang="pt-BR" sz="1300" b="0" dirty="0">
                 <a:solidFill>
                   <a:srgbClr val="1E293B"/>
                 </a:solidFill>
@@ -15088,7 +15088,7 @@
               <a:buNone/>
             </a:pPr>
             <a:r>
-              <a:rPr lang="pt-BR" sz="880" b="1" dirty="0">
+              <a:rPr lang="pt-BR" sz="1100" b="1" dirty="0">
                 <a:solidFill>
                   <a:srgbClr val="FFFFFF"/>
                 </a:solidFill>
@@ -15124,7 +15124,7 @@
               <a:buNone/>
             </a:pPr>
             <a:r>
-              <a:rPr lang="pt-BR" sz="980" b="0" dirty="0">
+              <a:rPr lang="pt-BR" sz="1300" b="0" dirty="0">
                 <a:solidFill>
                   <a:srgbClr val="1E293B"/>
                 </a:solidFill>
@@ -15138,7 +15138,7 @@
               <a:buNone/>
             </a:pPr>
             <a:r>
-              <a:rPr lang="pt-BR" sz="980" b="0" dirty="0">
+              <a:rPr lang="pt-BR" sz="1300" b="0" dirty="0">
                 <a:solidFill>
                   <a:srgbClr val="1E293B"/>
                 </a:solidFill>
@@ -15151,11 +15151,11 @@
             <a:pPr indent="0" marL="0">
               <a:buNone/>
               <a:spcBef>
-                <a:spcPts val="80"/>
+                <a:spcPts val="100"/>
               </a:spcBef>
             </a:pPr>
             <a:r>
-              <a:rPr lang="pt-BR" sz="980" b="0" dirty="0">
+              <a:rPr lang="pt-BR" sz="1300" b="0" dirty="0">
                 <a:solidFill>
                   <a:srgbClr val="1E293B"/>
                 </a:solidFill>
@@ -15169,7 +15169,7 @@
               <a:buNone/>
             </a:pPr>
             <a:r>
-              <a:rPr lang="pt-BR" sz="980" b="0" dirty="0">
+              <a:rPr lang="pt-BR" sz="1300" b="0" dirty="0">
                 <a:solidFill>
                   <a:srgbClr val="1E293B"/>
                 </a:solidFill>
@@ -15182,11 +15182,11 @@
             <a:pPr indent="0" marL="0">
               <a:buNone/>
               <a:spcBef>
-                <a:spcPts val="80"/>
+                <a:spcPts val="100"/>
               </a:spcBef>
             </a:pPr>
             <a:r>
-              <a:rPr lang="pt-BR" sz="980" b="0" dirty="0">
+              <a:rPr lang="pt-BR" sz="1300" b="0" dirty="0">
                 <a:solidFill>
                   <a:srgbClr val="1E293B"/>
                 </a:solidFill>
@@ -15200,7 +15200,7 @@
               <a:buNone/>
             </a:pPr>
             <a:r>
-              <a:rPr lang="pt-BR" sz="980" b="0" dirty="0">
+              <a:rPr lang="pt-BR" sz="1300" b="0" dirty="0">
                 <a:solidFill>
                   <a:srgbClr val="1E293B"/>
                 </a:solidFill>
@@ -15214,7 +15214,7 @@
               <a:buNone/>
             </a:pPr>
             <a:r>
-              <a:rPr lang="pt-BR" sz="980" b="0" dirty="0">
+              <a:rPr lang="pt-BR" sz="1300" b="0" dirty="0">
                 <a:solidFill>
                   <a:srgbClr val="1E293B"/>
                 </a:solidFill>
@@ -15227,11 +15227,11 @@
             <a:pPr indent="0" marL="0">
               <a:buNone/>
               <a:spcBef>
-                <a:spcPts val="80"/>
+                <a:spcPts val="100"/>
               </a:spcBef>
             </a:pPr>
             <a:r>
-              <a:rPr lang="pt-BR" sz="980" b="0" dirty="0">
+              <a:rPr lang="pt-BR" sz="1300" b="0" dirty="0">
                 <a:solidFill>
                   <a:srgbClr val="1E293B"/>
                 </a:solidFill>
@@ -15245,7 +15245,7 @@
               <a:buNone/>
             </a:pPr>
             <a:r>
-              <a:rPr lang="pt-BR" sz="980" b="0" dirty="0">
+              <a:rPr lang="pt-BR" sz="1300" b="0" dirty="0">
                 <a:solidFill>
                   <a:srgbClr val="1E293B"/>
                 </a:solidFill>
@@ -15323,7 +15323,7 @@
               <a:buNone/>
             </a:pPr>
             <a:r>
-              <a:rPr lang="pt-BR" sz="880" b="1" dirty="0">
+              <a:rPr lang="pt-BR" sz="1100" b="1" dirty="0">
                 <a:solidFill>
                   <a:srgbClr val="FFFFFF"/>
                 </a:solidFill>
@@ -15359,7 +15359,7 @@
               <a:buNone/>
             </a:pPr>
             <a:r>
-              <a:rPr lang="pt-BR" sz="980" b="0" dirty="0">
+              <a:rPr lang="pt-BR" sz="1300" b="0" dirty="0">
                 <a:solidFill>
                   <a:srgbClr val="1E293B"/>
                 </a:solidFill>
@@ -15373,7 +15373,7 @@
               <a:buNone/>
             </a:pPr>
             <a:r>
-              <a:rPr lang="pt-BR" sz="980" b="0" dirty="0">
+              <a:rPr lang="pt-BR" sz="1300" b="0" dirty="0">
                 <a:solidFill>
                   <a:srgbClr val="1E293B"/>
                 </a:solidFill>
@@ -15387,7 +15387,7 @@
               <a:buNone/>
             </a:pPr>
             <a:r>
-              <a:rPr lang="pt-BR" sz="980" b="0" dirty="0">
+              <a:rPr lang="pt-BR" sz="1300" b="0" dirty="0">
                 <a:solidFill>
                   <a:srgbClr val="1E293B"/>
                 </a:solidFill>
@@ -15401,7 +15401,7 @@
               <a:buNone/>
             </a:pPr>
             <a:r>
-              <a:rPr lang="pt-BR" sz="980" b="0" dirty="0">
+              <a:rPr lang="pt-BR" sz="1300" b="0" dirty="0">
                 <a:solidFill>
                   <a:srgbClr val="1E293B"/>
                 </a:solidFill>
@@ -15415,7 +15415,7 @@
               <a:buNone/>
             </a:pPr>
             <a:r>
-              <a:rPr lang="pt-BR" sz="980" b="0" dirty="0">
+              <a:rPr lang="pt-BR" sz="1300" b="0" dirty="0">
                 <a:solidFill>
                   <a:srgbClr val="1E293B"/>
                 </a:solidFill>
@@ -15429,7 +15429,7 @@
               <a:buNone/>
             </a:pPr>
             <a:r>
-              <a:rPr lang="pt-BR" sz="980" b="0" dirty="0">
+              <a:rPr lang="pt-BR" sz="1300" b="0" dirty="0">
                 <a:solidFill>
                   <a:srgbClr val="1E293B"/>
                 </a:solidFill>
@@ -15443,7 +15443,7 @@
               <a:buNone/>
             </a:pPr>
             <a:r>
-              <a:rPr lang="pt-BR" sz="980" b="0" dirty="0">
+              <a:rPr lang="pt-BR" sz="1300" b="0" dirty="0">
                 <a:solidFill>
                   <a:srgbClr val="1E293B"/>
                 </a:solidFill>
@@ -15519,7 +15519,7 @@
               <a:buNone/>
             </a:pPr>
             <a:r>
-              <a:rPr lang="pt-BR" sz="800" b="1" dirty="0">
+              <a:rPr lang="pt-BR" sz="1000" b="1" dirty="0">
                 <a:solidFill>
                   <a:srgbClr val="DC2626"/>
                 </a:solidFill>
@@ -15533,7 +15533,7 @@
               <a:buNone/>
             </a:pPr>
             <a:r>
-              <a:rPr lang="pt-BR" sz="930" b="0" dirty="0">
+              <a:rPr lang="pt-BR" sz="1200" b="0" dirty="0">
                 <a:solidFill>
                   <a:srgbClr val="334155"/>
                 </a:solidFill>
@@ -15569,7 +15569,7 @@
               <a:buNone/>
             </a:pPr>
             <a:r>
-              <a:rPr lang="pt-BR" sz="800" b="1" dirty="0">
+              <a:rPr lang="pt-BR" sz="1000" b="1" dirty="0">
                 <a:solidFill>
                   <a:srgbClr val="DC2626"/>
                 </a:solidFill>
@@ -15583,7 +15583,7 @@
               <a:buNone/>
             </a:pPr>
             <a:r>
-              <a:rPr lang="pt-BR" sz="930" b="0" dirty="0">
+              <a:rPr lang="pt-BR" sz="1200" b="0" dirty="0">
                 <a:solidFill>
                   <a:srgbClr val="334155"/>
                 </a:solidFill>
@@ -15757,7 +15757,7 @@
               <a:buNone/>
             </a:pPr>
             <a:r>
-              <a:rPr lang="pt-BR" sz="1000" b="0" i="1" dirty="0">
+              <a:rPr lang="pt-BR" sz="1200" b="0" i="1" dirty="0">
                 <a:solidFill>
                   <a:srgbClr val="FFFFFF"/>
                 </a:solidFill>
@@ -15793,7 +15793,7 @@
               <a:buNone/>
             </a:pPr>
             <a:r>
-              <a:rPr lang="pt-BR" sz="900" b="1" dirty="0">
+              <a:rPr lang="pt-BR" sz="1100" b="1" dirty="0">
                 <a:solidFill>
                   <a:srgbClr val="FFFFFF"/>
                 </a:solidFill>
@@ -15829,7 +15829,7 @@
               <a:buNone/>
             </a:pPr>
             <a:r>
-              <a:rPr lang="pt-BR" sz="780" b="0" i="1" dirty="0">
+              <a:rPr lang="pt-BR" sz="950" b="0" i="1" dirty="0">
                 <a:solidFill>
                   <a:srgbClr val="FFFFFF"/>
                 </a:solidFill>
@@ -15885,7 +15885,7 @@
               <a:buNone/>
             </a:pPr>
             <a:r>
-              <a:rPr lang="pt-BR" sz="1150" b="0" i="1" dirty="0">
+              <a:rPr lang="pt-BR" sz="1400" b="0" i="1" dirty="0">
                 <a:solidFill>
                   <a:srgbClr val="DC2626"/>
                 </a:solidFill>
@@ -15963,7 +15963,7 @@
               <a:buNone/>
             </a:pPr>
             <a:r>
-              <a:rPr lang="pt-BR" sz="880" b="1" dirty="0">
+              <a:rPr lang="pt-BR" sz="1100" b="1" dirty="0">
                 <a:solidFill>
                   <a:srgbClr val="FFFFFF"/>
                 </a:solidFill>
@@ -15999,7 +15999,7 @@
               <a:buNone/>
             </a:pPr>
             <a:r>
-              <a:rPr lang="pt-BR" sz="980" b="0" dirty="0">
+              <a:rPr lang="pt-BR" sz="1300" b="0" dirty="0">
                 <a:solidFill>
                   <a:srgbClr val="1E293B"/>
                 </a:solidFill>
@@ -16013,7 +16013,7 @@
               <a:buNone/>
             </a:pPr>
             <a:r>
-              <a:rPr lang="pt-BR" sz="980" b="0" dirty="0">
+              <a:rPr lang="pt-BR" sz="1300" b="0" dirty="0">
                 <a:solidFill>
                   <a:srgbClr val="1E293B"/>
                 </a:solidFill>
@@ -16027,7 +16027,7 @@
               <a:buNone/>
             </a:pPr>
             <a:r>
-              <a:rPr lang="pt-BR" sz="980" b="0" dirty="0">
+              <a:rPr lang="pt-BR" sz="1300" b="0" dirty="0">
                 <a:solidFill>
                   <a:srgbClr val="1E293B"/>
                 </a:solidFill>
@@ -16041,7 +16041,7 @@
               <a:buNone/>
             </a:pPr>
             <a:r>
-              <a:rPr lang="pt-BR" sz="980" b="0" dirty="0">
+              <a:rPr lang="pt-BR" sz="1300" b="0" dirty="0">
                 <a:solidFill>
                   <a:srgbClr val="1E293B"/>
                 </a:solidFill>
@@ -16055,7 +16055,7 @@
               <a:buNone/>
             </a:pPr>
             <a:r>
-              <a:rPr lang="pt-BR" sz="980" b="0" dirty="0">
+              <a:rPr lang="pt-BR" sz="1300" b="0" dirty="0">
                 <a:solidFill>
                   <a:srgbClr val="1E293B"/>
                 </a:solidFill>
@@ -16068,11 +16068,11 @@
             <a:pPr indent="0" marL="0">
               <a:buNone/>
               <a:spcBef>
-                <a:spcPts val="80"/>
+                <a:spcPts val="100"/>
               </a:spcBef>
             </a:pPr>
             <a:r>
-              <a:rPr lang="pt-BR" sz="980" b="0" dirty="0">
+              <a:rPr lang="pt-BR" sz="1300" b="0" dirty="0">
                 <a:solidFill>
                   <a:srgbClr val="1E293B"/>
                 </a:solidFill>
@@ -16086,7 +16086,7 @@
               <a:buNone/>
             </a:pPr>
             <a:r>
-              <a:rPr lang="pt-BR" sz="980" b="0" dirty="0">
+              <a:rPr lang="pt-BR" sz="1300" b="0" dirty="0">
                 <a:solidFill>
                   <a:srgbClr val="1E293B"/>
                 </a:solidFill>
@@ -16164,7 +16164,7 @@
               <a:buNone/>
             </a:pPr>
             <a:r>
-              <a:rPr lang="pt-BR" sz="880" b="1" dirty="0">
+              <a:rPr lang="pt-BR" sz="1100" b="1" dirty="0">
                 <a:solidFill>
                   <a:srgbClr val="FFFFFF"/>
                 </a:solidFill>
@@ -16200,7 +16200,7 @@
               <a:buNone/>
             </a:pPr>
             <a:r>
-              <a:rPr lang="pt-BR" sz="980" b="0" dirty="0">
+              <a:rPr lang="pt-BR" sz="1300" b="0" dirty="0">
                 <a:solidFill>
                   <a:srgbClr val="1E293B"/>
                 </a:solidFill>
@@ -16214,7 +16214,7 @@
               <a:buNone/>
             </a:pPr>
             <a:r>
-              <a:rPr lang="pt-BR" sz="980" b="0" dirty="0">
+              <a:rPr lang="pt-BR" sz="1300" b="0" dirty="0">
                 <a:solidFill>
                   <a:srgbClr val="1E293B"/>
                 </a:solidFill>
@@ -16228,7 +16228,7 @@
               <a:buNone/>
             </a:pPr>
             <a:r>
-              <a:rPr lang="pt-BR" sz="980" b="0" dirty="0">
+              <a:rPr lang="pt-BR" sz="1300" b="0" dirty="0">
                 <a:solidFill>
                   <a:srgbClr val="1E293B"/>
                 </a:solidFill>
@@ -16241,11 +16241,11 @@
             <a:pPr indent="0" marL="0">
               <a:buNone/>
               <a:spcBef>
-                <a:spcPts val="80"/>
+                <a:spcPts val="100"/>
               </a:spcBef>
             </a:pPr>
             <a:r>
-              <a:rPr lang="pt-BR" sz="980" b="0" dirty="0">
+              <a:rPr lang="pt-BR" sz="1300" b="0" dirty="0">
                 <a:solidFill>
                   <a:srgbClr val="1E293B"/>
                 </a:solidFill>
@@ -16259,7 +16259,7 @@
               <a:buNone/>
             </a:pPr>
             <a:r>
-              <a:rPr lang="pt-BR" sz="980" b="0" dirty="0">
+              <a:rPr lang="pt-BR" sz="1300" b="0" dirty="0">
                 <a:solidFill>
                   <a:srgbClr val="1E293B"/>
                 </a:solidFill>
@@ -16272,11 +16272,11 @@
             <a:pPr indent="0" marL="0">
               <a:buNone/>
               <a:spcBef>
-                <a:spcPts val="80"/>
+                <a:spcPts val="100"/>
               </a:spcBef>
             </a:pPr>
             <a:r>
-              <a:rPr lang="pt-BR" sz="980" b="0" dirty="0">
+              <a:rPr lang="pt-BR" sz="1300" b="0" dirty="0">
                 <a:solidFill>
                   <a:srgbClr val="1E293B"/>
                 </a:solidFill>
@@ -16290,7 +16290,7 @@
               <a:buNone/>
             </a:pPr>
             <a:r>
-              <a:rPr lang="pt-BR" sz="980" b="0" dirty="0">
+              <a:rPr lang="pt-BR" sz="1300" b="0" dirty="0">
                 <a:solidFill>
                   <a:srgbClr val="1E293B"/>
                 </a:solidFill>
@@ -16303,11 +16303,11 @@
             <a:pPr indent="0" marL="0">
               <a:buNone/>
               <a:spcBef>
-                <a:spcPts val="80"/>
+                <a:spcPts val="100"/>
               </a:spcBef>
             </a:pPr>
             <a:r>
-              <a:rPr lang="pt-BR" sz="980" b="0" dirty="0">
+              <a:rPr lang="pt-BR" sz="1300" b="0" dirty="0">
                 <a:solidFill>
                   <a:srgbClr val="1E293B"/>
                 </a:solidFill>
@@ -16321,7 +16321,7 @@
               <a:buNone/>
             </a:pPr>
             <a:r>
-              <a:rPr lang="pt-BR" sz="980" b="0" dirty="0">
+              <a:rPr lang="pt-BR" sz="1300" b="0" dirty="0">
                 <a:solidFill>
                   <a:srgbClr val="1E293B"/>
                 </a:solidFill>
@@ -16399,7 +16399,7 @@
               <a:buNone/>
             </a:pPr>
             <a:r>
-              <a:rPr lang="pt-BR" sz="880" b="1" dirty="0">
+              <a:rPr lang="pt-BR" sz="1100" b="1" dirty="0">
                 <a:solidFill>
                   <a:srgbClr val="FFFFFF"/>
                 </a:solidFill>
@@ -16435,7 +16435,7 @@
               <a:buNone/>
             </a:pPr>
             <a:r>
-              <a:rPr lang="pt-BR" sz="980" b="0" dirty="0">
+              <a:rPr lang="pt-BR" sz="1300" b="0" dirty="0">
                 <a:solidFill>
                   <a:srgbClr val="1E293B"/>
                 </a:solidFill>
@@ -16449,7 +16449,7 @@
               <a:buNone/>
             </a:pPr>
             <a:r>
-              <a:rPr lang="pt-BR" sz="980" b="0" dirty="0">
+              <a:rPr lang="pt-BR" sz="1300" b="0" dirty="0">
                 <a:solidFill>
                   <a:srgbClr val="1E293B"/>
                 </a:solidFill>
@@ -16463,7 +16463,7 @@
               <a:buNone/>
             </a:pPr>
             <a:r>
-              <a:rPr lang="pt-BR" sz="980" b="0" dirty="0">
+              <a:rPr lang="pt-BR" sz="1300" b="0" dirty="0">
                 <a:solidFill>
                   <a:srgbClr val="1E293B"/>
                 </a:solidFill>
@@ -16476,11 +16476,11 @@
             <a:pPr indent="0" marL="0">
               <a:buNone/>
               <a:spcBef>
-                <a:spcPts val="80"/>
+                <a:spcPts val="100"/>
               </a:spcBef>
             </a:pPr>
             <a:r>
-              <a:rPr lang="pt-BR" sz="980" b="0" dirty="0">
+              <a:rPr lang="pt-BR" sz="1300" b="0" dirty="0">
                 <a:solidFill>
                   <a:srgbClr val="1E293B"/>
                 </a:solidFill>
@@ -16494,7 +16494,7 @@
               <a:buNone/>
             </a:pPr>
             <a:r>
-              <a:rPr lang="pt-BR" sz="980" b="0" dirty="0">
+              <a:rPr lang="pt-BR" sz="1300" b="0" dirty="0">
                 <a:solidFill>
                   <a:srgbClr val="1E293B"/>
                 </a:solidFill>
@@ -16507,11 +16507,11 @@
             <a:pPr indent="0" marL="0">
               <a:buNone/>
               <a:spcBef>
-                <a:spcPts val="80"/>
+                <a:spcPts val="100"/>
               </a:spcBef>
             </a:pPr>
             <a:r>
-              <a:rPr lang="pt-BR" sz="980" b="0" dirty="0">
+              <a:rPr lang="pt-BR" sz="1300" b="0" dirty="0">
                 <a:solidFill>
                   <a:srgbClr val="1E293B"/>
                 </a:solidFill>
@@ -16525,7 +16525,7 @@
               <a:buNone/>
             </a:pPr>
             <a:r>
-              <a:rPr lang="pt-BR" sz="980" b="0" dirty="0">
+              <a:rPr lang="pt-BR" sz="1300" b="0" dirty="0">
                 <a:solidFill>
                   <a:srgbClr val="1E293B"/>
                 </a:solidFill>
@@ -16601,7 +16601,7 @@
               <a:buNone/>
             </a:pPr>
             <a:r>
-              <a:rPr lang="pt-BR" sz="800" b="1" dirty="0">
+              <a:rPr lang="pt-BR" sz="1000" b="1" dirty="0">
                 <a:solidFill>
                   <a:srgbClr val="DC2626"/>
                 </a:solidFill>
@@ -16615,7 +16615,7 @@
               <a:buNone/>
             </a:pPr>
             <a:r>
-              <a:rPr lang="pt-BR" sz="930" b="0" dirty="0">
+              <a:rPr lang="pt-BR" sz="1200" b="0" dirty="0">
                 <a:solidFill>
                   <a:srgbClr val="334155"/>
                 </a:solidFill>
@@ -16651,7 +16651,7 @@
               <a:buNone/>
             </a:pPr>
             <a:r>
-              <a:rPr lang="pt-BR" sz="800" b="1" dirty="0">
+              <a:rPr lang="pt-BR" sz="1000" b="1" dirty="0">
                 <a:solidFill>
                   <a:srgbClr val="DC2626"/>
                 </a:solidFill>
@@ -16665,7 +16665,7 @@
               <a:buNone/>
             </a:pPr>
             <a:r>
-              <a:rPr lang="pt-BR" sz="930" b="0" dirty="0">
+              <a:rPr lang="pt-BR" sz="1200" b="0" dirty="0">
                 <a:solidFill>
                   <a:srgbClr val="334155"/>
                 </a:solidFill>
@@ -16861,7 +16861,7 @@
               <a:buNone/>
             </a:pPr>
             <a:r>
-              <a:rPr lang="pt-BR" sz="900" b="1" dirty="0">
+              <a:rPr lang="pt-BR" sz="1100" b="1" dirty="0">
                 <a:solidFill>
                   <a:srgbClr val="FFFFFF"/>
                 </a:solidFill>
@@ -16897,7 +16897,7 @@
               <a:buNone/>
             </a:pPr>
             <a:r>
-              <a:rPr lang="pt-BR" sz="780" b="0" i="1" dirty="0">
+              <a:rPr lang="pt-BR" sz="950" b="0" i="1" dirty="0">
                 <a:solidFill>
                   <a:srgbClr val="FFFFFF"/>
                 </a:solidFill>
@@ -16953,7 +16953,7 @@
               <a:buNone/>
             </a:pPr>
             <a:r>
-              <a:rPr lang="pt-BR" sz="1150" b="0" i="1" dirty="0">
+              <a:rPr lang="pt-BR" sz="1400" b="0" i="1" dirty="0">
                 <a:solidFill>
                   <a:srgbClr val="2563EB"/>
                 </a:solidFill>
@@ -17031,7 +17031,7 @@
               <a:buNone/>
             </a:pPr>
             <a:r>
-              <a:rPr lang="pt-BR" sz="880" b="1" dirty="0">
+              <a:rPr lang="pt-BR" sz="1100" b="1" dirty="0">
                 <a:solidFill>
                   <a:srgbClr val="FFFFFF"/>
                 </a:solidFill>
@@ -17067,7 +17067,7 @@
               <a:buNone/>
             </a:pPr>
             <a:r>
-              <a:rPr lang="pt-BR" sz="980" b="0" dirty="0">
+              <a:rPr lang="pt-BR" sz="1300" b="0" dirty="0">
                 <a:solidFill>
                   <a:srgbClr val="1E293B"/>
                 </a:solidFill>
@@ -17080,11 +17080,11 @@
             <a:pPr indent="0" marL="0">
               <a:buNone/>
               <a:spcBef>
-                <a:spcPts val="80"/>
+                <a:spcPts val="100"/>
               </a:spcBef>
             </a:pPr>
             <a:r>
-              <a:rPr lang="pt-BR" sz="980" b="0" dirty="0">
+              <a:rPr lang="pt-BR" sz="1300" b="0" dirty="0">
                 <a:solidFill>
                   <a:srgbClr val="1E293B"/>
                 </a:solidFill>
@@ -17097,11 +17097,11 @@
             <a:pPr indent="0" marL="0">
               <a:buNone/>
               <a:spcBef>
-                <a:spcPts val="80"/>
+                <a:spcPts val="100"/>
               </a:spcBef>
             </a:pPr>
             <a:r>
-              <a:rPr lang="pt-BR" sz="980" b="0" dirty="0">
+              <a:rPr lang="pt-BR" sz="1300" b="0" dirty="0">
                 <a:solidFill>
                   <a:srgbClr val="1E293B"/>
                 </a:solidFill>
@@ -17114,11 +17114,11 @@
             <a:pPr indent="0" marL="0">
               <a:buNone/>
               <a:spcBef>
-                <a:spcPts val="80"/>
+                <a:spcPts val="100"/>
               </a:spcBef>
             </a:pPr>
             <a:r>
-              <a:rPr lang="pt-BR" sz="980" b="0" dirty="0">
+              <a:rPr lang="pt-BR" sz="1300" b="0" dirty="0">
                 <a:solidFill>
                   <a:srgbClr val="1E293B"/>
                 </a:solidFill>
@@ -17132,7 +17132,7 @@
               <a:buNone/>
             </a:pPr>
             <a:r>
-              <a:rPr lang="pt-BR" sz="980" b="0" dirty="0">
+              <a:rPr lang="pt-BR" sz="1300" b="0" dirty="0">
                 <a:solidFill>
                   <a:srgbClr val="1E293B"/>
                 </a:solidFill>
@@ -17146,7 +17146,7 @@
               <a:buNone/>
             </a:pPr>
             <a:r>
-              <a:rPr lang="pt-BR" sz="980" b="0" dirty="0">
+              <a:rPr lang="pt-BR" sz="1300" b="0" dirty="0">
                 <a:solidFill>
                   <a:srgbClr val="1E293B"/>
                 </a:solidFill>
@@ -17159,11 +17159,11 @@
             <a:pPr indent="0" marL="0">
               <a:buNone/>
               <a:spcBef>
-                <a:spcPts val="80"/>
+                <a:spcPts val="100"/>
               </a:spcBef>
             </a:pPr>
             <a:r>
-              <a:rPr lang="pt-BR" sz="980" b="0" dirty="0">
+              <a:rPr lang="pt-BR" sz="1300" b="0" dirty="0">
                 <a:solidFill>
                   <a:srgbClr val="1E293B"/>
                 </a:solidFill>
@@ -17241,7 +17241,7 @@
               <a:buNone/>
             </a:pPr>
             <a:r>
-              <a:rPr lang="pt-BR" sz="880" b="1" dirty="0">
+              <a:rPr lang="pt-BR" sz="1100" b="1" dirty="0">
                 <a:solidFill>
                   <a:srgbClr val="FFFFFF"/>
                 </a:solidFill>
@@ -17277,7 +17277,7 @@
               <a:buNone/>
             </a:pPr>
             <a:r>
-              <a:rPr lang="pt-BR" sz="980" b="0" dirty="0">
+              <a:rPr lang="pt-BR" sz="1300" b="0" dirty="0">
                 <a:solidFill>
                   <a:srgbClr val="1E293B"/>
                 </a:solidFill>
@@ -17291,7 +17291,7 @@
               <a:buNone/>
             </a:pPr>
             <a:r>
-              <a:rPr lang="pt-BR" sz="980" b="0" dirty="0">
+              <a:rPr lang="pt-BR" sz="1300" b="0" dirty="0">
                 <a:solidFill>
                   <a:srgbClr val="1E293B"/>
                 </a:solidFill>
@@ -17305,7 +17305,7 @@
               <a:buNone/>
             </a:pPr>
             <a:r>
-              <a:rPr lang="pt-BR" sz="980" b="0" dirty="0">
+              <a:rPr lang="pt-BR" sz="1300" b="0" dirty="0">
                 <a:solidFill>
                   <a:srgbClr val="1E293B"/>
                 </a:solidFill>
@@ -17319,7 +17319,7 @@
               <a:buNone/>
             </a:pPr>
             <a:r>
-              <a:rPr lang="pt-BR" sz="980" b="0" dirty="0">
+              <a:rPr lang="pt-BR" sz="1300" b="0" dirty="0">
                 <a:solidFill>
                   <a:srgbClr val="1E293B"/>
                 </a:solidFill>
@@ -17332,11 +17332,11 @@
             <a:pPr indent="0" marL="0">
               <a:buNone/>
               <a:spcBef>
-                <a:spcPts val="80"/>
+                <a:spcPts val="100"/>
               </a:spcBef>
             </a:pPr>
             <a:r>
-              <a:rPr lang="pt-BR" sz="980" b="0" dirty="0">
+              <a:rPr lang="pt-BR" sz="1300" b="0" dirty="0">
                 <a:solidFill>
                   <a:srgbClr val="1E293B"/>
                 </a:solidFill>
@@ -17350,7 +17350,7 @@
               <a:buNone/>
             </a:pPr>
             <a:r>
-              <a:rPr lang="pt-BR" sz="980" b="0" dirty="0">
+              <a:rPr lang="pt-BR" sz="1300" b="0" dirty="0">
                 <a:solidFill>
                   <a:srgbClr val="1E293B"/>
                 </a:solidFill>
@@ -17363,11 +17363,11 @@
             <a:pPr indent="0" marL="0">
               <a:buNone/>
               <a:spcBef>
-                <a:spcPts val="80"/>
+                <a:spcPts val="100"/>
               </a:spcBef>
             </a:pPr>
             <a:r>
-              <a:rPr lang="pt-BR" sz="980" b="0" dirty="0">
+              <a:rPr lang="pt-BR" sz="1300" b="0" dirty="0">
                 <a:solidFill>
                   <a:srgbClr val="1E293B"/>
                 </a:solidFill>
@@ -17381,7 +17381,7 @@
               <a:buNone/>
             </a:pPr>
             <a:r>
-              <a:rPr lang="pt-BR" sz="980" b="0" dirty="0">
+              <a:rPr lang="pt-BR" sz="1300" b="0" dirty="0">
                 <a:solidFill>
                   <a:srgbClr val="1E293B"/>
                 </a:solidFill>
@@ -17395,7 +17395,7 @@
               <a:buNone/>
             </a:pPr>
             <a:r>
-              <a:rPr lang="pt-BR" sz="980" b="0" dirty="0">
+              <a:rPr lang="pt-BR" sz="1300" b="0" dirty="0">
                 <a:solidFill>
                   <a:srgbClr val="1E293B"/>
                 </a:solidFill>
@@ -17408,11 +17408,11 @@
             <a:pPr indent="0" marL="0">
               <a:buNone/>
               <a:spcBef>
-                <a:spcPts val="80"/>
+                <a:spcPts val="100"/>
               </a:spcBef>
             </a:pPr>
             <a:r>
-              <a:rPr lang="pt-BR" sz="980" b="0" dirty="0">
+              <a:rPr lang="pt-BR" sz="1300" b="0" dirty="0">
                 <a:solidFill>
                   <a:srgbClr val="1E293B"/>
                 </a:solidFill>
@@ -17426,7 +17426,7 @@
               <a:buNone/>
             </a:pPr>
             <a:r>
-              <a:rPr lang="pt-BR" sz="980" b="0" dirty="0">
+              <a:rPr lang="pt-BR" sz="1300" b="0" dirty="0">
                 <a:solidFill>
                   <a:srgbClr val="1E293B"/>
                 </a:solidFill>
@@ -17440,7 +17440,7 @@
               <a:buNone/>
             </a:pPr>
             <a:r>
-              <a:rPr lang="pt-BR" sz="980" b="0" dirty="0">
+              <a:rPr lang="pt-BR" sz="1300" b="0" dirty="0">
                 <a:solidFill>
                   <a:srgbClr val="1E293B"/>
                 </a:solidFill>
@@ -17518,7 +17518,7 @@
               <a:buNone/>
             </a:pPr>
             <a:r>
-              <a:rPr lang="pt-BR" sz="880" b="1" dirty="0">
+              <a:rPr lang="pt-BR" sz="1100" b="1" dirty="0">
                 <a:solidFill>
                   <a:srgbClr val="FFFFFF"/>
                 </a:solidFill>
@@ -17554,7 +17554,7 @@
               <a:buNone/>
             </a:pPr>
             <a:r>
-              <a:rPr lang="pt-BR" sz="980" b="0" dirty="0">
+              <a:rPr lang="pt-BR" sz="1300" b="0" dirty="0">
                 <a:solidFill>
                   <a:srgbClr val="1E293B"/>
                 </a:solidFill>
@@ -17568,7 +17568,7 @@
               <a:buNone/>
             </a:pPr>
             <a:r>
-              <a:rPr lang="pt-BR" sz="980" b="0" dirty="0">
+              <a:rPr lang="pt-BR" sz="1300" b="0" dirty="0">
                 <a:solidFill>
                   <a:srgbClr val="1E293B"/>
                 </a:solidFill>
@@ -17581,11 +17581,11 @@
             <a:pPr indent="0" marL="0">
               <a:buNone/>
               <a:spcBef>
-                <a:spcPts val="80"/>
+                <a:spcPts val="100"/>
               </a:spcBef>
             </a:pPr>
             <a:r>
-              <a:rPr lang="pt-BR" sz="980" b="0" dirty="0">
+              <a:rPr lang="pt-BR" sz="1300" b="0" dirty="0">
                 <a:solidFill>
                   <a:srgbClr val="1E293B"/>
                 </a:solidFill>
@@ -17599,7 +17599,7 @@
               <a:buNone/>
             </a:pPr>
             <a:r>
-              <a:rPr lang="pt-BR" sz="980" b="0" dirty="0">
+              <a:rPr lang="pt-BR" sz="1300" b="0" dirty="0">
                 <a:solidFill>
                   <a:srgbClr val="1E293B"/>
                 </a:solidFill>
@@ -17612,11 +17612,11 @@
             <a:pPr indent="0" marL="0">
               <a:buNone/>
               <a:spcBef>
-                <a:spcPts val="80"/>
+                <a:spcPts val="100"/>
               </a:spcBef>
             </a:pPr>
             <a:r>
-              <a:rPr lang="pt-BR" sz="980" b="0" dirty="0">
+              <a:rPr lang="pt-BR" sz="1300" b="0" dirty="0">
                 <a:solidFill>
                   <a:srgbClr val="1E293B"/>
                 </a:solidFill>
@@ -17630,7 +17630,7 @@
               <a:buNone/>
             </a:pPr>
             <a:r>
-              <a:rPr lang="pt-BR" sz="980" b="0" dirty="0">
+              <a:rPr lang="pt-BR" sz="1300" b="0" dirty="0">
                 <a:solidFill>
                   <a:srgbClr val="1E293B"/>
                 </a:solidFill>
@@ -17643,11 +17643,11 @@
             <a:pPr indent="0" marL="0">
               <a:buNone/>
               <a:spcBef>
-                <a:spcPts val="80"/>
+                <a:spcPts val="100"/>
               </a:spcBef>
             </a:pPr>
             <a:r>
-              <a:rPr lang="pt-BR" sz="980" b="0" dirty="0">
+              <a:rPr lang="pt-BR" sz="1300" b="0" dirty="0">
                 <a:solidFill>
                   <a:srgbClr val="1E293B"/>
                 </a:solidFill>
@@ -17661,7 +17661,7 @@
               <a:buNone/>
             </a:pPr>
             <a:r>
-              <a:rPr lang="pt-BR" sz="980" b="0" dirty="0">
+              <a:rPr lang="pt-BR" sz="1300" b="0" dirty="0">
                 <a:solidFill>
                   <a:srgbClr val="1E293B"/>
                 </a:solidFill>
@@ -17737,7 +17737,7 @@
               <a:buNone/>
             </a:pPr>
             <a:r>
-              <a:rPr lang="pt-BR" sz="800" b="1" dirty="0">
+              <a:rPr lang="pt-BR" sz="1000" b="1" dirty="0">
                 <a:solidFill>
                   <a:srgbClr val="2563EB"/>
                 </a:solidFill>
@@ -17751,7 +17751,7 @@
               <a:buNone/>
             </a:pPr>
             <a:r>
-              <a:rPr lang="pt-BR" sz="930" b="0" dirty="0">
+              <a:rPr lang="pt-BR" sz="1200" b="0" dirty="0">
                 <a:solidFill>
                   <a:srgbClr val="334155"/>
                 </a:solidFill>
@@ -17787,7 +17787,7 @@
               <a:buNone/>
             </a:pPr>
             <a:r>
-              <a:rPr lang="pt-BR" sz="800" b="1" dirty="0">
+              <a:rPr lang="pt-BR" sz="1000" b="1" dirty="0">
                 <a:solidFill>
                   <a:srgbClr val="2563EB"/>
                 </a:solidFill>
@@ -17801,7 +17801,7 @@
               <a:buNone/>
             </a:pPr>
             <a:r>
-              <a:rPr lang="pt-BR" sz="930" b="0" dirty="0">
+              <a:rPr lang="pt-BR" sz="1200" b="0" dirty="0">
                 <a:solidFill>
                   <a:srgbClr val="334155"/>
                 </a:solidFill>
@@ -17997,7 +17997,7 @@
               <a:buNone/>
             </a:pPr>
             <a:r>
-              <a:rPr lang="pt-BR" sz="900" b="1" dirty="0">
+              <a:rPr lang="pt-BR" sz="1100" b="1" dirty="0">
                 <a:solidFill>
                   <a:srgbClr val="FFFFFF"/>
                 </a:solidFill>
@@ -18033,7 +18033,7 @@
               <a:buNone/>
             </a:pPr>
             <a:r>
-              <a:rPr lang="pt-BR" sz="780" b="0" i="1" dirty="0">
+              <a:rPr lang="pt-BR" sz="950" b="0" i="1" dirty="0">
                 <a:solidFill>
                   <a:srgbClr val="FFFFFF"/>
                 </a:solidFill>
@@ -18089,7 +18089,7 @@
               <a:buNone/>
             </a:pPr>
             <a:r>
-              <a:rPr lang="pt-BR" sz="1150" b="0" i="1" dirty="0">
+              <a:rPr lang="pt-BR" sz="1400" b="0" i="1" dirty="0">
                 <a:solidFill>
                   <a:srgbClr val="0D9488"/>
                 </a:solidFill>
@@ -18167,7 +18167,7 @@
               <a:buNone/>
             </a:pPr>
             <a:r>
-              <a:rPr lang="pt-BR" sz="880" b="1" dirty="0">
+              <a:rPr lang="pt-BR" sz="1100" b="1" dirty="0">
                 <a:solidFill>
                   <a:srgbClr val="FFFFFF"/>
                 </a:solidFill>
@@ -18203,7 +18203,7 @@
               <a:buNone/>
             </a:pPr>
             <a:r>
-              <a:rPr lang="pt-BR" sz="980" b="0" dirty="0">
+              <a:rPr lang="pt-BR" sz="1300" b="0" dirty="0">
                 <a:solidFill>
                   <a:srgbClr val="1E293B"/>
                 </a:solidFill>
@@ -18217,7 +18217,7 @@
               <a:buNone/>
             </a:pPr>
             <a:r>
-              <a:rPr lang="pt-BR" sz="980" b="0" dirty="0">
+              <a:rPr lang="pt-BR" sz="1300" b="0" dirty="0">
                 <a:solidFill>
                   <a:srgbClr val="1E293B"/>
                 </a:solidFill>
@@ -18231,7 +18231,7 @@
               <a:buNone/>
             </a:pPr>
             <a:r>
-              <a:rPr lang="pt-BR" sz="980" b="0" dirty="0">
+              <a:rPr lang="pt-BR" sz="1300" b="0" dirty="0">
                 <a:solidFill>
                   <a:srgbClr val="1E293B"/>
                 </a:solidFill>
@@ -18244,11 +18244,11 @@
             <a:pPr indent="0" marL="0">
               <a:buNone/>
               <a:spcBef>
-                <a:spcPts val="80"/>
+                <a:spcPts val="100"/>
               </a:spcBef>
             </a:pPr>
             <a:r>
-              <a:rPr lang="pt-BR" sz="980" b="0" dirty="0">
+              <a:rPr lang="pt-BR" sz="1300" b="0" dirty="0">
                 <a:solidFill>
                   <a:srgbClr val="1E293B"/>
                 </a:solidFill>
@@ -18262,7 +18262,7 @@
               <a:buNone/>
             </a:pPr>
             <a:r>
-              <a:rPr lang="pt-BR" sz="980" b="0" dirty="0">
+              <a:rPr lang="pt-BR" sz="1300" b="0" dirty="0">
                 <a:solidFill>
                   <a:srgbClr val="1E293B"/>
                 </a:solidFill>
@@ -18276,7 +18276,7 @@
               <a:buNone/>
             </a:pPr>
             <a:r>
-              <a:rPr lang="pt-BR" sz="980" b="0" dirty="0">
+              <a:rPr lang="pt-BR" sz="1300" b="0" dirty="0">
                 <a:solidFill>
                   <a:srgbClr val="1E293B"/>
                 </a:solidFill>
@@ -18289,11 +18289,11 @@
             <a:pPr indent="0" marL="0">
               <a:buNone/>
               <a:spcBef>
-                <a:spcPts val="80"/>
+                <a:spcPts val="100"/>
               </a:spcBef>
             </a:pPr>
             <a:r>
-              <a:rPr lang="pt-BR" sz="980" b="0" dirty="0">
+              <a:rPr lang="pt-BR" sz="1300" b="0" dirty="0">
                 <a:solidFill>
                   <a:srgbClr val="1E293B"/>
                 </a:solidFill>
@@ -18307,7 +18307,7 @@
               <a:buNone/>
             </a:pPr>
             <a:r>
-              <a:rPr lang="pt-BR" sz="980" b="0" dirty="0">
+              <a:rPr lang="pt-BR" sz="1300" b="0" dirty="0">
                 <a:solidFill>
                   <a:srgbClr val="1E293B"/>
                 </a:solidFill>
@@ -18385,7 +18385,7 @@
               <a:buNone/>
             </a:pPr>
             <a:r>
-              <a:rPr lang="pt-BR" sz="880" b="1" dirty="0">
+              <a:rPr lang="pt-BR" sz="1100" b="1" dirty="0">
                 <a:solidFill>
                   <a:srgbClr val="FFFFFF"/>
                 </a:solidFill>
@@ -18421,7 +18421,7 @@
               <a:buNone/>
             </a:pPr>
             <a:r>
-              <a:rPr lang="pt-BR" sz="980" b="0" dirty="0">
+              <a:rPr lang="pt-BR" sz="1300" b="0" dirty="0">
                 <a:solidFill>
                   <a:srgbClr val="1E293B"/>
                 </a:solidFill>
@@ -18435,7 +18435,7 @@
               <a:buNone/>
             </a:pPr>
             <a:r>
-              <a:rPr lang="pt-BR" sz="980" b="0" dirty="0">
+              <a:rPr lang="pt-BR" sz="1300" b="0" dirty="0">
                 <a:solidFill>
                   <a:srgbClr val="1E293B"/>
                 </a:solidFill>
@@ -18449,7 +18449,7 @@
               <a:buNone/>
             </a:pPr>
             <a:r>
-              <a:rPr lang="pt-BR" sz="980" b="0" dirty="0">
+              <a:rPr lang="pt-BR" sz="1300" b="0" dirty="0">
                 <a:solidFill>
                   <a:srgbClr val="1E293B"/>
                 </a:solidFill>
@@ -18462,11 +18462,11 @@
             <a:pPr indent="0" marL="0">
               <a:buNone/>
               <a:spcBef>
-                <a:spcPts val="80"/>
+                <a:spcPts val="100"/>
               </a:spcBef>
             </a:pPr>
             <a:r>
-              <a:rPr lang="pt-BR" sz="980" b="0" dirty="0">
+              <a:rPr lang="pt-BR" sz="1300" b="0" dirty="0">
                 <a:solidFill>
                   <a:srgbClr val="1E293B"/>
                 </a:solidFill>
@@ -18480,7 +18480,7 @@
               <a:buNone/>
             </a:pPr>
             <a:r>
-              <a:rPr lang="pt-BR" sz="980" b="0" dirty="0">
+              <a:rPr lang="pt-BR" sz="1300" b="0" dirty="0">
                 <a:solidFill>
                   <a:srgbClr val="1E293B"/>
                 </a:solidFill>
@@ -18493,11 +18493,11 @@
             <a:pPr indent="0" marL="0">
               <a:buNone/>
               <a:spcBef>
-                <a:spcPts val="80"/>
+                <a:spcPts val="100"/>
               </a:spcBef>
             </a:pPr>
             <a:r>
-              <a:rPr lang="pt-BR" sz="980" b="0" dirty="0">
+              <a:rPr lang="pt-BR" sz="1300" b="0" dirty="0">
                 <a:solidFill>
                   <a:srgbClr val="1E293B"/>
                 </a:solidFill>
@@ -18511,7 +18511,7 @@
               <a:buNone/>
             </a:pPr>
             <a:r>
-              <a:rPr lang="pt-BR" sz="980" b="0" dirty="0">
+              <a:rPr lang="pt-BR" sz="1300" b="0" dirty="0">
                 <a:solidFill>
                   <a:srgbClr val="1E293B"/>
                 </a:solidFill>
@@ -18524,11 +18524,11 @@
             <a:pPr indent="0" marL="0">
               <a:buNone/>
               <a:spcBef>
-                <a:spcPts val="80"/>
+                <a:spcPts val="100"/>
               </a:spcBef>
             </a:pPr>
             <a:r>
-              <a:rPr lang="pt-BR" sz="980" b="0" dirty="0">
+              <a:rPr lang="pt-BR" sz="1300" b="0" dirty="0">
                 <a:solidFill>
                   <a:srgbClr val="1E293B"/>
                 </a:solidFill>
@@ -18542,7 +18542,7 @@
               <a:buNone/>
             </a:pPr>
             <a:r>
-              <a:rPr lang="pt-BR" sz="980" b="0" dirty="0">
+              <a:rPr lang="pt-BR" sz="1300" b="0" dirty="0">
                 <a:solidFill>
                   <a:srgbClr val="1E293B"/>
                 </a:solidFill>
@@ -18556,7 +18556,7 @@
               <a:buNone/>
             </a:pPr>
             <a:r>
-              <a:rPr lang="pt-BR" sz="980" b="0" dirty="0">
+              <a:rPr lang="pt-BR" sz="1300" b="0" dirty="0">
                 <a:solidFill>
                   <a:srgbClr val="1E293B"/>
                 </a:solidFill>
@@ -18634,7 +18634,7 @@
               <a:buNone/>
             </a:pPr>
             <a:r>
-              <a:rPr lang="pt-BR" sz="880" b="1" dirty="0">
+              <a:rPr lang="pt-BR" sz="1100" b="1" dirty="0">
                 <a:solidFill>
                   <a:srgbClr val="FFFFFF"/>
                 </a:solidFill>
@@ -18670,7 +18670,7 @@
               <a:buNone/>
             </a:pPr>
             <a:r>
-              <a:rPr lang="pt-BR" sz="980" b="0" dirty="0">
+              <a:rPr lang="pt-BR" sz="1300" b="0" dirty="0">
                 <a:solidFill>
                   <a:srgbClr val="1E293B"/>
                 </a:solidFill>
@@ -18684,7 +18684,7 @@
               <a:buNone/>
             </a:pPr>
             <a:r>
-              <a:rPr lang="pt-BR" sz="980" b="0" dirty="0">
+              <a:rPr lang="pt-BR" sz="1300" b="0" dirty="0">
                 <a:solidFill>
                   <a:srgbClr val="1E293B"/>
                 </a:solidFill>
@@ -18698,7 +18698,7 @@
               <a:buNone/>
             </a:pPr>
             <a:r>
-              <a:rPr lang="pt-BR" sz="980" b="0" dirty="0">
+              <a:rPr lang="pt-BR" sz="1300" b="0" dirty="0">
                 <a:solidFill>
                   <a:srgbClr val="1E293B"/>
                 </a:solidFill>
@@ -18712,7 +18712,7 @@
               <a:buNone/>
             </a:pPr>
             <a:r>
-              <a:rPr lang="pt-BR" sz="980" b="0" dirty="0">
+              <a:rPr lang="pt-BR" sz="1300" b="0" dirty="0">
                 <a:solidFill>
                   <a:srgbClr val="1E293B"/>
                 </a:solidFill>
@@ -18725,11 +18725,11 @@
             <a:pPr indent="0" marL="0">
               <a:buNone/>
               <a:spcBef>
-                <a:spcPts val="80"/>
+                <a:spcPts val="100"/>
               </a:spcBef>
             </a:pPr>
             <a:r>
-              <a:rPr lang="pt-BR" sz="980" b="0" dirty="0">
+              <a:rPr lang="pt-BR" sz="1300" b="0" dirty="0">
                 <a:solidFill>
                   <a:srgbClr val="1E293B"/>
                 </a:solidFill>
@@ -18743,7 +18743,7 @@
               <a:buNone/>
             </a:pPr>
             <a:r>
-              <a:rPr lang="pt-BR" sz="980" b="0" dirty="0">
+              <a:rPr lang="pt-BR" sz="1300" b="0" dirty="0">
                 <a:solidFill>
                   <a:srgbClr val="1E293B"/>
                 </a:solidFill>
@@ -18757,7 +18757,7 @@
               <a:buNone/>
             </a:pPr>
             <a:r>
-              <a:rPr lang="pt-BR" sz="980" b="0" dirty="0">
+              <a:rPr lang="pt-BR" sz="1300" b="0" dirty="0">
                 <a:solidFill>
                   <a:srgbClr val="1E293B"/>
                 </a:solidFill>
@@ -18771,7 +18771,7 @@
               <a:buNone/>
             </a:pPr>
             <a:r>
-              <a:rPr lang="pt-BR" sz="980" b="0" dirty="0">
+              <a:rPr lang="pt-BR" sz="1300" b="0" dirty="0">
                 <a:solidFill>
                   <a:srgbClr val="1E293B"/>
                 </a:solidFill>
@@ -18847,7 +18847,7 @@
               <a:buNone/>
             </a:pPr>
             <a:r>
-              <a:rPr lang="pt-BR" sz="800" b="1" dirty="0">
+              <a:rPr lang="pt-BR" sz="1000" b="1" dirty="0">
                 <a:solidFill>
                   <a:srgbClr val="0D9488"/>
                 </a:solidFill>
@@ -18861,7 +18861,7 @@
               <a:buNone/>
             </a:pPr>
             <a:r>
-              <a:rPr lang="pt-BR" sz="930" b="0" dirty="0">
+              <a:rPr lang="pt-BR" sz="1200" b="0" dirty="0">
                 <a:solidFill>
                   <a:srgbClr val="334155"/>
                 </a:solidFill>
@@ -18897,7 +18897,7 @@
               <a:buNone/>
             </a:pPr>
             <a:r>
-              <a:rPr lang="pt-BR" sz="800" b="1" dirty="0">
+              <a:rPr lang="pt-BR" sz="1000" b="1" dirty="0">
                 <a:solidFill>
                   <a:srgbClr val="0D9488"/>
                 </a:solidFill>
@@ -18911,7 +18911,7 @@
               <a:buNone/>
             </a:pPr>
             <a:r>
-              <a:rPr lang="pt-BR" sz="930" b="0" dirty="0">
+              <a:rPr lang="pt-BR" sz="1200" b="0" dirty="0">
                 <a:solidFill>
                   <a:srgbClr val="334155"/>
                 </a:solidFill>

</xml_diff>